<commit_message>
Broaden pitch to US + European mandate; add Knut Nyman role
Transatlantic scope (Europe 50-60% incl. Nordics, US 40-50%), two-regime
engagement playbook, refreshed US/EU pipeline, and a founding Principal
role for Knut Nyman covering US situations and campaign strategy.

https://claude.ai/code/session_014wJkiGJDWLqynffcMLAwBq
</commit_message>
<xml_diff>
--- a/nordic-capital-activism-pitch/Nordic_Capital_Engaged_Equities_Deck.pptx
+++ b/nordic-capital-activism-pitch/Nordic_Capital_Engaged_Equities_Deck.pptx
@@ -3311,7 +3311,7 @@
                 </a:solidFill>
                 <a:latin typeface="Georgia"/>
               </a:rPr>
-              <a:t>A constructive activism strategy for the Nordic public markets</a:t>
+              <a:t>A constructive activism strategy for US and European public markets</a:t>
             </a:r>
           </a:p>
         </p:txBody>
@@ -3660,7 +3660,7 @@
         <p:spPr>
           <a:xfrm>
             <a:off x="502920" y="1188720"/>
-            <a:ext cx="11247120" cy="1627632"/>
+            <a:ext cx="11247120" cy="1371600"/>
           </a:xfrm>
           <a:prstGeom prst="rect">
             <a:avLst/>
@@ -3704,7 +3704,7 @@
         <p:spPr>
           <a:xfrm>
             <a:off x="502920" y="1188720"/>
-            <a:ext cx="50800" cy="1627632"/>
+            <a:ext cx="50800" cy="1371600"/>
           </a:xfrm>
           <a:prstGeom prst="rect">
             <a:avLst/>
@@ -3747,8 +3747,8 @@
         </p:nvSpPr>
         <p:spPr>
           <a:xfrm>
-            <a:off x="731520" y="1261872"/>
-            <a:ext cx="4754880" cy="320040"/>
+            <a:off x="731520" y="1243584"/>
+            <a:ext cx="5120640" cy="292608"/>
           </a:xfrm>
           <a:prstGeom prst="rect">
             <a:avLst/>
@@ -3770,13 +3770,13 @@
               </a:spcAft>
             </a:pPr>
             <a:r>
-              <a:rPr sz="1350" b="1" i="0">
+              <a:rPr sz="1300" b="1" i="0">
                 <a:solidFill>
                   <a:srgbClr val="0B2545"/>
                 </a:solidFill>
                 <a:latin typeface="Georgia"/>
               </a:rPr>
-              <a:t>Tieto  ·  FI  ·  Software &amp; IT Services</a:t>
+              <a:t>Baxter International  ·  US  ·  MedTech</a:t>
             </a:r>
           </a:p>
         </p:txBody>
@@ -3789,8 +3789,8 @@
         </p:nvSpPr>
         <p:spPr>
           <a:xfrm>
-            <a:off x="7863840" y="1261872"/>
-            <a:ext cx="3749039" cy="320040"/>
+            <a:off x="7863840" y="1243584"/>
+            <a:ext cx="3749039" cy="292608"/>
           </a:xfrm>
           <a:prstGeom prst="rect">
             <a:avLst/>
@@ -3812,13 +3812,13 @@
               </a:spcAft>
             </a:pPr>
             <a:r>
-              <a:rPr sz="1100" b="1" i="0">
+              <a:rPr sz="1050" b="1" i="0">
                 <a:solidFill>
                   <a:srgbClr val="C49A3B"/>
                 </a:solidFill>
                 <a:latin typeface="Georgia"/>
               </a:rPr>
-              <a:t>Completing the break-up</a:t>
+              <a:t>Completing the simplification</a:t>
             </a:r>
           </a:p>
         </p:txBody>
@@ -3831,8 +3831,8 @@
         </p:nvSpPr>
         <p:spPr>
           <a:xfrm>
-            <a:off x="731520" y="1600200"/>
-            <a:ext cx="6035040" cy="1188720"/>
+            <a:off x="731520" y="1554480"/>
+            <a:ext cx="6035040" cy="960120"/>
           </a:xfrm>
           <a:prstGeom prst="rect">
             <a:avLst/>
@@ -3847,20 +3847,20 @@
           <a:p>
             <a:pPr algn="l">
               <a:lnSpc>
-                <a:spcPct val="106000"/>
-              </a:lnSpc>
-              <a:spcAft>
-                <a:spcPts val="400"/>
-              </a:spcAft>
-            </a:pPr>
-            <a:r>
-              <a:rPr sz="1050" b="0" i="0">
+                <a:spcPct val="103000"/>
+              </a:lnSpc>
+              <a:spcAft>
+                <a:spcPts val="400"/>
+              </a:spcAft>
+            </a:pPr>
+            <a:r>
+              <a:rPr sz="980" b="0" i="0">
                 <a:solidFill>
                   <a:srgbClr val="555F6E"/>
                 </a:solidFill>
                 <a:latin typeface="Georgia"/>
               </a:rPr>
-              <a:t>Situation: Tietoevry has validated the separation path: Banking demerger toward a Helsinki listing announced; Tech Services sold to Agilitas for EUR 300m (closed Sep 2025) with proceeds to debt.</a:t>
+              <a:t>Situation: Multi-year simplification in motion (BioPharma Solutions sold; Vantive kidney-care divested to Carlyle, early 2025), yet the equity kept de-rating amid execution stumbles and a CEO transition — a fallen angel far below peer multiples.</a:t>
             </a:r>
           </a:p>
         </p:txBody>
@@ -3873,8 +3873,8 @@
         </p:nvSpPr>
         <p:spPr>
           <a:xfrm>
-            <a:off x="6949440" y="1600200"/>
-            <a:ext cx="4663440" cy="1188720"/>
+            <a:off x="6949440" y="1554480"/>
+            <a:ext cx="4663440" cy="960120"/>
           </a:xfrm>
           <a:prstGeom prst="rect">
             <a:avLst/>
@@ -3889,20 +3889,20 @@
           <a:p>
             <a:pPr algn="l">
               <a:lnSpc>
-                <a:spcPct val="106000"/>
-              </a:lnSpc>
-              <a:spcAft>
-                <a:spcPts val="400"/>
-              </a:spcAft>
-            </a:pPr>
-            <a:r>
-              <a:rPr sz="1050" b="0" i="0">
+                <a:spcPct val="103000"/>
+              </a:lnSpc>
+              <a:spcAft>
+                <a:spcPts val="400"/>
+              </a:spcAft>
+            </a:pPr>
+            <a:r>
+              <a:rPr sz="980" b="0" i="0">
                 <a:solidFill>
                   <a:srgbClr val="2B3340"/>
                 </a:solidFill>
                 <a:latin typeface="Georgia"/>
               </a:rPr>
-              <a:t>Value plan: Support and accelerate value realisation; enforce capital-return discipline; position the remaining Nordic software core for consolidation — as buyer or seller.</a:t>
+              <a:t>Value plan: Finish the job: complete the separation program, reset the cost base, refresh the board, disciplined capital-return framework. Classic universal-proxy-era engagement.</a:t>
             </a:r>
           </a:p>
         </p:txBody>
@@ -3915,8 +3915,8 @@
         </p:nvSpPr>
         <p:spPr>
           <a:xfrm>
-            <a:off x="502920" y="2944368"/>
-            <a:ext cx="11247120" cy="1627632"/>
+            <a:off x="502920" y="2688336"/>
+            <a:ext cx="11247120" cy="1371600"/>
           </a:xfrm>
           <a:prstGeom prst="rect">
             <a:avLst/>
@@ -3959,8 +3959,8 @@
         </p:nvSpPr>
         <p:spPr>
           <a:xfrm>
-            <a:off x="502920" y="2944368"/>
-            <a:ext cx="50800" cy="1627632"/>
+            <a:off x="502920" y="2688336"/>
+            <a:ext cx="50800" cy="1371600"/>
           </a:xfrm>
           <a:prstGeom prst="rect">
             <a:avLst/>
@@ -4003,8 +4003,8 @@
         </p:nvSpPr>
         <p:spPr>
           <a:xfrm>
-            <a:off x="731520" y="3017520"/>
-            <a:ext cx="4754880" cy="320040"/>
+            <a:off x="731520" y="2743200"/>
+            <a:ext cx="5120640" cy="292608"/>
           </a:xfrm>
           <a:prstGeom prst="rect">
             <a:avLst/>
@@ -4026,13 +4026,13 @@
               </a:spcAft>
             </a:pPr>
             <a:r>
-              <a:rPr sz="1350" b="1" i="0">
+              <a:rPr sz="1300" b="1" i="0">
                 <a:solidFill>
                   <a:srgbClr val="0B2545"/>
                 </a:solidFill>
                 <a:latin typeface="Georgia"/>
               </a:rPr>
-              <a:t>Orkla  ·  NO  ·  Branded Consumer / Holding</a:t>
+              <a:t>Global Payments  ·  US  ·  Payments</a:t>
             </a:r>
           </a:p>
         </p:txBody>
@@ -4045,8 +4045,8 @@
         </p:nvSpPr>
         <p:spPr>
           <a:xfrm>
-            <a:off x="7863840" y="3017520"/>
-            <a:ext cx="3749039" cy="320040"/>
+            <a:off x="7863840" y="2743200"/>
+            <a:ext cx="3749039" cy="292608"/>
           </a:xfrm>
           <a:prstGeom prst="rect">
             <a:avLst/>
@@ -4068,13 +4068,13 @@
               </a:spcAft>
             </a:pPr>
             <a:r>
-              <a:rPr sz="1100" b="1" i="0">
+              <a:rPr sz="1050" b="1" i="0">
                 <a:solidFill>
                   <a:srgbClr val="C49A3B"/>
                 </a:solidFill>
                 <a:latin typeface="Georgia"/>
               </a:rPr>
-              <a:t>Conglomerate discount</a:t>
+              <a:t>Capital allocation &amp; credibility reset</a:t>
             </a:r>
           </a:p>
         </p:txBody>
@@ -4087,8 +4087,8 @@
         </p:nvSpPr>
         <p:spPr>
           <a:xfrm>
-            <a:off x="731520" y="3355848"/>
-            <a:ext cx="6035040" cy="1188720"/>
+            <a:off x="731520" y="3054096"/>
+            <a:ext cx="6035040" cy="960120"/>
           </a:xfrm>
           <a:prstGeom prst="rect">
             <a:avLst/>
@@ -4103,20 +4103,20 @@
           <a:p>
             <a:pPr algn="l">
               <a:lnSpc>
-                <a:spcPct val="106000"/>
-              </a:lnSpc>
-              <a:spcAft>
-                <a:spcPts val="400"/>
-              </a:spcAft>
-            </a:pPr>
-            <a:r>
-              <a:rPr sz="1050" b="0" i="0">
+                <a:spcPct val="103000"/>
+              </a:lnSpc>
+              <a:spcAft>
+                <a:spcPts val="400"/>
+              </a:spcAft>
+            </a:pPr>
+            <a:r>
+              <a:rPr sz="980" b="0" i="0">
                 <a:solidFill>
                   <a:srgbClr val="555F6E"/>
                 </a:solidFill>
                 <a:latin typeface="Georgia"/>
               </a:rPr>
-              <a:t>Situation: Self-declared industrial investment company with ~12 portfolio companies, a ~42.6% Jotun stake (world-class hidden asset) and hydropower; equity persistently below credible SOTP.</a:t>
+              <a:t>Situation: Scaled merchant-acquiring franchise at a deeply depressed multiple after the poorly received 2025 Worldpay / Issuer Solutions restructuring; activist interest publicly reported — the value gap is recognised.</a:t>
             </a:r>
           </a:p>
         </p:txBody>
@@ -4129,8 +4129,8 @@
         </p:nvSpPr>
         <p:spPr>
           <a:xfrm>
-            <a:off x="6949440" y="3355848"/>
-            <a:ext cx="4663440" cy="1188720"/>
+            <a:off x="6949440" y="3054096"/>
+            <a:ext cx="4663440" cy="960120"/>
           </a:xfrm>
           <a:prstGeom prst="rect">
             <a:avLst/>
@@ -4145,20 +4145,20 @@
           <a:p>
             <a:pPr algn="l">
               <a:lnSpc>
-                <a:spcPct val="106000"/>
-              </a:lnSpc>
-              <a:spcAft>
-                <a:spcPts val="400"/>
-              </a:spcAft>
-            </a:pPr>
-            <a:r>
-              <a:rPr sz="1050" b="0" i="0">
+                <a:spcPct val="103000"/>
+              </a:lnSpc>
+              <a:spcAft>
+                <a:spcPts val="400"/>
+              </a:spcAft>
+            </a:pPr>
+            <a:r>
+              <a:rPr sz="980" b="0" i="0">
                 <a:solidFill>
                   <a:srgbClr val="2B3340"/>
                 </a:solidFill>
                 <a:latin typeface="Georgia"/>
               </a:rPr>
-              <a:t>Value plan: Accelerate announced monetisations; capital-return framework tied to disposal proceeds; transparent per-asset reporting that forces the SOTP into the price.</a:t>
+              <a:t>Value plan: Integration milestones with board accountability; divest non-core; binding capital-return commitments post-deleveraging; payments operating expertise to the board (our Nets/Nexi heritage).</a:t>
             </a:r>
           </a:p>
         </p:txBody>
@@ -4171,8 +4171,264 @@
         </p:nvSpPr>
         <p:spPr>
           <a:xfrm>
-            <a:off x="502920" y="4800600"/>
-            <a:ext cx="11247120" cy="1325880"/>
+            <a:off x="502920" y="4187952"/>
+            <a:ext cx="11247120" cy="1371600"/>
+          </a:xfrm>
+          <a:prstGeom prst="rect">
+            <a:avLst/>
+          </a:prstGeom>
+          <a:solidFill>
+            <a:srgbClr val="F2F4F8"/>
+          </a:solidFill>
+          <a:ln>
+            <a:noFill/>
+          </a:ln>
+          <a:effectLst/>
+        </p:spPr>
+        <p:style>
+          <a:lnRef idx="1">
+            <a:schemeClr val="accent1"/>
+          </a:lnRef>
+          <a:fillRef idx="3">
+            <a:schemeClr val="accent1"/>
+          </a:fillRef>
+          <a:effectRef idx="2">
+            <a:schemeClr val="accent1"/>
+          </a:effectRef>
+          <a:fontRef idx="minor">
+            <a:schemeClr val="lt1"/>
+          </a:fontRef>
+        </p:style>
+        <p:txBody>
+          <a:bodyPr rtlCol="0" anchor="ctr"/>
+          <a:lstStyle/>
+          <a:p>
+            <a:pPr algn="ctr"/>
+          </a:p>
+        </p:txBody>
+      </p:sp>
+      <p:sp>
+        <p:nvSpPr>
+          <p:cNvPr id="20" name="Rectangle 19"/>
+          <p:cNvSpPr/>
+          <p:nvPr/>
+        </p:nvSpPr>
+        <p:spPr>
+          <a:xfrm>
+            <a:off x="502920" y="4187952"/>
+            <a:ext cx="50800" cy="1371600"/>
+          </a:xfrm>
+          <a:prstGeom prst="rect">
+            <a:avLst/>
+          </a:prstGeom>
+          <a:solidFill>
+            <a:srgbClr val="C49A3B"/>
+          </a:solidFill>
+          <a:ln>
+            <a:noFill/>
+          </a:ln>
+          <a:effectLst/>
+        </p:spPr>
+        <p:style>
+          <a:lnRef idx="1">
+            <a:schemeClr val="accent1"/>
+          </a:lnRef>
+          <a:fillRef idx="3">
+            <a:schemeClr val="accent1"/>
+          </a:fillRef>
+          <a:effectRef idx="2">
+            <a:schemeClr val="accent1"/>
+          </a:effectRef>
+          <a:fontRef idx="minor">
+            <a:schemeClr val="lt1"/>
+          </a:fontRef>
+        </p:style>
+        <p:txBody>
+          <a:bodyPr rtlCol="0" anchor="ctr"/>
+          <a:lstStyle/>
+          <a:p>
+            <a:pPr algn="ctr"/>
+          </a:p>
+        </p:txBody>
+      </p:sp>
+      <p:sp>
+        <p:nvSpPr>
+          <p:cNvPr id="21" name="TextBox 20"/>
+          <p:cNvSpPr txBox="1"/>
+          <p:nvPr/>
+        </p:nvSpPr>
+        <p:spPr>
+          <a:xfrm>
+            <a:off x="731520" y="4242816"/>
+            <a:ext cx="5120640" cy="292608"/>
+          </a:xfrm>
+          <a:prstGeom prst="rect">
+            <a:avLst/>
+          </a:prstGeom>
+          <a:noFill/>
+        </p:spPr>
+        <p:txBody>
+          <a:bodyPr wrap="square" anchor="t">
+            <a:spAutoFit/>
+          </a:bodyPr>
+          <a:lstStyle/>
+          <a:p>
+            <a:pPr algn="l">
+              <a:lnSpc>
+                <a:spcPct val="100000"/>
+              </a:lnSpc>
+              <a:spcAft>
+                <a:spcPts val="400"/>
+              </a:spcAft>
+            </a:pPr>
+            <a:r>
+              <a:rPr sz="1300" b="1" i="0">
+                <a:solidFill>
+                  <a:srgbClr val="0B2545"/>
+                </a:solidFill>
+                <a:latin typeface="Georgia"/>
+              </a:rPr>
+              <a:t>Zimmer Biomet  ·  US  ·  MedTech</a:t>
+            </a:r>
+          </a:p>
+        </p:txBody>
+      </p:sp>
+      <p:sp>
+        <p:nvSpPr>
+          <p:cNvPr id="22" name="TextBox 21"/>
+          <p:cNvSpPr txBox="1"/>
+          <p:nvPr/>
+        </p:nvSpPr>
+        <p:spPr>
+          <a:xfrm>
+            <a:off x="7863840" y="4242816"/>
+            <a:ext cx="3749039" cy="292608"/>
+          </a:xfrm>
+          <a:prstGeom prst="rect">
+            <a:avLst/>
+          </a:prstGeom>
+          <a:noFill/>
+        </p:spPr>
+        <p:txBody>
+          <a:bodyPr wrap="square" anchor="t">
+            <a:spAutoFit/>
+          </a:bodyPr>
+          <a:lstStyle/>
+          <a:p>
+            <a:pPr algn="r">
+              <a:lnSpc>
+                <a:spcPct val="100000"/>
+              </a:lnSpc>
+              <a:spcAft>
+                <a:spcPts val="400"/>
+              </a:spcAft>
+            </a:pPr>
+            <a:r>
+              <a:rPr sz="1050" b="1" i="0">
+                <a:solidFill>
+                  <a:srgbClr val="C49A3B"/>
+                </a:solidFill>
+                <a:latin typeface="Georgia"/>
+              </a:rPr>
+              <a:t>Capital-allocation catalyst</a:t>
+            </a:r>
+          </a:p>
+        </p:txBody>
+      </p:sp>
+      <p:sp>
+        <p:nvSpPr>
+          <p:cNvPr id="23" name="TextBox 22"/>
+          <p:cNvSpPr txBox="1"/>
+          <p:nvPr/>
+        </p:nvSpPr>
+        <p:spPr>
+          <a:xfrm>
+            <a:off x="731520" y="4553712"/>
+            <a:ext cx="6035040" cy="960120"/>
+          </a:xfrm>
+          <a:prstGeom prst="rect">
+            <a:avLst/>
+          </a:prstGeom>
+          <a:noFill/>
+        </p:spPr>
+        <p:txBody>
+          <a:bodyPr wrap="square" anchor="t">
+            <a:spAutoFit/>
+          </a:bodyPr>
+          <a:lstStyle/>
+          <a:p>
+            <a:pPr algn="l">
+              <a:lnSpc>
+                <a:spcPct val="103000"/>
+              </a:lnSpc>
+              <a:spcAft>
+                <a:spcPts val="400"/>
+              </a:spcAft>
+            </a:pPr>
+            <a:r>
+              <a:rPr sz="980" b="0" i="0">
+                <a:solidFill>
+                  <a:srgbClr val="555F6E"/>
+                </a:solidFill>
+                <a:latin typeface="Georgia"/>
+              </a:rPr>
+              <a:t>Situation: Orthopaedics leader compounding modestly at a structurally depressed multiple; investor confidence eroded by guidance resets and M&amp;A choices.</a:t>
+            </a:r>
+          </a:p>
+        </p:txBody>
+      </p:sp>
+      <p:sp>
+        <p:nvSpPr>
+          <p:cNvPr id="24" name="TextBox 23"/>
+          <p:cNvSpPr txBox="1"/>
+          <p:nvPr/>
+        </p:nvSpPr>
+        <p:spPr>
+          <a:xfrm>
+            <a:off x="6949440" y="4553712"/>
+            <a:ext cx="4663440" cy="960120"/>
+          </a:xfrm>
+          <a:prstGeom prst="rect">
+            <a:avLst/>
+          </a:prstGeom>
+          <a:noFill/>
+        </p:spPr>
+        <p:txBody>
+          <a:bodyPr wrap="square" anchor="t">
+            <a:spAutoFit/>
+          </a:bodyPr>
+          <a:lstStyle/>
+          <a:p>
+            <a:pPr algn="l">
+              <a:lnSpc>
+                <a:spcPct val="103000"/>
+              </a:lnSpc>
+              <a:spcAft>
+                <a:spcPts val="400"/>
+              </a:spcAft>
+            </a:pPr>
+            <a:r>
+              <a:rPr sz="980" b="0" i="0">
+                <a:solidFill>
+                  <a:srgbClr val="2B3340"/>
+                </a:solidFill>
+                <a:latin typeface="Georgia"/>
+              </a:rPr>
+              <a:t>Value plan: Capital-allocation framework (organic + buybacks over dilutive M&amp;A); prune subscale adjacencies; margin program toward peer levels.</a:t>
+            </a:r>
+          </a:p>
+        </p:txBody>
+      </p:sp>
+      <p:sp>
+        <p:nvSpPr>
+          <p:cNvPr id="25" name="Rectangle 24"/>
+          <p:cNvSpPr/>
+          <p:nvPr/>
+        </p:nvSpPr>
+        <p:spPr>
+          <a:xfrm>
+            <a:off x="502920" y="5715000"/>
+            <a:ext cx="11247120" cy="777240"/>
           </a:xfrm>
           <a:prstGeom prst="rect">
             <a:avLst/>
@@ -4209,14 +4465,14 @@
       </p:sp>
       <p:sp>
         <p:nvSpPr>
-          <p:cNvPr id="20" name="TextBox 19"/>
-          <p:cNvSpPr txBox="1"/>
-          <p:nvPr/>
-        </p:nvSpPr>
-        <p:spPr>
-          <a:xfrm>
-            <a:off x="777240" y="4983480"/>
-            <a:ext cx="10789920" cy="1005840"/>
+          <p:cNvPr id="26" name="TextBox 25"/>
+          <p:cNvSpPr txBox="1"/>
+          <p:nvPr/>
+        </p:nvSpPr>
+        <p:spPr>
+          <a:xfrm>
+            <a:off x="777240" y="5788152"/>
+            <a:ext cx="10789920" cy="640080"/>
           </a:xfrm>
           <a:prstGeom prst="rect">
             <a:avLst/>
@@ -4234,11 +4490,11 @@
                 <a:spcPct val="100000"/>
               </a:lnSpc>
               <a:spcAft>
-                <a:spcPts val="400"/>
-              </a:spcAft>
-            </a:pPr>
-            <a:r>
-              <a:rPr sz="1200" b="1" i="0">
+                <a:spcPts val="100"/>
+              </a:spcAft>
+            </a:pPr>
+            <a:r>
+              <a:rPr sz="1050" b="1" i="0">
                 <a:solidFill>
                   <a:srgbClr val="C49A3B"/>
                 </a:solidFill>
@@ -4250,20 +4506,20 @@
           <a:p>
             <a:pPr algn="l">
               <a:lnSpc>
-                <a:spcPct val="115000"/>
-              </a:lnSpc>
-              <a:spcAft>
-                <a:spcPts val="400"/>
-              </a:spcAft>
-            </a:pPr>
-            <a:r>
-              <a:rPr sz="1300" b="0" i="0">
+                <a:spcPct val="105000"/>
+              </a:lnSpc>
+              <a:spcAft>
+                <a:spcPts val="400"/>
+              </a:spcAft>
+            </a:pPr>
+            <a:r>
+              <a:rPr sz="1100" b="0" i="0">
                 <a:solidFill>
                   <a:srgbClr val="FFFFFF"/>
                 </a:solidFill>
                 <a:latin typeface="Georgia"/>
               </a:rPr>
-              <a:t>Securitas (self-help largely delivered — a model of the re-rating we underwrite) · Demant · Ambu · Dometic · Thule · Huhtamäki · Valmet · Storebrand · ISS</a:t>
+              <a:t>EU: Getinge · GN Store Nord · Orkla · Tieto · Demant · Securitas · ISS · Valmet · Storebrand   |   US: Teleflex · Henry Schein · Fiserv · specialty insurers</a:t>
             </a:r>
           </a:p>
         </p:txBody>
@@ -4603,7 +4859,7 @@
                           </a:solidFill>
                           <a:latin typeface="Georgia"/>
                         </a:rPr>
-                        <a:t>USD 1.5bn target; USD 2.0bn hard cap — sized to the EUR 1–10bn mid-cap band where influence is cheap and competition thin</a:t>
+                        <a:t>USD 1.5bn target; USD 2.0bn hard cap — sized to the USD 2–15bn transatlantic mid-cap band where influence is cheap and competition thin</a:t>
                       </a:r>
                     </a:p>
                   </a:txBody>
@@ -4741,7 +4997,7 @@
                           </a:solidFill>
                           <a:latin typeface="Georgia"/>
                         </a:rPr>
-                        <a:t>1.25–1.50% management; 17.5% performance over max(MSCI Nordic + 200bps, 5% absolute); 3-year crystallisation; high-water mark</a:t>
+                        <a:t>1.25–1.50% management; 17.5% performance over max(50/50 S&amp;P 500 / MSCI Europe + 200bps, 5% absolute); 3-year crystallisation; high-water mark</a:t>
                       </a:r>
                     </a:p>
                   </a:txBody>
@@ -5079,7 +5335,7 @@
                 </a:solidFill>
                 <a:latin typeface="Georgia"/>
               </a:rPr>
-              <a:t>Team &amp; organisation: small, senior, conflict-proofed</a:t>
+              <a:t>Team &amp; organisation: small, senior, transatlantic, conflict-proofed</a:t>
             </a:r>
           </a:p>
         </p:txBody>
@@ -5134,8 +5390,8 @@
         </p:nvSpPr>
         <p:spPr>
           <a:xfrm>
-            <a:off x="3931920" y="1143000"/>
-            <a:ext cx="4297680" cy="685800"/>
+            <a:off x="3931920" y="1097280"/>
+            <a:ext cx="4297680" cy="658368"/>
           </a:xfrm>
           <a:prstGeom prst="rect">
             <a:avLst/>
@@ -5178,7 +5434,7 @@
         </p:nvSpPr>
         <p:spPr>
           <a:xfrm>
-            <a:off x="3931920" y="1243584"/>
+            <a:off x="3931920" y="1179576"/>
             <a:ext cx="4297680" cy="457200"/>
           </a:xfrm>
           <a:prstGeom prst="rect">
@@ -5201,14 +5457,14 @@
               </a:spcAft>
             </a:pPr>
             <a:r>
-              <a:rPr sz="1150" b="1" i="0">
+              <a:rPr sz="1100" b="1" i="0">
                 <a:solidFill>
                   <a:srgbClr val="FFFFFF"/>
                 </a:solidFill>
                 <a:latin typeface="Georgia"/>
               </a:rPr>
               <a:t>Head of Engaged Equities (Partner)
-Ex-Cevian / top activist franchise · ExCo member</a:t>
+Ex-Cevian / top activist franchise · ExCo · Stockholm</a:t>
             </a:r>
           </a:p>
         </p:txBody>
@@ -5221,8 +5477,180 @@
         </p:nvSpPr>
         <p:spPr>
           <a:xfrm>
-            <a:off x="502920" y="2148840"/>
-            <a:ext cx="3611880" cy="960120"/>
+            <a:off x="502920" y="1901952"/>
+            <a:ext cx="11247120" cy="868680"/>
+          </a:xfrm>
+          <a:prstGeom prst="rect">
+            <a:avLst/>
+          </a:prstGeom>
+          <a:solidFill>
+            <a:srgbClr val="133A63"/>
+          </a:solidFill>
+          <a:ln>
+            <a:noFill/>
+          </a:ln>
+          <a:effectLst/>
+        </p:spPr>
+        <p:style>
+          <a:lnRef idx="1">
+            <a:schemeClr val="accent1"/>
+          </a:lnRef>
+          <a:fillRef idx="3">
+            <a:schemeClr val="accent1"/>
+          </a:fillRef>
+          <a:effectRef idx="2">
+            <a:schemeClr val="accent1"/>
+          </a:effectRef>
+          <a:fontRef idx="minor">
+            <a:schemeClr val="lt1"/>
+          </a:fontRef>
+        </p:style>
+        <p:txBody>
+          <a:bodyPr rtlCol="0" anchor="ctr"/>
+          <a:lstStyle/>
+          <a:p>
+            <a:pPr algn="ctr"/>
+          </a:p>
+        </p:txBody>
+      </p:sp>
+      <p:sp>
+        <p:nvSpPr>
+          <p:cNvPr id="10" name="Rectangle 9"/>
+          <p:cNvSpPr/>
+          <p:nvPr/>
+        </p:nvSpPr>
+        <p:spPr>
+          <a:xfrm>
+            <a:off x="502920" y="1901952"/>
+            <a:ext cx="50800" cy="868680"/>
+          </a:xfrm>
+          <a:prstGeom prst="rect">
+            <a:avLst/>
+          </a:prstGeom>
+          <a:solidFill>
+            <a:srgbClr val="C49A3B"/>
+          </a:solidFill>
+          <a:ln>
+            <a:noFill/>
+          </a:ln>
+          <a:effectLst/>
+        </p:spPr>
+        <p:style>
+          <a:lnRef idx="1">
+            <a:schemeClr val="accent1"/>
+          </a:lnRef>
+          <a:fillRef idx="3">
+            <a:schemeClr val="accent1"/>
+          </a:fillRef>
+          <a:effectRef idx="2">
+            <a:schemeClr val="accent1"/>
+          </a:effectRef>
+          <a:fontRef idx="minor">
+            <a:schemeClr val="lt1"/>
+          </a:fontRef>
+        </p:style>
+        <p:txBody>
+          <a:bodyPr rtlCol="0" anchor="ctr"/>
+          <a:lstStyle/>
+          <a:p>
+            <a:pPr algn="ctr"/>
+          </a:p>
+        </p:txBody>
+      </p:sp>
+      <p:sp>
+        <p:nvSpPr>
+          <p:cNvPr id="11" name="TextBox 10"/>
+          <p:cNvSpPr txBox="1"/>
+          <p:nvPr/>
+        </p:nvSpPr>
+        <p:spPr>
+          <a:xfrm>
+            <a:off x="777240" y="1975104"/>
+            <a:ext cx="10789920" cy="320040"/>
+          </a:xfrm>
+          <a:prstGeom prst="rect">
+            <a:avLst/>
+          </a:prstGeom>
+          <a:noFill/>
+        </p:spPr>
+        <p:txBody>
+          <a:bodyPr wrap="square" anchor="t">
+            <a:spAutoFit/>
+          </a:bodyPr>
+          <a:lstStyle/>
+          <a:p>
+            <a:pPr algn="l">
+              <a:lnSpc>
+                <a:spcPct val="100000"/>
+              </a:lnSpc>
+              <a:spcAft>
+                <a:spcPts val="400"/>
+              </a:spcAft>
+            </a:pPr>
+            <a:r>
+              <a:rPr sz="1250" b="1" i="0">
+                <a:solidFill>
+                  <a:srgbClr val="C49A3B"/>
+                </a:solidFill>
+                <a:latin typeface="Georgia"/>
+              </a:rPr>
+              <a:t>Knut Nyman — Principal, US Situations &amp; Campaign Strategy  ·  New York  ·  joining from Elliott Investment Management</a:t>
+            </a:r>
+          </a:p>
+        </p:txBody>
+      </p:sp>
+      <p:sp>
+        <p:nvSpPr>
+          <p:cNvPr id="12" name="TextBox 11"/>
+          <p:cNvSpPr txBox="1"/>
+          <p:nvPr/>
+        </p:nvSpPr>
+        <p:spPr>
+          <a:xfrm>
+            <a:off x="777240" y="2304288"/>
+            <a:ext cx="10789920" cy="411480"/>
+          </a:xfrm>
+          <a:prstGeom prst="rect">
+            <a:avLst/>
+          </a:prstGeom>
+          <a:noFill/>
+        </p:spPr>
+        <p:txBody>
+          <a:bodyPr wrap="square" anchor="t">
+            <a:spAutoFit/>
+          </a:bodyPr>
+          <a:lstStyle/>
+          <a:p>
+            <a:pPr algn="l">
+              <a:lnSpc>
+                <a:spcPct val="105000"/>
+              </a:lnSpc>
+              <a:spcAft>
+                <a:spcPts val="400"/>
+              </a:spcAft>
+            </a:pPr>
+            <a:r>
+              <a:rPr sz="1050" b="0" i="0">
+                <a:solidFill>
+                  <a:srgbClr val="FFFFFF"/>
+                </a:solidFill>
+                <a:latin typeface="Georgia"/>
+              </a:rPr>
+              <a:t>Owns the US book: idea generation &amp; underwriting · 13D and universal-proxy playbook · settlement negotiation · US advisor network. Co-leads 1–2 campaigns per year; campaign lead from year two; path to Partner; carry from day one.</a:t>
+            </a:r>
+          </a:p>
+        </p:txBody>
+      </p:sp>
+      <p:sp>
+        <p:nvSpPr>
+          <p:cNvPr id="13" name="Rectangle 12"/>
+          <p:cNvSpPr/>
+          <p:nvPr/>
+        </p:nvSpPr>
+        <p:spPr>
+          <a:xfrm>
+            <a:off x="502920" y="2907792"/>
+            <a:ext cx="3611880" cy="896112"/>
           </a:xfrm>
           <a:prstGeom prst="rect">
             <a:avLst/>
@@ -5259,14 +5687,14 @@
       </p:sp>
       <p:sp>
         <p:nvSpPr>
-          <p:cNvPr id="10" name="Rectangle 9"/>
+          <p:cNvPr id="14" name="Rectangle 13"/>
           <p:cNvSpPr/>
           <p:nvPr/>
         </p:nvSpPr>
         <p:spPr>
           <a:xfrm>
-            <a:off x="502920" y="2148840"/>
-            <a:ext cx="44450" cy="960120"/>
+            <a:off x="502920" y="2907792"/>
+            <a:ext cx="44450" cy="896112"/>
           </a:xfrm>
           <a:prstGeom prst="rect">
             <a:avLst/>
@@ -5303,13 +5731,13 @@
       </p:sp>
       <p:sp>
         <p:nvSpPr>
-          <p:cNvPr id="11" name="TextBox 10"/>
-          <p:cNvSpPr txBox="1"/>
-          <p:nvPr/>
-        </p:nvSpPr>
-        <p:spPr>
-          <a:xfrm>
-            <a:off x="640080" y="2221992"/>
+          <p:cNvPr id="15" name="TextBox 14"/>
+          <p:cNvSpPr txBox="1"/>
+          <p:nvPr/>
+        </p:nvSpPr>
+        <p:spPr>
+          <a:xfrm>
+            <a:off x="640080" y="2962656"/>
             <a:ext cx="3383280" cy="365760"/>
           </a:xfrm>
           <a:prstGeom prst="rect">
@@ -5332,7 +5760,7 @@
               </a:spcAft>
             </a:pPr>
             <a:r>
-              <a:rPr sz="1150" b="1" i="0">
+              <a:rPr sz="1100" b="1" i="0">
                 <a:solidFill>
                   <a:srgbClr val="0B2545"/>
                 </a:solidFill>
@@ -5345,14 +5773,14 @@
       </p:sp>
       <p:sp>
         <p:nvSpPr>
-          <p:cNvPr id="12" name="TextBox 11"/>
-          <p:cNvSpPr txBox="1"/>
-          <p:nvPr/>
-        </p:nvSpPr>
-        <p:spPr>
-          <a:xfrm>
-            <a:off x="640080" y="2624328"/>
-            <a:ext cx="3383280" cy="411480"/>
+          <p:cNvPr id="16" name="TextBox 15"/>
+          <p:cNvSpPr txBox="1"/>
+          <p:nvPr/>
+        </p:nvSpPr>
+        <p:spPr>
+          <a:xfrm>
+            <a:off x="640080" y="3364992"/>
+            <a:ext cx="3383280" cy="384048"/>
           </a:xfrm>
           <a:prstGeom prst="rect">
             <a:avLst/>
@@ -5374,7 +5802,7 @@
               </a:spcAft>
             </a:pPr>
             <a:r>
-              <a:rPr sz="1000" b="0" i="0">
+              <a:rPr sz="950" b="0" i="0">
                 <a:solidFill>
                   <a:srgbClr val="555F6E"/>
                 </a:solidFill>
@@ -5387,14 +5815,14 @@
       </p:sp>
       <p:sp>
         <p:nvSpPr>
-          <p:cNvPr id="13" name="Rectangle 12"/>
+          <p:cNvPr id="17" name="Rectangle 16"/>
           <p:cNvSpPr/>
           <p:nvPr/>
         </p:nvSpPr>
         <p:spPr>
           <a:xfrm>
-            <a:off x="4325112" y="2148840"/>
-            <a:ext cx="3611880" cy="960120"/>
+            <a:off x="4325112" y="2907792"/>
+            <a:ext cx="3611880" cy="896112"/>
           </a:xfrm>
           <a:prstGeom prst="rect">
             <a:avLst/>
@@ -5431,14 +5859,14 @@
       </p:sp>
       <p:sp>
         <p:nvSpPr>
-          <p:cNvPr id="14" name="Rectangle 13"/>
+          <p:cNvPr id="18" name="Rectangle 17"/>
           <p:cNvSpPr/>
           <p:nvPr/>
         </p:nvSpPr>
         <p:spPr>
           <a:xfrm>
-            <a:off x="4325112" y="2148840"/>
-            <a:ext cx="44450" cy="960120"/>
+            <a:off x="4325112" y="2907792"/>
+            <a:ext cx="44450" cy="896112"/>
           </a:xfrm>
           <a:prstGeom prst="rect">
             <a:avLst/>
@@ -5475,13 +5903,13 @@
       </p:sp>
       <p:sp>
         <p:nvSpPr>
-          <p:cNvPr id="15" name="TextBox 14"/>
-          <p:cNvSpPr txBox="1"/>
-          <p:nvPr/>
-        </p:nvSpPr>
-        <p:spPr>
-          <a:xfrm>
-            <a:off x="4462272" y="2221992"/>
+          <p:cNvPr id="19" name="TextBox 18"/>
+          <p:cNvSpPr txBox="1"/>
+          <p:nvPr/>
+        </p:nvSpPr>
+        <p:spPr>
+          <a:xfrm>
+            <a:off x="4462272" y="2962656"/>
             <a:ext cx="3383280" cy="365760"/>
           </a:xfrm>
           <a:prstGeom prst="rect">
@@ -5504,7 +5932,7 @@
               </a:spcAft>
             </a:pPr>
             <a:r>
-              <a:rPr sz="1150" b="1" i="0">
+              <a:rPr sz="1100" b="1" i="0">
                 <a:solidFill>
                   <a:srgbClr val="0B2545"/>
                 </a:solidFill>
@@ -5517,14 +5945,14 @@
       </p:sp>
       <p:sp>
         <p:nvSpPr>
-          <p:cNvPr id="16" name="TextBox 15"/>
-          <p:cNvSpPr txBox="1"/>
-          <p:nvPr/>
-        </p:nvSpPr>
-        <p:spPr>
-          <a:xfrm>
-            <a:off x="4462272" y="2624328"/>
-            <a:ext cx="3383280" cy="411480"/>
+          <p:cNvPr id="20" name="TextBox 19"/>
+          <p:cNvSpPr txBox="1"/>
+          <p:nvPr/>
+        </p:nvSpPr>
+        <p:spPr>
+          <a:xfrm>
+            <a:off x="4462272" y="3364992"/>
+            <a:ext cx="3383280" cy="384048"/>
           </a:xfrm>
           <a:prstGeom prst="rect">
             <a:avLst/>
@@ -5546,27 +5974,27 @@
               </a:spcAft>
             </a:pPr>
             <a:r>
-              <a:rPr sz="1000" b="0" i="0">
+              <a:rPr sz="950" b="0" i="0">
                 <a:solidFill>
                   <a:srgbClr val="555F6E"/>
                 </a:solidFill>
                 <a:latin typeface="Georgia"/>
               </a:rPr>
-              <a:t>Campaign lead</a:t>
-            </a:r>
-          </a:p>
-        </p:txBody>
-      </p:sp>
-      <p:sp>
-        <p:nvSpPr>
-          <p:cNvPr id="17" name="Rectangle 16"/>
+              <a:t>Campaign lead (one per region)</a:t>
+            </a:r>
+          </a:p>
+        </p:txBody>
+      </p:sp>
+      <p:sp>
+        <p:nvSpPr>
+          <p:cNvPr id="21" name="Rectangle 20"/>
           <p:cNvSpPr/>
           <p:nvPr/>
         </p:nvSpPr>
         <p:spPr>
           <a:xfrm>
-            <a:off x="8147304" y="2148840"/>
-            <a:ext cx="3611880" cy="960120"/>
+            <a:off x="8147304" y="2907792"/>
+            <a:ext cx="3611880" cy="896112"/>
           </a:xfrm>
           <a:prstGeom prst="rect">
             <a:avLst/>
@@ -5603,14 +6031,14 @@
       </p:sp>
       <p:sp>
         <p:nvSpPr>
-          <p:cNvPr id="18" name="Rectangle 17"/>
+          <p:cNvPr id="22" name="Rectangle 21"/>
           <p:cNvSpPr/>
           <p:nvPr/>
         </p:nvSpPr>
         <p:spPr>
           <a:xfrm>
-            <a:off x="8147304" y="2148840"/>
-            <a:ext cx="44450" cy="960120"/>
+            <a:off x="8147304" y="2907792"/>
+            <a:ext cx="44450" cy="896112"/>
           </a:xfrm>
           <a:prstGeom prst="rect">
             <a:avLst/>
@@ -5647,13 +6075,13 @@
       </p:sp>
       <p:sp>
         <p:nvSpPr>
-          <p:cNvPr id="19" name="TextBox 18"/>
-          <p:cNvSpPr txBox="1"/>
-          <p:nvPr/>
-        </p:nvSpPr>
-        <p:spPr>
-          <a:xfrm>
-            <a:off x="8284464" y="2221992"/>
+          <p:cNvPr id="23" name="TextBox 22"/>
+          <p:cNvSpPr txBox="1"/>
+          <p:nvPr/>
+        </p:nvSpPr>
+        <p:spPr>
+          <a:xfrm>
+            <a:off x="8284464" y="2962656"/>
             <a:ext cx="3383280" cy="365760"/>
           </a:xfrm>
           <a:prstGeom prst="rect">
@@ -5676,7 +6104,7 @@
               </a:spcAft>
             </a:pPr>
             <a:r>
-              <a:rPr sz="1150" b="1" i="0">
+              <a:rPr sz="1100" b="1" i="0">
                 <a:solidFill>
                   <a:srgbClr val="0B2545"/>
                 </a:solidFill>
@@ -5689,14 +6117,14 @@
       </p:sp>
       <p:sp>
         <p:nvSpPr>
-          <p:cNvPr id="20" name="TextBox 19"/>
-          <p:cNvSpPr txBox="1"/>
-          <p:nvPr/>
-        </p:nvSpPr>
-        <p:spPr>
-          <a:xfrm>
-            <a:off x="8284464" y="2624328"/>
-            <a:ext cx="3383280" cy="411480"/>
+          <p:cNvPr id="24" name="TextBox 23"/>
+          <p:cNvSpPr txBox="1"/>
+          <p:nvPr/>
+        </p:nvSpPr>
+        <p:spPr>
+          <a:xfrm>
+            <a:off x="8284464" y="3364992"/>
+            <a:ext cx="3383280" cy="384048"/>
           </a:xfrm>
           <a:prstGeom prst="rect">
             <a:avLst/>
@@ -5718,27 +6146,27 @@
               </a:spcAft>
             </a:pPr>
             <a:r>
-              <a:rPr sz="1000" b="0" i="0">
+              <a:rPr sz="950" b="0" i="0">
                 <a:solidFill>
                   <a:srgbClr val="555F6E"/>
                 </a:solidFill>
                 <a:latin typeface="Georgia"/>
               </a:rPr>
-              <a:t>Campaign lead</a:t>
-            </a:r>
-          </a:p>
-        </p:txBody>
-      </p:sp>
-      <p:sp>
-        <p:nvSpPr>
-          <p:cNvPr id="21" name="Rectangle 20"/>
+              <a:t>Campaign lead (one per region)</a:t>
+            </a:r>
+          </a:p>
+        </p:txBody>
+      </p:sp>
+      <p:sp>
+        <p:nvSpPr>
+          <p:cNvPr id="25" name="Rectangle 24"/>
           <p:cNvSpPr/>
           <p:nvPr/>
         </p:nvSpPr>
         <p:spPr>
           <a:xfrm>
-            <a:off x="502920" y="3291840"/>
-            <a:ext cx="3611880" cy="960120"/>
+            <a:off x="502920" y="3931920"/>
+            <a:ext cx="3611880" cy="896112"/>
           </a:xfrm>
           <a:prstGeom prst="rect">
             <a:avLst/>
@@ -5775,14 +6203,14 @@
       </p:sp>
       <p:sp>
         <p:nvSpPr>
-          <p:cNvPr id="22" name="Rectangle 21"/>
+          <p:cNvPr id="26" name="Rectangle 25"/>
           <p:cNvSpPr/>
           <p:nvPr/>
         </p:nvSpPr>
         <p:spPr>
           <a:xfrm>
-            <a:off x="502920" y="3291840"/>
-            <a:ext cx="44450" cy="960120"/>
+            <a:off x="502920" y="3931920"/>
+            <a:ext cx="44450" cy="896112"/>
           </a:xfrm>
           <a:prstGeom prst="rect">
             <a:avLst/>
@@ -5819,13 +6247,13 @@
       </p:sp>
       <p:sp>
         <p:nvSpPr>
-          <p:cNvPr id="23" name="TextBox 22"/>
-          <p:cNvSpPr txBox="1"/>
-          <p:nvPr/>
-        </p:nvSpPr>
-        <p:spPr>
-          <a:xfrm>
-            <a:off x="640080" y="3364992"/>
+          <p:cNvPr id="27" name="TextBox 26"/>
+          <p:cNvSpPr txBox="1"/>
+          <p:nvPr/>
+        </p:nvSpPr>
+        <p:spPr>
+          <a:xfrm>
+            <a:off x="640080" y="3986784"/>
             <a:ext cx="3383280" cy="365760"/>
           </a:xfrm>
           <a:prstGeom prst="rect">
@@ -5848,7 +6276,7 @@
               </a:spcAft>
             </a:pPr>
             <a:r>
-              <a:rPr sz="1150" b="1" i="0">
+              <a:rPr sz="1100" b="1" i="0">
                 <a:solidFill>
                   <a:srgbClr val="0B2545"/>
                 </a:solidFill>
@@ -5861,14 +6289,14 @@
       </p:sp>
       <p:sp>
         <p:nvSpPr>
-          <p:cNvPr id="24" name="TextBox 23"/>
-          <p:cNvSpPr txBox="1"/>
-          <p:nvPr/>
-        </p:nvSpPr>
-        <p:spPr>
-          <a:xfrm>
-            <a:off x="640080" y="3767328"/>
-            <a:ext cx="3383280" cy="411480"/>
+          <p:cNvPr id="28" name="TextBox 27"/>
+          <p:cNvSpPr txBox="1"/>
+          <p:nvPr/>
+        </p:nvSpPr>
+        <p:spPr>
+          <a:xfrm>
+            <a:off x="640080" y="4389120"/>
+            <a:ext cx="3383280" cy="384048"/>
           </a:xfrm>
           <a:prstGeom prst="rect">
             <a:avLst/>
@@ -5890,27 +6318,27 @@
               </a:spcAft>
             </a:pPr>
             <a:r>
-              <a:rPr sz="1000" b="0" i="0">
+              <a:rPr sz="950" b="0" i="0">
                 <a:solidFill>
                   <a:srgbClr val="555F6E"/>
                 </a:solidFill>
                 <a:latin typeface="Georgia"/>
               </a:rPr>
-              <a:t>Modelling · register analytics · benchmarking</a:t>
-            </a:r>
-          </a:p>
-        </p:txBody>
-      </p:sp>
-      <p:sp>
-        <p:nvSpPr>
-          <p:cNvPr id="25" name="Rectangle 24"/>
+              <a:t>Modelling · register analytics · split SHB/NY</a:t>
+            </a:r>
+          </a:p>
+        </p:txBody>
+      </p:sp>
+      <p:sp>
+        <p:nvSpPr>
+          <p:cNvPr id="29" name="Rectangle 28"/>
           <p:cNvSpPr/>
           <p:nvPr/>
         </p:nvSpPr>
         <p:spPr>
           <a:xfrm>
-            <a:off x="4325112" y="3291840"/>
-            <a:ext cx="3611880" cy="960120"/>
+            <a:off x="4325112" y="3931920"/>
+            <a:ext cx="3611880" cy="896112"/>
           </a:xfrm>
           <a:prstGeom prst="rect">
             <a:avLst/>
@@ -5947,14 +6375,14 @@
       </p:sp>
       <p:sp>
         <p:nvSpPr>
-          <p:cNvPr id="26" name="Rectangle 25"/>
+          <p:cNvPr id="30" name="Rectangle 29"/>
           <p:cNvSpPr/>
           <p:nvPr/>
         </p:nvSpPr>
         <p:spPr>
           <a:xfrm>
-            <a:off x="4325112" y="3291840"/>
-            <a:ext cx="44450" cy="960120"/>
+            <a:off x="4325112" y="3931920"/>
+            <a:ext cx="44450" cy="896112"/>
           </a:xfrm>
           <a:prstGeom prst="rect">
             <a:avLst/>
@@ -5991,13 +6419,13 @@
       </p:sp>
       <p:sp>
         <p:nvSpPr>
-          <p:cNvPr id="27" name="TextBox 26"/>
-          <p:cNvSpPr txBox="1"/>
-          <p:nvPr/>
-        </p:nvSpPr>
-        <p:spPr>
-          <a:xfrm>
-            <a:off x="4462272" y="3364992"/>
+          <p:cNvPr id="31" name="TextBox 30"/>
+          <p:cNvSpPr txBox="1"/>
+          <p:nvPr/>
+        </p:nvSpPr>
+        <p:spPr>
+          <a:xfrm>
+            <a:off x="4462272" y="3986784"/>
             <a:ext cx="3383280" cy="365760"/>
           </a:xfrm>
           <a:prstGeom prst="rect">
@@ -6020,7 +6448,7 @@
               </a:spcAft>
             </a:pPr>
             <a:r>
-              <a:rPr sz="1150" b="1" i="0">
+              <a:rPr sz="1100" b="1" i="0">
                 <a:solidFill>
                   <a:srgbClr val="0B2545"/>
                 </a:solidFill>
@@ -6033,14 +6461,14 @@
       </p:sp>
       <p:sp>
         <p:nvSpPr>
-          <p:cNvPr id="28" name="TextBox 27"/>
-          <p:cNvSpPr txBox="1"/>
-          <p:nvPr/>
-        </p:nvSpPr>
-        <p:spPr>
-          <a:xfrm>
-            <a:off x="4462272" y="3767328"/>
-            <a:ext cx="3383280" cy="411480"/>
+          <p:cNvPr id="32" name="TextBox 31"/>
+          <p:cNvSpPr txBox="1"/>
+          <p:nvPr/>
+        </p:nvSpPr>
+        <p:spPr>
+          <a:xfrm>
+            <a:off x="4462272" y="4389120"/>
+            <a:ext cx="3383280" cy="384048"/>
           </a:xfrm>
           <a:prstGeom prst="rect">
             <a:avLst/>
@@ -6062,7 +6490,7 @@
               </a:spcAft>
             </a:pPr>
             <a:r>
-              <a:rPr sz="1000" b="0" i="0">
+              <a:rPr sz="950" b="0" i="0">
                 <a:solidFill>
                   <a:srgbClr val="555F6E"/>
                 </a:solidFill>
@@ -6075,14 +6503,14 @@
       </p:sp>
       <p:sp>
         <p:nvSpPr>
-          <p:cNvPr id="29" name="Rectangle 28"/>
+          <p:cNvPr id="33" name="Rectangle 32"/>
           <p:cNvSpPr/>
           <p:nvPr/>
         </p:nvSpPr>
         <p:spPr>
           <a:xfrm>
-            <a:off x="8147304" y="3291840"/>
-            <a:ext cx="3611880" cy="960120"/>
+            <a:off x="8147304" y="3931920"/>
+            <a:ext cx="3611880" cy="896112"/>
           </a:xfrm>
           <a:prstGeom prst="rect">
             <a:avLst/>
@@ -6119,14 +6547,14 @@
       </p:sp>
       <p:sp>
         <p:nvSpPr>
-          <p:cNvPr id="30" name="Rectangle 29"/>
+          <p:cNvPr id="34" name="Rectangle 33"/>
           <p:cNvSpPr/>
           <p:nvPr/>
         </p:nvSpPr>
         <p:spPr>
           <a:xfrm>
-            <a:off x="8147304" y="3291840"/>
-            <a:ext cx="44450" cy="960120"/>
+            <a:off x="8147304" y="3931920"/>
+            <a:ext cx="44450" cy="896112"/>
           </a:xfrm>
           <a:prstGeom prst="rect">
             <a:avLst/>
@@ -6163,13 +6591,13 @@
       </p:sp>
       <p:sp>
         <p:nvSpPr>
-          <p:cNvPr id="31" name="TextBox 30"/>
-          <p:cNvSpPr txBox="1"/>
-          <p:nvPr/>
-        </p:nvSpPr>
-        <p:spPr>
-          <a:xfrm>
-            <a:off x="8284464" y="3364992"/>
+          <p:cNvPr id="35" name="TextBox 34"/>
+          <p:cNvSpPr txBox="1"/>
+          <p:nvPr/>
+        </p:nvSpPr>
+        <p:spPr>
+          <a:xfrm>
+            <a:off x="8284464" y="3986784"/>
             <a:ext cx="3383280" cy="365760"/>
           </a:xfrm>
           <a:prstGeom prst="rect">
@@ -6192,7 +6620,7 @@
               </a:spcAft>
             </a:pPr>
             <a:r>
-              <a:rPr sz="1150" b="1" i="0">
+              <a:rPr sz="1100" b="1" i="0">
                 <a:solidFill>
                   <a:srgbClr val="0B2545"/>
                 </a:solidFill>
@@ -6205,14 +6633,14 @@
       </p:sp>
       <p:sp>
         <p:nvSpPr>
-          <p:cNvPr id="32" name="TextBox 31"/>
-          <p:cNvSpPr txBox="1"/>
-          <p:nvPr/>
-        </p:nvSpPr>
-        <p:spPr>
-          <a:xfrm>
-            <a:off x="8284464" y="3767328"/>
-            <a:ext cx="3383280" cy="411480"/>
+          <p:cNvPr id="36" name="TextBox 35"/>
+          <p:cNvSpPr txBox="1"/>
+          <p:nvPr/>
+        </p:nvSpPr>
+        <p:spPr>
+          <a:xfrm>
+            <a:off x="8284464" y="4389120"/>
+            <a:ext cx="3383280" cy="384048"/>
           </a:xfrm>
           <a:prstGeom prst="rect">
             <a:avLst/>
@@ -6234,7 +6662,7 @@
               </a:spcAft>
             </a:pPr>
             <a:r>
-              <a:rPr sz="1000" b="0" i="0">
+              <a:rPr sz="950" b="0" i="0">
                 <a:solidFill>
                   <a:srgbClr val="555F6E"/>
                 </a:solidFill>
@@ -6247,14 +6675,14 @@
       </p:sp>
       <p:sp>
         <p:nvSpPr>
-          <p:cNvPr id="33" name="TextBox 32"/>
-          <p:cNvSpPr txBox="1"/>
-          <p:nvPr/>
-        </p:nvSpPr>
-        <p:spPr>
-          <a:xfrm>
-            <a:off x="502920" y="4617720"/>
-            <a:ext cx="11247120" cy="1645920"/>
+          <p:cNvPr id="37" name="TextBox 36"/>
+          <p:cNvSpPr txBox="1"/>
+          <p:nvPr/>
+        </p:nvSpPr>
+        <p:spPr>
+          <a:xfrm>
+            <a:off x="502920" y="5074920"/>
+            <a:ext cx="11247120" cy="1371600"/>
           </a:xfrm>
           <a:prstGeom prst="rect">
             <a:avLst/>
@@ -6272,11 +6700,11 @@
                 <a:spcPct val="105000"/>
               </a:lnSpc>
               <a:spcAft>
-                <a:spcPts val="600"/>
-              </a:spcAft>
-            </a:pPr>
-            <a:r>
-              <a:rPr sz="1150">
+                <a:spcPts val="400"/>
+              </a:spcAft>
+            </a:pPr>
+            <a:r>
+              <a:rPr sz="1050">
                 <a:solidFill>
                   <a:srgbClr val="C49A3B"/>
                 </a:solidFill>
@@ -6285,7 +6713,7 @@
               <a:t>▪  </a:t>
             </a:r>
             <a:r>
-              <a:rPr b="1" sz="1150">
+              <a:rPr b="1" sz="1050">
                 <a:solidFill>
                   <a:srgbClr val="0B2545"/>
                 </a:solidFill>
@@ -6294,7 +6722,7 @@
               <a:t>Conflicts framework (make-or-break): </a:t>
             </a:r>
             <a:r>
-              <a:rPr sz="1150">
+              <a:rPr sz="1050">
                 <a:solidFill>
                   <a:srgbClr val="2B3340"/>
                 </a:solidFill>
@@ -6309,11 +6737,11 @@
                 <a:spcPct val="105000"/>
               </a:lnSpc>
               <a:spcAft>
-                <a:spcPts val="600"/>
-              </a:spcAft>
-            </a:pPr>
-            <a:r>
-              <a:rPr sz="1150">
+                <a:spcPts val="400"/>
+              </a:spcAft>
+            </a:pPr>
+            <a:r>
+              <a:rPr sz="1050">
                 <a:solidFill>
                   <a:srgbClr val="C49A3B"/>
                 </a:solidFill>
@@ -6322,7 +6750,7 @@
               <a:t>▪  </a:t>
             </a:r>
             <a:r>
-              <a:rPr b="1" sz="1150">
+              <a:rPr b="1" sz="1050">
                 <a:solidFill>
                   <a:srgbClr val="0B2545"/>
                 </a:solidFill>
@@ -6331,7 +6759,7 @@
               <a:t>Take-private protocol: </a:t>
             </a:r>
             <a:r>
-              <a:rPr sz="1150">
+              <a:rPr sz="1050">
                 <a:solidFill>
                   <a:srgbClr val="2B3340"/>
                 </a:solidFill>
@@ -6346,11 +6774,11 @@
                 <a:spcPct val="105000"/>
               </a:lnSpc>
               <a:spcAft>
-                <a:spcPts val="600"/>
-              </a:spcAft>
-            </a:pPr>
-            <a:r>
-              <a:rPr sz="1150">
+                <a:spcPts val="400"/>
+              </a:spcAft>
+            </a:pPr>
+            <a:r>
+              <a:rPr sz="1050">
                 <a:solidFill>
                   <a:srgbClr val="C49A3B"/>
                 </a:solidFill>
@@ -6359,7 +6787,7 @@
               <a:t>▪  </a:t>
             </a:r>
             <a:r>
-              <a:rPr b="1" sz="1150">
+              <a:rPr b="1" sz="1050">
                 <a:solidFill>
                   <a:srgbClr val="0B2545"/>
                 </a:solidFill>
@@ -6368,13 +6796,13 @@
               <a:t>Reputation committee: </a:t>
             </a:r>
             <a:r>
-              <a:rPr sz="1150">
+              <a:rPr sz="1050">
                 <a:solidFill>
                   <a:srgbClr val="2B3340"/>
                 </a:solidFill>
                 <a:latin typeface="Georgia"/>
               </a:rPr>
-              <a:t>Managing Partner sign-off required for any public escalation, media engagement or EGM requisition.</a:t>
+              <a:t>Managing Partner sign-off for any public escalation, media engagement or EGM/proxy action.</a:t>
             </a:r>
           </a:p>
         </p:txBody>
@@ -6951,7 +7379,7 @@
                           </a:solidFill>
                           <a:latin typeface="Georgia"/>
                         </a:rPr>
-                        <a:t>Mid-cap liquidity (SEK/NOK/DKK)</a:t>
+                        <a:t>European mid-cap liquidity (thinner than US lines)</a:t>
                       </a:r>
                     </a:p>
                   </a:txBody>
@@ -6973,7 +7401,7 @@
                           </a:solidFill>
                           <a:latin typeface="Georgia"/>
                         </a:rPr>
-                        <a:t>ADV-tied sizing; evergreen + gates; co-invest sleeves; event-driven exits</a:t>
+                        <a:t>ADV-tied sizing; larger tickets in US names; evergreen + gates; co-invest sleeves; event-driven exits</a:t>
                       </a:r>
                     </a:p>
                   </a:txBody>
@@ -7735,7 +8163,7 @@
                 </a:solidFill>
                 <a:latin typeface="Georgia"/>
               </a:rPr>
-              <a:t>Head + Deputy hired · core team of 6 · EUR 150–200m seed closed · 10–14 underwritten names · LP pre-marketing</a:t>
+              <a:t>Head + Deputy hired · Knut Nyman &amp; NY pod on board · core team of 7 · EUR 150–200m seed closed · 12–16 underwritten names · LP pre-marketing</a:t>
             </a:r>
           </a:p>
         </p:txBody>
@@ -7949,7 +8377,7 @@
                 </a:solidFill>
                 <a:latin typeface="Georgia"/>
               </a:rPr>
-              <a:t>First close ~USD 750m · 2–3 positions built against Q3-2027 ownership snapshots (seats 2028 nomination committees)</a:t>
+              <a:t>First close ~USD 750m · 2–3 positions built against the board calendar (Q3-2027 Nordic snapshots; US nomination windows for the 2028 proxy season)</a:t>
             </a:r>
           </a:p>
         </p:txBody>
@@ -8163,7 +8591,7 @@
                 </a:solidFill>
                 <a:latin typeface="Georgia"/>
               </a:rPr>
-              <a:t>Final close USD 1.5–2.0bn · 6–8 positions · first board seats at the 2028 AGM season · first realisations 2029</a:t>
+              <a:t>Final close USD 1.5–2.0bn · 6–8 positions across both regions · first board seats and settlements in the 2028 cycles · first realisations 2029</a:t>
             </a:r>
           </a:p>
         </p:txBody>
@@ -8416,7 +8844,7 @@
                 </a:solidFill>
                 <a:latin typeface="Georgia"/>
               </a:rPr>
-              <a:t>The Nordic engagement franchise has not been built yet.</a:t>
+              <a:t>The transatlantic engagement franchise has not been built yet.</a:t>
             </a:r>
           </a:p>
         </p:txBody>
@@ -8792,7 +9220,7 @@
                 </a:solidFill>
                 <a:latin typeface="Georgia"/>
               </a:rPr>
-              <a:t>a USD 1.5bn (cap USD 2.0bn) constructive-activism fund taking 4–10% stakes in 6–8 listed Nordic mid-caps (EUR 1–10bn market cap).</a:t>
+              <a:t>a USD 1.5bn (cap USD 2.0bn) constructive-activism fund taking 2–10% stakes in 6–8 listed US and European companies (USD 2–15bn market cap) in the firm's core sectors.</a:t>
             </a:r>
           </a:p>
           <a:p>
@@ -8829,7 +9257,7 @@
                 </a:solidFill>
                 <a:latin typeface="Georgia"/>
               </a:rPr>
-              <a:t>operational improvement, portfolio separation, capital-allocation reform — executed via nomination committees and board seats, not public fights.</a:t>
+              <a:t>operational improvement, portfolio separation, capital-allocation reform — via nomination committees and board seats in Europe, universal-proxy-backed engagement in the US.</a:t>
             </a:r>
           </a:p>
           <a:p>
@@ -8866,7 +9294,7 @@
                 </a:solidFill>
                 <a:latin typeface="Georgia"/>
               </a:rPr>
-              <a:t>record global activism, an M&amp;A-heavy campaign mix that favours a PE sponsor, persistent 30–50% value gaps in under-covered Nordic mid-caps — and only one established practitioner (Cevian) in the region.</a:t>
+              <a:t>record global activism with an M&amp;A-heavy mix that favours a PE sponsor, 30–50% value gaps in de-rated quality mid-caps on both continents — and no practitioner combining operating depth with a transatlantic mandate.</a:t>
             </a:r>
           </a:p>
           <a:p>
@@ -8903,7 +9331,7 @@
                 </a:solidFill>
                 <a:latin typeface="Georgia"/>
               </a:rPr>
-              <a:t>operating credibility, the region's best director bench, domestic legitimacy, and sector depth in healthcare, tech &amp; payments, financial services and industrials.</a:t>
+              <a:t>operating credibility, the best director bench in Europe, a New York platform, and sector depth in healthcare, tech &amp; payments, financial services and industrials. US campaign strategy led by Knut Nyman, joining from Elliott.</a:t>
             </a:r>
           </a:p>
           <a:p>
@@ -9152,7 +9580,7 @@
                 </a:solidFill>
                 <a:latin typeface="Georgia"/>
               </a:rPr>
-              <a:t>Concentrated core positions, 4–10% stakes</a:t>
+              <a:t>Core positions · ~50/50 US &amp; Europe · 2–10% stakes</a:t>
             </a:r>
           </a:p>
         </p:txBody>
@@ -9510,7 +9938,7 @@
                 </a:solidFill>
                 <a:latin typeface="Georgia"/>
               </a:rPr>
-              <a:t>Why now: the opening for a second Nordic engagement franchise</a:t>
+              <a:t>Why now: the opening for a transatlantic engagement franchise</a:t>
             </a:r>
           </a:p>
         </p:txBody>
@@ -9854,7 +10282,7 @@
                 </a:solidFill>
                 <a:latin typeface="Georgia"/>
               </a:rPr>
-              <a:t>Persistent Nordic value gaps</a:t>
+              <a:t>Value gaps on both continents</a:t>
             </a:r>
           </a:p>
         </p:txBody>
@@ -9896,7 +10324,7 @@
                 </a:solidFill>
                 <a:latin typeface="Georgia"/>
               </a:rPr>
-              <a:t>Nordic mid-caps are structurally under-covered post-MiFID II; quality franchises trade at 30–50% discounts to intrinsic value on SOTP / normalised margins — below the entry multiples our buyout funds pay in auctions.</a:t>
+              <a:t>Europe: structural discount to the US, compounded in under-covered mid-caps. US: the post-2021 de-rating left fallen-angel quality in medtech, payments and software at 30–50% discounts — below the multiples our buyout funds pay in auctions.</a:t>
             </a:r>
           </a:p>
         </p:txBody>
@@ -10026,7 +10454,7 @@
                 </a:solidFill>
                 <a:latin typeface="Georgia"/>
               </a:rPr>
-              <a:t>Thin dedicated competition</a:t>
+              <a:t>Mis-shaped competition</a:t>
             </a:r>
           </a:p>
         </p:txBody>
@@ -10068,7 +10496,7 @@
                 </a:solidFill>
                 <a:latin typeface="Georgia"/>
               </a:rPr>
-              <a:t>Cevian is the only institutional-scale practitioner and has migrated toward pan-European large-caps. The EUR 1–10bn mid-cap band is underserved — and the 2026 launch of Active Value Partners (ex-Cevian) confirms institutional appetite for the space.</a:t>
+              <a:t>US activism is crowded at the mega-cap end but thin in operationally complex mid-caps; in Europe, Cevian has drifted large-cap and has no US book. Nobody combines PE operating depth with a transatlantic mandate.</a:t>
             </a:r>
           </a:p>
         </p:txBody>
@@ -10240,7 +10668,7 @@
                 </a:solidFill>
                 <a:latin typeface="Georgia"/>
               </a:rPr>
-              <a:t>Nordic institutions, AP funds and universal owners increasingly back well-argued engagement agendas — lowering the cost of building winning coalitions.</a:t>
+              <a:t>Index funds and pension institutions on both continents increasingly back well-argued engagement agendas — lowering the cost of building winning coalitions.</a:t>
             </a:r>
           </a:p>
         </p:txBody>
@@ -10345,7 +10773,7 @@
                 </a:solidFill>
                 <a:latin typeface="Georgia"/>
               </a:rPr>
-              <a:t>The category-defining domestic engagement franchise in the Nordics has not yet been built. Nordic Capital can build it — with advantages Cevian never had: a buyout platform behind the engagement and an operating bench measured in hundreds of professionals.</a:t>
+              <a:t>The category-defining sponsor-backed engagement franchise spanning the US and Europe has not yet been built. Nordic Capital can build it — with advantages neither Cevian nor the US funds have: a buyout platform behind the engagement and an operating bench measured in hundreds of professionals.</a:t>
             </a:r>
           </a:p>
         </p:txBody>
@@ -10535,7 +10963,7 @@
                 </a:solidFill>
                 <a:latin typeface="Georgia"/>
               </a:rPr>
-              <a:t>The Nordics: the most activist-friendly governance model in the world</a:t>
+              <a:t>Two engagement regimes, one playbook</a:t>
             </a:r>
           </a:p>
         </p:txBody>
@@ -10592,7 +11020,7 @@
         </p:nvGraphicFramePr>
         <p:xfrm>
           <a:off x="502920" y="1234440"/>
-          <a:ext cx="11247120" cy="4279392"/>
+          <a:ext cx="11247120" cy="4343400"/>
         </p:xfrm>
         <a:graphic>
           <a:graphicData uri="http://schemas.openxmlformats.org/drawingml/2006/table">
@@ -10601,24 +11029,24 @@
                 <a:tableStyleId>{5C22544A-7EE6-4342-B048-85BDC9FD1C3A}</a:tableStyleId>
               </a:tblPr>
               <a:tblGrid>
-                <a:gridCol w="2103120"/>
+                <a:gridCol w="1645920"/>
+                <a:gridCol w="4846320"/>
                 <a:gridCol w="4754880"/>
-                <a:gridCol w="4389120"/>
               </a:tblGrid>
-              <a:tr h="713232">
+              <a:tr h="868680">
                 <a:tc>
                   <a:txBody>
                     <a:bodyPr/>
                     <a:lstStyle/>
                     <a:p>
                       <a:r>
-                        <a:rPr sz="1150" b="1">
+                        <a:rPr sz="1100" b="1">
                           <a:solidFill>
                             <a:srgbClr val="FFFFFF"/>
                           </a:solidFill>
                           <a:latin typeface="Georgia"/>
                         </a:rPr>
-                        <a:t>Feature</a:t>
+                        <a:t>Dimension</a:t>
                       </a:r>
                     </a:p>
                   </a:txBody>
@@ -10634,13 +11062,13 @@
                     <a:lstStyle/>
                     <a:p>
                       <a:r>
-                        <a:rPr sz="1150" b="1">
+                        <a:rPr sz="1100" b="1">
                           <a:solidFill>
                             <a:srgbClr val="FFFFFF"/>
                           </a:solidFill>
                           <a:latin typeface="Georgia"/>
                         </a:rPr>
-                        <a:t>Mechanism</a:t>
+                        <a:t>Europe / Nordics (home field)</a:t>
                       </a:r>
                     </a:p>
                   </a:txBody>
@@ -10656,13 +11084,13 @@
                     <a:lstStyle/>
                     <a:p>
                       <a:r>
-                        <a:rPr sz="1150" b="1">
+                        <a:rPr sz="1100" b="1">
                           <a:solidFill>
                             <a:srgbClr val="FFFFFF"/>
                           </a:solidFill>
                           <a:latin typeface="Georgia"/>
                         </a:rPr>
-                        <a:t>What it means for us</a:t>
+                        <a:t>United States</a:t>
                       </a:r>
                     </a:p>
                   </a:txBody>
@@ -10673,20 +11101,20 @@
                   </a:tcPr>
                 </a:tc>
               </a:tr>
-              <a:tr h="713232">
+              <a:tr h="868680">
                 <a:tc>
                   <a:txBody>
                     <a:bodyPr/>
                     <a:lstStyle/>
                     <a:p>
                       <a:r>
-                        <a:rPr sz="1100">
+                        <a:rPr sz="1050">
                           <a:solidFill>
                             <a:srgbClr val="2B3340"/>
                           </a:solidFill>
                           <a:latin typeface="Georgia"/>
                         </a:rPr>
-                        <a:t>Nomination committees</a:t>
+                        <a:t>Path to the board</a:t>
                       </a:r>
                     </a:p>
                   </a:txBody>
@@ -10702,13 +11130,13 @@
                     <a:lstStyle/>
                     <a:p>
                       <a:r>
-                        <a:rPr sz="1100">
+                        <a:rPr sz="1050">
                           <a:solidFill>
                             <a:srgbClr val="2B3340"/>
                           </a:solidFill>
                           <a:latin typeface="Georgia"/>
                         </a:rPr>
-                        <a:t>Board nominations controlled by the largest shareholders (top 3–4 as of Aug/Sep records) — not by the board</a:t>
+                        <a:t>Shareholder-elected nomination committees (Nordics: top 3–4 holders as of Aug/Sep records); sphere engagement; 4–8% wins influence without a proxy fight</a:t>
                       </a:r>
                     </a:p>
                   </a:txBody>
@@ -10724,13 +11152,13 @@
                     <a:lstStyle/>
                     <a:p>
                       <a:r>
-                        <a:rPr sz="1100">
+                        <a:rPr sz="1050">
                           <a:solidFill>
                             <a:srgbClr val="2B3340"/>
                           </a:solidFill>
                           <a:latin typeface="Georgia"/>
                         </a:rPr>
-                        <a:t>A 4–8% stake routinely earns direct influence over board composition — no proxy fight needed</a:t>
+                        <a:t>Universal proxy card (2022) slashed the cost of board challenges; most campaigns settle for seats; 2–6% stakes suffice with a credible slate</a:t>
                       </a:r>
                     </a:p>
                   </a:txBody>
@@ -10741,20 +11169,20 @@
                   </a:tcPr>
                 </a:tc>
               </a:tr>
-              <a:tr h="713232">
+              <a:tr h="868680">
                 <a:tc>
                   <a:txBody>
                     <a:bodyPr/>
                     <a:lstStyle/>
                     <a:p>
                       <a:r>
-                        <a:rPr sz="1100">
+                        <a:rPr sz="1050">
                           <a:solidFill>
                             <a:srgbClr val="2B3340"/>
                           </a:solidFill>
                           <a:latin typeface="Georgia"/>
                         </a:rPr>
-                        <a:t>Low EGM threshold</a:t>
+                        <a:t>Escalation tools</a:t>
                       </a:r>
                     </a:p>
                   </a:txBody>
@@ -10770,13 +11198,13 @@
                     <a:lstStyle/>
                     <a:p>
                       <a:r>
-                        <a:rPr sz="1100">
+                        <a:rPr sz="1050">
                           <a:solidFill>
                             <a:srgbClr val="2B3340"/>
                           </a:solidFill>
                           <a:latin typeface="Georgia"/>
                         </a:rPr>
-                        <a:t>10% of shares can call an extraordinary general meeting (Sweden; similar across the region)</a:t>
+                        <a:t>Low EGM thresholds (10% in Sweden); public shareholder registers enable precise coalition mapping</a:t>
                       </a:r>
                     </a:p>
                   </a:txBody>
@@ -10792,13 +11220,13 @@
                     <a:lstStyle/>
                     <a:p>
                       <a:r>
-                        <a:rPr sz="1100">
+                        <a:rPr sz="1050">
                           <a:solidFill>
                             <a:srgbClr val="2B3340"/>
                           </a:solidFill>
                           <a:latin typeface="Georgia"/>
                         </a:rPr>
-                        <a:t>Credible escalation path that rarely needs to be used</a:t>
+                        <a:t>13D platform; precision proxy contests; settlement negotiation; deep advisor ecosystem</a:t>
                       </a:r>
                     </a:p>
                   </a:txBody>
@@ -10809,20 +11237,20 @@
                   </a:tcPr>
                 </a:tc>
               </a:tr>
-              <a:tr h="713232">
+              <a:tr h="868680">
                 <a:tc>
                   <a:txBody>
                     <a:bodyPr/>
                     <a:lstStyle/>
                     <a:p>
                       <a:r>
-                        <a:rPr sz="1100">
+                        <a:rPr sz="1050">
                           <a:solidFill>
                             <a:srgbClr val="2B3340"/>
                           </a:solidFill>
                           <a:latin typeface="Georgia"/>
                         </a:rPr>
-                        <a:t>Ownership transparency</a:t>
+                        <a:t>Culture &amp; cost</a:t>
                       </a:r>
                     </a:p>
                   </a:txBody>
@@ -10838,13 +11266,13 @@
                     <a:lstStyle/>
                     <a:p>
                       <a:r>
-                        <a:rPr sz="1100">
+                        <a:rPr sz="1050">
                           <a:solidFill>
                             <a:srgbClr val="2B3340"/>
                           </a:solidFill>
                           <a:latin typeface="Georgia"/>
                         </a:rPr>
-                        <a:t>Public shareholder registers (e.g. Euroclear Sweden), frequently updated</a:t>
+                        <a:t>Consensus boards; private argumentation usually sufficient; low campaign cost</a:t>
                       </a:r>
                     </a:p>
                   </a:txBody>
@@ -10860,13 +11288,13 @@
                     <a:lstStyle/>
                     <a:p>
                       <a:r>
-                        <a:rPr sz="1100">
+                        <a:rPr sz="1050">
                           <a:solidFill>
                             <a:srgbClr val="2B3340"/>
                           </a:solidFill>
                           <a:latin typeface="Georgia"/>
                         </a:rPr>
-                        <a:t>Precise coalition mapping before and during campaigns</a:t>
+                        <a:t>Faster, transactional; settlements within 6–12 months; higher cost, higher liquidity</a:t>
                       </a:r>
                     </a:p>
                   </a:txBody>
@@ -10877,20 +11305,20 @@
                   </a:tcPr>
                 </a:tc>
               </a:tr>
-              <a:tr h="713232">
+              <a:tr h="868680">
                 <a:tc>
                   <a:txBody>
                     <a:bodyPr/>
                     <a:lstStyle/>
                     <a:p>
                       <a:r>
-                        <a:rPr sz="1100">
+                        <a:rPr sz="1050">
                           <a:solidFill>
                             <a:srgbClr val="2B3340"/>
                           </a:solidFill>
                           <a:latin typeface="Georgia"/>
                         </a:rPr>
-                        <a:t>Consensus board culture</a:t>
+                        <a:t>Our edge</a:t>
                       </a:r>
                     </a:p>
                   </a:txBody>
@@ -10906,13 +11334,13 @@
                     <a:lstStyle/>
                     <a:p>
                       <a:r>
-                        <a:rPr sz="1100">
+                        <a:rPr sz="1050">
                           <a:solidFill>
                             <a:srgbClr val="2B3340"/>
                           </a:solidFill>
                           <a:latin typeface="Georgia"/>
                         </a:rPr>
-                        <a:t>Boards and ownership spheres respond to well-researched private engagement</a:t>
+                        <a:t>Domestic legitimacy of a 30-year Stockholm-rooted owner; Europe's best director bench; Cevian-validated model, no second practitioner</a:t>
                       </a:r>
                     </a:p>
                   </a:txBody>
@@ -10928,13 +11356,13 @@
                     <a:lstStyle/>
                     <a:p>
                       <a:r>
-                        <a:rPr sz="1100">
+                        <a:rPr sz="1050">
                           <a:solidFill>
                             <a:srgbClr val="2B3340"/>
                           </a:solidFill>
                           <a:latin typeface="Georgia"/>
                         </a:rPr>
-                        <a:t>Lower campaign cost, faster outcomes, brand-compatible conduct</a:t>
+                        <a:t>Sector operating credibility US activists lack; PE-grade separation expertise; campaign leadership hired from the US activist front line</a:t>
                       </a:r>
                     </a:p>
                   </a:txBody>
@@ -10945,74 +11373,6 @@
                   </a:tcPr>
                 </a:tc>
               </a:tr>
-              <a:tr h="713232">
-                <a:tc>
-                  <a:txBody>
-                    <a:bodyPr/>
-                    <a:lstStyle/>
-                    <a:p>
-                      <a:r>
-                        <a:rPr sz="1100">
-                          <a:solidFill>
-                            <a:srgbClr val="2B3340"/>
-                          </a:solidFill>
-                          <a:latin typeface="Georgia"/>
-                        </a:rPr>
-                        <a:t>Spheres &amp; dual-class shares</a:t>
-                      </a:r>
-                    </a:p>
-                  </a:txBody>
-                  <a:tcPr>
-                    <a:solidFill>
-                      <a:srgbClr val="FFFFFF"/>
-                    </a:solidFill>
-                  </a:tcPr>
-                </a:tc>
-                <a:tc>
-                  <a:txBody>
-                    <a:bodyPr/>
-                    <a:lstStyle/>
-                    <a:p>
-                      <a:r>
-                        <a:rPr sz="1100">
-                          <a:solidFill>
-                            <a:srgbClr val="2B3340"/>
-                          </a:solidFill>
-                          <a:latin typeface="Georgia"/>
-                        </a:rPr>
-                        <a:t>Families, foundations and investment companies anchor many issuers</a:t>
-                      </a:r>
-                    </a:p>
-                  </a:txBody>
-                  <a:tcPr>
-                    <a:solidFill>
-                      <a:srgbClr val="FFFFFF"/>
-                    </a:solidFill>
-                  </a:tcPr>
-                </a:tc>
-                <a:tc>
-                  <a:txBody>
-                    <a:bodyPr/>
-                    <a:lstStyle/>
-                    <a:p>
-                      <a:r>
-                        <a:rPr sz="1100">
-                          <a:solidFill>
-                            <a:srgbClr val="2B3340"/>
-                          </a:solidFill>
-                          <a:latin typeface="Georgia"/>
-                        </a:rPr>
-                        <a:t>Screened ex ante; sphere-free mid-caps are exceptionally open to engagement</a:t>
-                      </a:r>
-                    </a:p>
-                  </a:txBody>
-                  <a:tcPr>
-                    <a:solidFill>
-                      <a:srgbClr val="FFFFFF"/>
-                    </a:solidFill>
-                  </a:tcPr>
-                </a:tc>
-              </a:tr>
             </a:tbl>
           </a:graphicData>
         </a:graphic>
@@ -11025,7 +11385,7 @@
         </p:nvSpPr>
         <p:spPr>
           <a:xfrm>
-            <a:off x="502920" y="5257800"/>
+            <a:off x="502920" y="5349240"/>
             <a:ext cx="11247120" cy="914400"/>
           </a:xfrm>
           <a:prstGeom prst="rect">
@@ -11054,7 +11414,7 @@
                 </a:solidFill>
                 <a:latin typeface="Georgia"/>
               </a:rPr>
-              <a:t>Proof of concept: Cevian's two decades of board-seat-driven engagement across the region — and returns in the low-to-mid teens net over cycles — demonstrate the model. Timing discipline: stakes must be built before the Q3 ownership snapshots that seat the following spring's nomination committees.</a:t>
+              <a:t>Same underwriting, same value plans, different influence mechanics. Timing discipline in both: Q3 ownership snapshots seat Nordic nomination committees; US nomination windows gate the proxy season.</a:t>
             </a:r>
           </a:p>
         </p:txBody>
@@ -11760,7 +12120,7 @@
                 </a:solidFill>
                 <a:latin typeface="Georgia"/>
               </a:rPr>
-              <a:t>Domestic legitimacy</a:t>
+              <a:t>Legitimacy + US credibility</a:t>
             </a:r>
           </a:p>
         </p:txBody>
@@ -11802,7 +12162,7 @@
                 </a:solidFill>
                 <a:latin typeface="Georgia"/>
               </a:rPr>
-              <a:t>Institutions, family spheres and governments engage differently with a Stockholm-rooted owner than with a New York or London activist. Lower friction = cheaper, faster, quieter wins.</a:t>
+              <a:t>European spheres and institutions trust a Stockholm-rooted owner; in the US, our New York platform and a campaign team hired from the activist front line give standing European funds never built.</a:t>
             </a:r>
           </a:p>
         </p:txBody>
@@ -11974,7 +12334,7 @@
                 </a:solidFill>
                 <a:latin typeface="Georgia"/>
               </a:rPr>
-              <a:t>Healthcare, tech &amp; payments, financial services, industrials — the listed mid-cap universe is full of businesses we have studied, bid on or competed against.</a:t>
+              <a:t>Healthcare, tech &amp; payments, financial services, industrials — the same lens in Boston, Amsterdam and Stockholm; a universe of businesses we have studied, bid on or competed against.</a:t>
             </a:r>
           </a:p>
         </p:txBody>
@@ -12592,7 +12952,7 @@
                 </a:solidFill>
                 <a:latin typeface="Georgia"/>
               </a:rPr>
-              <a:t>Take 4–10% positions in 6–8 listed Nordic companies (EUR 1–10bn market cap) with ≥30% upside to intrinsic value, and close the gap in 2–4 years through actions the company itself can take — driven from the nomination committee and the boardroom.</a:t>
+              <a:t>Take 2–10% positions in 6–8 listed US and European companies (USD 2–15bn market cap) with ≥30% upside to intrinsic value, and close the gap in 2–4 years through actions the company itself can take — driven from the boardroom under each market's governance regime.</a:t>
             </a:r>
           </a:p>
         </p:txBody>
@@ -12932,7 +13292,7 @@
                 </a:solidFill>
                 <a:latin typeface="Georgia"/>
               </a:rPr>
-              <a:t>4–10% via market + blocks, timed to Q3 ownership snapshots; chair meeting before crossing 5%</a:t>
+              <a:t>2–10% via market + blocks, timed to each market's board calendar; chair meeting before crossing 5%</a:t>
             </a:r>
           </a:p>
         </p:txBody>
@@ -13102,7 +13462,7 @@
                 </a:solidFill>
                 <a:latin typeface="Georgia"/>
               </a:rPr>
-              <a:t>Private value plan to board &amp; anchors; nomination-committee seat; propose 1–2 directors from our bench</a:t>
+              <a:t>Private value plan to board &amp; anchors; EU: nomination-committee seat; US: negotiated refreshment under universal-proxy optionality</a:t>
             </a:r>
           </a:p>
         </p:txBody>
@@ -13990,7 +14350,7 @@
                 </a:solidFill>
                 <a:latin typeface="Georgia"/>
               </a:rPr>
-              <a:t>Examples: Elekta, Getinge</a:t>
+              <a:t>Examples: Elekta, Smith+Nephew</a:t>
             </a:r>
           </a:p>
         </p:txBody>
@@ -14246,7 +14606,7 @@
                 </a:solidFill>
                 <a:latin typeface="Georgia"/>
               </a:rPr>
-              <a:t>Examples: GN Store Nord, Orkla</a:t>
+              <a:t>Examples: Philips, Baxter</a:t>
             </a:r>
           </a:p>
         </p:txBody>
@@ -14502,7 +14862,7 @@
                 </a:solidFill>
                 <a:latin typeface="Georgia"/>
               </a:rPr>
-              <a:t>Example: Tieto (completing its break-up)</a:t>
+              <a:t>Examples: Global Payments, Zimmer Biomet</a:t>
             </a:r>
           </a:p>
         </p:txBody>
@@ -14544,7 +14904,7 @@
                 </a:solidFill>
                 <a:latin typeface="Georgia"/>
               </a:rPr>
-              <a:t>Sector focus mirrors the PE franchise: Healthcare &amp; MedTech 30–40% · Industrials &amp; Business Services 25–35% · Tech, Software &amp; Payments 15–25% · Financial Services 10–20%. Geography: SE ~40–50%, DK ~20–25%, FI ~15–20%, NO ~10–15%.</a:t>
+              <a:t>Sector focus mirrors the PE franchise: Healthcare &amp; MedTech 30–40% · Industrials &amp; Business Services 25–35% · Tech, Software &amp; Payments 15–25% · Financial Services 10–20%. Geography: US 40–50% · Europe 50–60% (of which Nordics 20–30%).</a:t>
             </a:r>
           </a:p>
         </p:txBody>
@@ -14862,7 +15222,7 @@
                 </a:solidFill>
                 <a:latin typeface="Georgia"/>
               </a:rPr>
-              <a:t>~1,400</a:t>
+              <a:t>~1,300</a:t>
             </a:r>
           </a:p>
         </p:txBody>
@@ -14904,7 +15264,7 @@
                 </a:solidFill>
                 <a:latin typeface="Georgia"/>
               </a:rPr>
-              <a:t>Nordic-listed companies</a:t>
+              <a:t>US &amp; European listed names in our four core sectors, USD 2–15bn, post liquidity screens (~55% US / 45% EU)</a:t>
             </a:r>
           </a:p>
         </p:txBody>
@@ -14990,7 +15350,7 @@
                 </a:solidFill>
                 <a:latin typeface="Georgia"/>
               </a:rPr>
-              <a:t>~150</a:t>
+              <a:t>~300</a:t>
             </a:r>
           </a:p>
         </p:txBody>
@@ -15032,7 +15392,7 @@
                 </a:solidFill>
                 <a:latin typeface="Georgia"/>
               </a:rPr>
-              <a:t>EUR 1–10bn market cap, post liquidity screens</a:t>
+              <a:t>Quality screen: defensible position, sound gross margins, clear peer set</a:t>
             </a:r>
           </a:p>
         </p:txBody>
@@ -15118,7 +15478,7 @@
                 </a:solidFill>
                 <a:latin typeface="Georgia"/>
               </a:rPr>
-              <a:t>~60</a:t>
+              <a:t>~80–100</a:t>
             </a:r>
           </a:p>
         </p:txBody>
@@ -15160,7 +15520,7 @@
                 </a:solidFill>
                 <a:latin typeface="Georgia"/>
               </a:rPr>
-              <a:t>Quality screen: defensible position, sound gross margins, clear peer set</a:t>
+              <a:t>Value gap ≥30% on normalised margins or SOTP</a:t>
             </a:r>
           </a:p>
         </p:txBody>
@@ -15246,7 +15606,7 @@
                 </a:solidFill>
                 <a:latin typeface="Georgia"/>
               </a:rPr>
-              <a:t>~25–30</a:t>
+              <a:t>~40</a:t>
             </a:r>
           </a:p>
         </p:txBody>
@@ -15288,7 +15648,7 @@
                 </a:solidFill>
                 <a:latin typeface="Georgia"/>
               </a:rPr>
-              <a:t>Value gap ≥30% on normalised margins or SOTP</a:t>
+              <a:t>Path to influence: open register, no hostile blocker, no defeating defence structures</a:t>
             </a:r>
           </a:p>
         </p:txBody>
@@ -15374,7 +15734,7 @@
                 </a:solidFill>
                 <a:latin typeface="Georgia"/>
               </a:rPr>
-              <a:t>~15–20</a:t>
+              <a:t>12–16</a:t>
             </a:r>
           </a:p>
         </p:txBody>
@@ -15416,7 +15776,7 @@
                 </a:solidFill>
                 <a:latin typeface="Georgia"/>
               </a:rPr>
-              <a:t>Path to influence: register open, no hostile blocking sphere</a:t>
+              <a:t>Live underwritten pipeline (after MNPI / conflicts clearance)</a:t>
             </a:r>
           </a:p>
         </p:txBody>
@@ -15544,7 +15904,7 @@
                 </a:solidFill>
                 <a:latin typeface="Georgia"/>
               </a:rPr>
-              <a:t>Funded positions (after MNPI / conflicts clearance)</a:t>
+              <a:t>Funded core positions</a:t>
             </a:r>
           </a:p>
         </p:txBody>
@@ -15586,7 +15946,7 @@
                 </a:solidFill>
                 <a:latin typeface="Georgia"/>
               </a:rPr>
-              <a:t>EUR 1.5bn across 6–8 cores = EUR 180–280m per position = 4–10% of EUR 2–6bn companies — exactly the band where nomination-committee seats are won and dedicated competition is thinnest.</a:t>
+              <a:t>USD 1.5bn across 6–8 cores = USD 180–280m per position = 4–10% of a USD 3–6bn European mid-cap or 2–5% of a USD 5–15bn US name — influential under both regimes, in the band where competition is thinnest.</a:t>
             </a:r>
           </a:p>
         </p:txBody>
@@ -15948,7 +16308,7 @@
                 </a:solidFill>
                 <a:latin typeface="Georgia"/>
               </a:rPr>
-              <a:t>Elekta  ·  SE  ·  MedTech</a:t>
+              <a:t>Elekta  ·  Sweden  ·  MedTech</a:t>
             </a:r>
           </a:p>
         </p:txBody>
@@ -16074,7 +16434,7 @@
                 </a:solidFill>
                 <a:latin typeface="Georgia"/>
               </a:rPr>
-              <a:t>Value plan: Board-sponsored margin program; order-to-revenue execution reset; service acceleration; strategic optionality. Healthcare is our home turf.</a:t>
+              <a:t>Value plan: Board-sponsored margin program; order-to-revenue execution reset; service acceleration; strategic optionality. Home-field nomination-committee engagement.</a:t>
             </a:r>
           </a:p>
         </p:txBody>
@@ -16204,7 +16564,7 @@
                 </a:solidFill>
                 <a:latin typeface="Georgia"/>
               </a:rPr>
-              <a:t>Getinge  ·  SE  ·  MedTech</a:t>
+              <a:t>Smith+Nephew  ·  UK  ·  MedTech</a:t>
             </a:r>
           </a:p>
         </p:txBody>
@@ -16246,7 +16606,7 @@
                 </a:solidFill>
                 <a:latin typeface="Georgia"/>
               </a:rPr>
-              <a:t>Margin recovery &amp; portfolio focus</a:t>
+              <a:t>Margin gap &amp; structural options</a:t>
             </a:r>
           </a:p>
         </p:txBody>
@@ -16288,7 +16648,7 @@
                 </a:solidFill>
                 <a:latin typeface="Georgia"/>
               </a:rPr>
-              <a:t>Situation: Profitability recovering (profit margin ~6.5% in 2025 vs ~4.7% in 2024) as quality costs roll off, but far below peers; three loosely related business areas invite portfolio review.</a:t>
+              <a:t>Situation: Quality ortho/sports-med/wound franchise lagging peers on margin and execution for years; engagement validated (Cevian on the register since 2024) with the turnaround only partly delivered.</a:t>
             </a:r>
           </a:p>
         </p:txBody>
@@ -16330,7 +16690,7 @@
                 </a:solidFill>
                 <a:latin typeface="Georgia"/>
               </a:rPr>
-              <a:t>Value plan: Complete the quality agenda with board accountability; drive Life Science separation review; normalise margins toward double-digit EBITA.</a:t>
+              <a:t>Value plan: Hold the board to peer-level margins; evaluate separation of underperforming franchises and a US listing review — a second credible engaged owner can be decisive.</a:t>
             </a:r>
           </a:p>
         </p:txBody>
@@ -16460,7 +16820,7 @@
                 </a:solidFill>
                 <a:latin typeface="Georgia"/>
               </a:rPr>
-              <a:t>GN Store Nord  ·  DK  ·  Hearing &amp; Audio</a:t>
+              <a:t>Philips  ·  Netherlands  ·  HealthTech</a:t>
             </a:r>
           </a:p>
         </p:txBody>
@@ -16502,7 +16862,7 @@
                 </a:solidFill>
                 <a:latin typeface="Georgia"/>
               </a:rPr>
-              <a:t>Separation thesis</a:t>
+              <a:t>Recovery &amp; SOTP</a:t>
             </a:r>
           </a:p>
         </p:txBody>
@@ -16544,7 +16904,7 @@
                 </a:solidFill>
                 <a:latin typeface="Georgia"/>
               </a:rPr>
-              <a:t>Situation: Two-business structure (hearing care; enterprise/consumer audio) with limited synergy; separation long debated while leverage suppressed action; register unusually open for a Danish large-cap.</a:t>
+              <a:t>Situation: Emerging from the Respironics recall era (US litigation settled) with margins well below pre-crisis levels and peers; anchor shareholder (Exor) shows the register is open to engaged owners.</a:t>
             </a:r>
           </a:p>
         </p:txBody>
@@ -16586,7 +16946,7 @@
                 </a:solidFill>
                 <a:latin typeface="Georgia"/>
               </a:rPr>
-              <a:t>Value plan: Deleverage milestones, then a formal separation review — both units have natural strategic and sponsor buyers.</a:t>
+              <a:t>Value plan: Margin normalisation with board accountability; portfolio review of Personal Health vs the healthcare core — force the SOTP into the price.</a:t>
             </a:r>
           </a:p>
         </p:txBody>

</xml_diff>

<commit_message>
Add precedents appendix: Cevian record, EQT Public Value, KKR-Henry Schein
Report Appendix A with ~21 Cevian campaigns and outcomes, the EQT
Public Value cautionary case (Storytel et al.), KKR-Henry Schein, and
Triton-Caverion; two matching appendix slides in the deck.

https://claude.ai/code/session_014wJkiGJDWLqynffcMLAwBq
</commit_message>
<xml_diff>
--- a/nordic-capital-activism-pitch/Nordic_Capital_Engaged_Equities_Deck.pptx
+++ b/nordic-capital-activism-pitch/Nordic_Capital_Engaged_Equities_Deck.pptx
@@ -20,6 +20,8 @@
     <p:sldId id="268" r:id="rId19"/>
     <p:sldId id="269" r:id="rId20"/>
     <p:sldId id="270" r:id="rId21"/>
+    <p:sldId id="271" r:id="rId22"/>
+    <p:sldId id="272" r:id="rId23"/>
   </p:sldIdLst>
   <p:sldSz cx="12191695" cy="6858000" type="screen4x3"/>
   <p:notesSz cx="6858000" cy="9144000"/>
@@ -8941,6 +8943,2182 @@
 </p:sld>
 </file>
 
+<file path=ppt/slides/slide16.xml><?xml version="1.0" encoding="utf-8"?>
+<p:sld xmlns:a="http://schemas.openxmlformats.org/drawingml/2006/main" xmlns:p="http://schemas.openxmlformats.org/presentationml/2006/main" xmlns:r="http://schemas.openxmlformats.org/officeDocument/2006/relationships">
+  <p:cSld>
+    <p:spTree>
+      <p:nvGrpSpPr>
+        <p:cNvPr id="1" name=""/>
+        <p:cNvGrpSpPr/>
+        <p:nvPr/>
+      </p:nvGrpSpPr>
+      <p:grpSpPr/>
+      <p:sp>
+        <p:nvSpPr>
+          <p:cNvPr id="2" name="Rectangle 1"/>
+          <p:cNvSpPr/>
+          <p:nvPr/>
+        </p:nvSpPr>
+        <p:spPr>
+          <a:xfrm>
+            <a:off x="0" y="0"/>
+            <a:ext cx="12191695" cy="868680"/>
+          </a:xfrm>
+          <a:prstGeom prst="rect">
+            <a:avLst/>
+          </a:prstGeom>
+          <a:solidFill>
+            <a:srgbClr val="0B2545"/>
+          </a:solidFill>
+          <a:ln>
+            <a:noFill/>
+          </a:ln>
+          <a:effectLst/>
+        </p:spPr>
+        <p:style>
+          <a:lnRef idx="1">
+            <a:schemeClr val="accent1"/>
+          </a:lnRef>
+          <a:fillRef idx="3">
+            <a:schemeClr val="accent1"/>
+          </a:fillRef>
+          <a:effectRef idx="2">
+            <a:schemeClr val="accent1"/>
+          </a:effectRef>
+          <a:fontRef idx="minor">
+            <a:schemeClr val="lt1"/>
+          </a:fontRef>
+        </p:style>
+        <p:txBody>
+          <a:bodyPr rtlCol="0" anchor="ctr"/>
+          <a:lstStyle/>
+          <a:p>
+            <a:pPr algn="ctr"/>
+          </a:p>
+        </p:txBody>
+      </p:sp>
+      <p:sp>
+        <p:nvSpPr>
+          <p:cNvPr id="3" name="Rectangle 2"/>
+          <p:cNvSpPr/>
+          <p:nvPr/>
+        </p:nvSpPr>
+        <p:spPr>
+          <a:xfrm>
+            <a:off x="0" y="868680"/>
+            <a:ext cx="12191695" cy="38100"/>
+          </a:xfrm>
+          <a:prstGeom prst="rect">
+            <a:avLst/>
+          </a:prstGeom>
+          <a:solidFill>
+            <a:srgbClr val="C49A3B"/>
+          </a:solidFill>
+          <a:ln>
+            <a:noFill/>
+          </a:ln>
+          <a:effectLst/>
+        </p:spPr>
+        <p:style>
+          <a:lnRef idx="1">
+            <a:schemeClr val="accent1"/>
+          </a:lnRef>
+          <a:fillRef idx="3">
+            <a:schemeClr val="accent1"/>
+          </a:fillRef>
+          <a:effectRef idx="2">
+            <a:schemeClr val="accent1"/>
+          </a:effectRef>
+          <a:fontRef idx="minor">
+            <a:schemeClr val="lt1"/>
+          </a:fontRef>
+        </p:style>
+        <p:txBody>
+          <a:bodyPr rtlCol="0" anchor="ctr"/>
+          <a:lstStyle/>
+          <a:p>
+            <a:pPr algn="ctr"/>
+          </a:p>
+        </p:txBody>
+      </p:sp>
+      <p:sp>
+        <p:nvSpPr>
+          <p:cNvPr id="4" name="TextBox 3"/>
+          <p:cNvSpPr txBox="1"/>
+          <p:nvPr/>
+        </p:nvSpPr>
+        <p:spPr>
+          <a:xfrm>
+            <a:off x="502920" y="73152"/>
+            <a:ext cx="10058400" cy="274320"/>
+          </a:xfrm>
+          <a:prstGeom prst="rect">
+            <a:avLst/>
+          </a:prstGeom>
+          <a:noFill/>
+        </p:spPr>
+        <p:txBody>
+          <a:bodyPr wrap="square" anchor="t">
+            <a:spAutoFit/>
+          </a:bodyPr>
+          <a:lstStyle/>
+          <a:p>
+            <a:pPr algn="l">
+              <a:lnSpc>
+                <a:spcPct val="100000"/>
+              </a:lnSpc>
+              <a:spcAft>
+                <a:spcPts val="400"/>
+              </a:spcAft>
+            </a:pPr>
+            <a:r>
+              <a:rPr sz="1000" b="1" i="0">
+                <a:solidFill>
+                  <a:srgbClr val="C49A3B"/>
+                </a:solidFill>
+                <a:latin typeface="Georgia"/>
+              </a:rPr>
+              <a:t>APPENDIX</a:t>
+            </a:r>
+          </a:p>
+        </p:txBody>
+      </p:sp>
+      <p:sp>
+        <p:nvSpPr>
+          <p:cNvPr id="5" name="TextBox 4"/>
+          <p:cNvSpPr txBox="1"/>
+          <p:nvPr/>
+        </p:nvSpPr>
+        <p:spPr>
+          <a:xfrm>
+            <a:off x="502920" y="310896"/>
+            <a:ext cx="11155680" cy="548640"/>
+          </a:xfrm>
+          <a:prstGeom prst="rect">
+            <a:avLst/>
+          </a:prstGeom>
+          <a:noFill/>
+        </p:spPr>
+        <p:txBody>
+          <a:bodyPr wrap="square" anchor="t">
+            <a:spAutoFit/>
+          </a:bodyPr>
+          <a:lstStyle/>
+          <a:p>
+            <a:pPr algn="l">
+              <a:lnSpc>
+                <a:spcPct val="100000"/>
+              </a:lnSpc>
+              <a:spcAft>
+                <a:spcPts val="400"/>
+              </a:spcAft>
+            </a:pPr>
+            <a:r>
+              <a:rPr sz="2400" b="1" i="0">
+                <a:solidFill>
+                  <a:srgbClr val="FFFFFF"/>
+                </a:solidFill>
+                <a:latin typeface="Georgia"/>
+              </a:rPr>
+              <a:t>Appendix — Precedents (1/2): Cevian, the constructive model at scale</a:t>
+            </a:r>
+          </a:p>
+        </p:txBody>
+      </p:sp>
+      <p:sp>
+        <p:nvSpPr>
+          <p:cNvPr id="6" name="TextBox 5"/>
+          <p:cNvSpPr txBox="1"/>
+          <p:nvPr/>
+        </p:nvSpPr>
+        <p:spPr>
+          <a:xfrm>
+            <a:off x="502920" y="6510528"/>
+            <a:ext cx="11155680" cy="274320"/>
+          </a:xfrm>
+          <a:prstGeom prst="rect">
+            <a:avLst/>
+          </a:prstGeom>
+          <a:noFill/>
+        </p:spPr>
+        <p:txBody>
+          <a:bodyPr wrap="square" anchor="t">
+            <a:spAutoFit/>
+          </a:bodyPr>
+          <a:lstStyle/>
+          <a:p>
+            <a:pPr algn="l">
+              <a:lnSpc>
+                <a:spcPct val="100000"/>
+              </a:lnSpc>
+              <a:spcAft>
+                <a:spcPts val="400"/>
+              </a:spcAft>
+            </a:pPr>
+            <a:r>
+              <a:rPr sz="800" b="0" i="0">
+                <a:solidFill>
+                  <a:srgbClr val="9AA4B2"/>
+                </a:solidFill>
+                <a:latin typeface="Georgia"/>
+              </a:rPr>
+              <a:t>Strictly private &amp; confidential — illustrative discussion material</a:t>
+            </a:r>
+          </a:p>
+        </p:txBody>
+      </p:sp>
+      <p:graphicFrame>
+        <p:nvGraphicFramePr>
+          <p:cNvPr id="7" name="Table 6"/>
+          <p:cNvGraphicFramePr>
+            <a:graphicFrameLocks noGrp="1"/>
+          </p:cNvGraphicFramePr>
+          <p:nvPr/>
+        </p:nvGraphicFramePr>
+        <p:xfrm>
+          <a:off x="502920" y="1097280"/>
+          <a:ext cx="11247120" cy="4992624"/>
+        </p:xfrm>
+        <a:graphic>
+          <a:graphicData uri="http://schemas.openxmlformats.org/drawingml/2006/table">
+            <a:tbl>
+              <a:tblPr firstRow="1" bandRow="1">
+                <a:tableStyleId>{5C22544A-7EE6-4342-B048-85BDC9FD1C3A}</a:tableStyleId>
+              </a:tblPr>
+              <a:tblGrid>
+                <a:gridCol w="1554480"/>
+                <a:gridCol w="914400"/>
+                <a:gridCol w="7680960"/>
+                <a:gridCol w="1097280"/>
+              </a:tblGrid>
+              <a:tr h="384048">
+                <a:tc>
+                  <a:txBody>
+                    <a:bodyPr/>
+                    <a:lstStyle/>
+                    <a:p>
+                      <a:r>
+                        <a:rPr sz="950" b="1">
+                          <a:solidFill>
+                            <a:srgbClr val="FFFFFF"/>
+                          </a:solidFill>
+                          <a:latin typeface="Georgia"/>
+                        </a:rPr>
+                        <a:t>Campaign</a:t>
+                      </a:r>
+                    </a:p>
+                  </a:txBody>
+                  <a:tcPr>
+                    <a:solidFill>
+                      <a:srgbClr val="0B2545"/>
+                    </a:solidFill>
+                  </a:tcPr>
+                </a:tc>
+                <a:tc>
+                  <a:txBody>
+                    <a:bodyPr/>
+                    <a:lstStyle/>
+                    <a:p>
+                      <a:r>
+                        <a:rPr sz="950" b="1">
+                          <a:solidFill>
+                            <a:srgbClr val="FFFFFF"/>
+                          </a:solidFill>
+                          <a:latin typeface="Georgia"/>
+                        </a:rPr>
+                        <a:t>Period</a:t>
+                      </a:r>
+                    </a:p>
+                  </a:txBody>
+                  <a:tcPr>
+                    <a:solidFill>
+                      <a:srgbClr val="0B2545"/>
+                    </a:solidFill>
+                  </a:tcPr>
+                </a:tc>
+                <a:tc>
+                  <a:txBody>
+                    <a:bodyPr/>
+                    <a:lstStyle/>
+                    <a:p>
+                      <a:r>
+                        <a:rPr sz="950" b="1">
+                          <a:solidFill>
+                            <a:srgbClr val="FFFFFF"/>
+                          </a:solidFill>
+                          <a:latin typeface="Georgia"/>
+                        </a:rPr>
+                        <a:t>What happened</a:t>
+                      </a:r>
+                    </a:p>
+                  </a:txBody>
+                  <a:tcPr>
+                    <a:solidFill>
+                      <a:srgbClr val="0B2545"/>
+                    </a:solidFill>
+                  </a:tcPr>
+                </a:tc>
+                <a:tc>
+                  <a:txBody>
+                    <a:bodyPr/>
+                    <a:lstStyle/>
+                    <a:p>
+                      <a:r>
+                        <a:rPr sz="950" b="1">
+                          <a:solidFill>
+                            <a:srgbClr val="FFFFFF"/>
+                          </a:solidFill>
+                          <a:latin typeface="Georgia"/>
+                        </a:rPr>
+                        <a:t>Result</a:t>
+                      </a:r>
+                    </a:p>
+                  </a:txBody>
+                  <a:tcPr>
+                    <a:solidFill>
+                      <a:srgbClr val="0B2545"/>
+                    </a:solidFill>
+                  </a:tcPr>
+                </a:tc>
+              </a:tr>
+              <a:tr h="384048">
+                <a:tc>
+                  <a:txBody>
+                    <a:bodyPr/>
+                    <a:lstStyle/>
+                    <a:p>
+                      <a:r>
+                        <a:rPr sz="900">
+                          <a:solidFill>
+                            <a:srgbClr val="2B3340"/>
+                          </a:solidFill>
+                          <a:latin typeface="Georgia"/>
+                        </a:rPr>
+                        <a:t>Skandia</a:t>
+                      </a:r>
+                    </a:p>
+                  </a:txBody>
+                  <a:tcPr>
+                    <a:solidFill>
+                      <a:srgbClr val="FFFFFF"/>
+                    </a:solidFill>
+                  </a:tcPr>
+                </a:tc>
+                <a:tc>
+                  <a:txBody>
+                    <a:bodyPr/>
+                    <a:lstStyle/>
+                    <a:p>
+                      <a:r>
+                        <a:rPr sz="900">
+                          <a:solidFill>
+                            <a:srgbClr val="2B3340"/>
+                          </a:solidFill>
+                          <a:latin typeface="Georgia"/>
+                        </a:rPr>
+                        <a:t>2002–06</a:t>
+                      </a:r>
+                    </a:p>
+                  </a:txBody>
+                  <a:tcPr>
+                    <a:solidFill>
+                      <a:srgbClr val="FFFFFF"/>
+                    </a:solidFill>
+                  </a:tcPr>
+                </a:tc>
+                <a:tc>
+                  <a:txBody>
+                    <a:bodyPr/>
+                    <a:lstStyle/>
+                    <a:p>
+                      <a:r>
+                        <a:rPr sz="900">
+                          <a:solidFill>
+                            <a:srgbClr val="2B3340"/>
+                          </a:solidFill>
+                          <a:latin typeface="Georgia"/>
+                        </a:rPr>
+                        <a:t>Governance overhaul, pushed sale; acquired by Old Mutual 2006</a:t>
+                      </a:r>
+                    </a:p>
+                  </a:txBody>
+                  <a:tcPr>
+                    <a:solidFill>
+                      <a:srgbClr val="FFFFFF"/>
+                    </a:solidFill>
+                  </a:tcPr>
+                </a:tc>
+                <a:tc>
+                  <a:txBody>
+                    <a:bodyPr/>
+                    <a:lstStyle/>
+                    <a:p>
+                      <a:r>
+                        <a:rPr sz="900">
+                          <a:solidFill>
+                            <a:srgbClr val="2B3340"/>
+                          </a:solidFill>
+                          <a:latin typeface="Georgia"/>
+                        </a:rPr>
+                        <a:t>Win</a:t>
+                      </a:r>
+                    </a:p>
+                  </a:txBody>
+                  <a:tcPr>
+                    <a:solidFill>
+                      <a:srgbClr val="FFFFFF"/>
+                    </a:solidFill>
+                  </a:tcPr>
+                </a:tc>
+              </a:tr>
+              <a:tr h="384048">
+                <a:tc>
+                  <a:txBody>
+                    <a:bodyPr/>
+                    <a:lstStyle/>
+                    <a:p>
+                      <a:r>
+                        <a:rPr sz="900">
+                          <a:solidFill>
+                            <a:srgbClr val="2B3340"/>
+                          </a:solidFill>
+                          <a:latin typeface="Georgia"/>
+                        </a:rPr>
+                        <a:t>Volvo Group</a:t>
+                      </a:r>
+                    </a:p>
+                  </a:txBody>
+                  <a:tcPr>
+                    <a:solidFill>
+                      <a:srgbClr val="F2F4F8"/>
+                    </a:solidFill>
+                  </a:tcPr>
+                </a:tc>
+                <a:tc>
+                  <a:txBody>
+                    <a:bodyPr/>
+                    <a:lstStyle/>
+                    <a:p>
+                      <a:r>
+                        <a:rPr sz="900">
+                          <a:solidFill>
+                            <a:srgbClr val="2B3340"/>
+                          </a:solidFill>
+                          <a:latin typeface="Georgia"/>
+                        </a:rPr>
+                        <a:t>2006–17</a:t>
+                      </a:r>
+                    </a:p>
+                  </a:txBody>
+                  <a:tcPr>
+                    <a:solidFill>
+                      <a:srgbClr val="F2F4F8"/>
+                    </a:solidFill>
+                  </a:tcPr>
+                </a:tc>
+                <a:tc>
+                  <a:txBody>
+                    <a:bodyPr/>
+                    <a:lstStyle/>
+                    <a:p>
+                      <a:r>
+                        <a:rPr sz="900">
+                          <a:solidFill>
+                            <a:srgbClr val="2B3340"/>
+                          </a:solidFill>
+                          <a:latin typeface="Georgia"/>
+                        </a:rPr>
+                        <a:t>Portfolio focus, cost discipline; stake sold to Geely for ~USD 3.9bn — reported among its most profitable</a:t>
+                      </a:r>
+                    </a:p>
+                  </a:txBody>
+                  <a:tcPr>
+                    <a:solidFill>
+                      <a:srgbClr val="F2F4F8"/>
+                    </a:solidFill>
+                  </a:tcPr>
+                </a:tc>
+                <a:tc>
+                  <a:txBody>
+                    <a:bodyPr/>
+                    <a:lstStyle/>
+                    <a:p>
+                      <a:r>
+                        <a:rPr sz="900">
+                          <a:solidFill>
+                            <a:srgbClr val="2B3340"/>
+                          </a:solidFill>
+                          <a:latin typeface="Georgia"/>
+                        </a:rPr>
+                        <a:t>Win</a:t>
+                      </a:r>
+                    </a:p>
+                  </a:txBody>
+                  <a:tcPr>
+                    <a:solidFill>
+                      <a:srgbClr val="F2F4F8"/>
+                    </a:solidFill>
+                  </a:tcPr>
+                </a:tc>
+              </a:tr>
+              <a:tr h="384048">
+                <a:tc>
+                  <a:txBody>
+                    <a:bodyPr/>
+                    <a:lstStyle/>
+                    <a:p>
+                      <a:r>
+                        <a:rPr sz="900">
+                          <a:solidFill>
+                            <a:srgbClr val="2B3340"/>
+                          </a:solidFill>
+                          <a:latin typeface="Georgia"/>
+                        </a:rPr>
+                        <a:t>Danske Bank</a:t>
+                      </a:r>
+                    </a:p>
+                  </a:txBody>
+                  <a:tcPr>
+                    <a:solidFill>
+                      <a:srgbClr val="FFFFFF"/>
+                    </a:solidFill>
+                  </a:tcPr>
+                </a:tc>
+                <a:tc>
+                  <a:txBody>
+                    <a:bodyPr/>
+                    <a:lstStyle/>
+                    <a:p>
+                      <a:r>
+                        <a:rPr sz="900">
+                          <a:solidFill>
+                            <a:srgbClr val="2B3340"/>
+                          </a:solidFill>
+                          <a:latin typeface="Georgia"/>
+                        </a:rPr>
+                        <a:t>2011–c.15</a:t>
+                      </a:r>
+                    </a:p>
+                  </a:txBody>
+                  <a:tcPr>
+                    <a:solidFill>
+                      <a:srgbClr val="FFFFFF"/>
+                    </a:solidFill>
+                  </a:tcPr>
+                </a:tc>
+                <a:tc>
+                  <a:txBody>
+                    <a:bodyPr/>
+                    <a:lstStyle/>
+                    <a:p>
+                      <a:r>
+                        <a:rPr sz="900">
+                          <a:solidFill>
+                            <a:srgbClr val="2B3340"/>
+                          </a:solidFill>
+                          <a:latin typeface="Georgia"/>
+                        </a:rPr>
+                        <a:t>Post-crisis efficiency &amp; capital agenda; strong recovery into exit</a:t>
+                      </a:r>
+                    </a:p>
+                  </a:txBody>
+                  <a:tcPr>
+                    <a:solidFill>
+                      <a:srgbClr val="FFFFFF"/>
+                    </a:solidFill>
+                  </a:tcPr>
+                </a:tc>
+                <a:tc>
+                  <a:txBody>
+                    <a:bodyPr/>
+                    <a:lstStyle/>
+                    <a:p>
+                      <a:r>
+                        <a:rPr sz="900">
+                          <a:solidFill>
+                            <a:srgbClr val="2B3340"/>
+                          </a:solidFill>
+                          <a:latin typeface="Georgia"/>
+                        </a:rPr>
+                        <a:t>Win</a:t>
+                      </a:r>
+                    </a:p>
+                  </a:txBody>
+                  <a:tcPr>
+                    <a:solidFill>
+                      <a:srgbClr val="FFFFFF"/>
+                    </a:solidFill>
+                  </a:tcPr>
+                </a:tc>
+              </a:tr>
+              <a:tr h="384048">
+                <a:tc>
+                  <a:txBody>
+                    <a:bodyPr/>
+                    <a:lstStyle/>
+                    <a:p>
+                      <a:r>
+                        <a:rPr sz="900">
+                          <a:solidFill>
+                            <a:srgbClr val="2B3340"/>
+                          </a:solidFill>
+                          <a:latin typeface="Georgia"/>
+                        </a:rPr>
+                        <a:t>Bilfinger</a:t>
+                      </a:r>
+                    </a:p>
+                  </a:txBody>
+                  <a:tcPr>
+                    <a:solidFill>
+                      <a:srgbClr val="F2F4F8"/>
+                    </a:solidFill>
+                  </a:tcPr>
+                </a:tc>
+                <a:tc>
+                  <a:txBody>
+                    <a:bodyPr/>
+                    <a:lstStyle/>
+                    <a:p>
+                      <a:r>
+                        <a:rPr sz="900">
+                          <a:solidFill>
+                            <a:srgbClr val="2B3340"/>
+                          </a:solidFill>
+                          <a:latin typeface="Georgia"/>
+                        </a:rPr>
+                        <a:t>2011–c.20</a:t>
+                      </a:r>
+                    </a:p>
+                  </a:txBody>
+                  <a:tcPr>
+                    <a:solidFill>
+                      <a:srgbClr val="F2F4F8"/>
+                    </a:solidFill>
+                  </a:tcPr>
+                </a:tc>
+                <a:tc>
+                  <a:txBody>
+                    <a:bodyPr/>
+                    <a:lstStyle/>
+                    <a:p>
+                      <a:r>
+                        <a:rPr sz="900">
+                          <a:solidFill>
+                            <a:srgbClr val="2B3340"/>
+                          </a:solidFill>
+                          <a:latin typeface="Georgia"/>
+                        </a:rPr>
+                        <a:t>Transformation thesis; profit warnings, CEO churn, a decade for little value</a:t>
+                      </a:r>
+                    </a:p>
+                  </a:txBody>
+                  <a:tcPr>
+                    <a:solidFill>
+                      <a:srgbClr val="F2F4F8"/>
+                    </a:solidFill>
+                  </a:tcPr>
+                </a:tc>
+                <a:tc>
+                  <a:txBody>
+                    <a:bodyPr/>
+                    <a:lstStyle/>
+                    <a:p>
+                      <a:r>
+                        <a:rPr sz="900">
+                          <a:solidFill>
+                            <a:srgbClr val="2B3340"/>
+                          </a:solidFill>
+                          <a:latin typeface="Georgia"/>
+                        </a:rPr>
+                        <a:t>Failure</a:t>
+                      </a:r>
+                    </a:p>
+                  </a:txBody>
+                  <a:tcPr>
+                    <a:solidFill>
+                      <a:srgbClr val="F2F4F8"/>
+                    </a:solidFill>
+                  </a:tcPr>
+                </a:tc>
+              </a:tr>
+              <a:tr h="384048">
+                <a:tc>
+                  <a:txBody>
+                    <a:bodyPr/>
+                    <a:lstStyle/>
+                    <a:p>
+                      <a:r>
+                        <a:rPr sz="900">
+                          <a:solidFill>
+                            <a:srgbClr val="2B3340"/>
+                          </a:solidFill>
+                          <a:latin typeface="Georgia"/>
+                        </a:rPr>
+                        <a:t>ThyssenKrupp</a:t>
+                      </a:r>
+                    </a:p>
+                  </a:txBody>
+                  <a:tcPr>
+                    <a:solidFill>
+                      <a:srgbClr val="FFFFFF"/>
+                    </a:solidFill>
+                  </a:tcPr>
+                </a:tc>
+                <a:tc>
+                  <a:txBody>
+                    <a:bodyPr/>
+                    <a:lstStyle/>
+                    <a:p>
+                      <a:r>
+                        <a:rPr sz="900">
+                          <a:solidFill>
+                            <a:srgbClr val="2B3340"/>
+                          </a:solidFill>
+                          <a:latin typeface="Georgia"/>
+                        </a:rPr>
+                        <a:t>2013–c.22</a:t>
+                      </a:r>
+                    </a:p>
+                  </a:txBody>
+                  <a:tcPr>
+                    <a:solidFill>
+                      <a:srgbClr val="FFFFFF"/>
+                    </a:solidFill>
+                  </a:tcPr>
+                </a:tc>
+                <a:tc>
+                  <a:txBody>
+                    <a:bodyPr/>
+                    <a:lstStyle/>
+                    <a:p>
+                      <a:r>
+                        <a:rPr sz="900">
+                          <a:solidFill>
+                            <a:srgbClr val="2B3340"/>
+                          </a:solidFill>
+                          <a:latin typeface="Georgia"/>
+                        </a:rPr>
+                        <a:t>Break-up thesis; Elevator sale (EUR 17bn) vindicated SOTP but fragile balance sheet destroyed equity en route</a:t>
+                      </a:r>
+                    </a:p>
+                  </a:txBody>
+                  <a:tcPr>
+                    <a:solidFill>
+                      <a:srgbClr val="FFFFFF"/>
+                    </a:solidFill>
+                  </a:tcPr>
+                </a:tc>
+                <a:tc>
+                  <a:txBody>
+                    <a:bodyPr/>
+                    <a:lstStyle/>
+                    <a:p>
+                      <a:r>
+                        <a:rPr sz="900">
+                          <a:solidFill>
+                            <a:srgbClr val="2B3340"/>
+                          </a:solidFill>
+                          <a:latin typeface="Georgia"/>
+                        </a:rPr>
+                        <a:t>Failure</a:t>
+                      </a:r>
+                    </a:p>
+                  </a:txBody>
+                  <a:tcPr>
+                    <a:solidFill>
+                      <a:srgbClr val="FFFFFF"/>
+                    </a:solidFill>
+                  </a:tcPr>
+                </a:tc>
+              </a:tr>
+              <a:tr h="384048">
+                <a:tc>
+                  <a:txBody>
+                    <a:bodyPr/>
+                    <a:lstStyle/>
+                    <a:p>
+                      <a:r>
+                        <a:rPr sz="900">
+                          <a:solidFill>
+                            <a:srgbClr val="2B3340"/>
+                          </a:solidFill>
+                          <a:latin typeface="Georgia"/>
+                        </a:rPr>
+                        <a:t>RSA Insurance</a:t>
+                      </a:r>
+                    </a:p>
+                  </a:txBody>
+                  <a:tcPr>
+                    <a:solidFill>
+                      <a:srgbClr val="F2F4F8"/>
+                    </a:solidFill>
+                  </a:tcPr>
+                </a:tc>
+                <a:tc>
+                  <a:txBody>
+                    <a:bodyPr/>
+                    <a:lstStyle/>
+                    <a:p>
+                      <a:r>
+                        <a:rPr sz="900">
+                          <a:solidFill>
+                            <a:srgbClr val="2B3340"/>
+                          </a:solidFill>
+                          <a:latin typeface="Georgia"/>
+                        </a:rPr>
+                        <a:t>2013–21</a:t>
+                      </a:r>
+                    </a:p>
+                  </a:txBody>
+                  <a:tcPr>
+                    <a:solidFill>
+                      <a:srgbClr val="F2F4F8"/>
+                    </a:solidFill>
+                  </a:tcPr>
+                </a:tc>
+                <a:tc>
+                  <a:txBody>
+                    <a:bodyPr/>
+                    <a:lstStyle/>
+                    <a:p>
+                      <a:r>
+                        <a:rPr sz="900">
+                          <a:solidFill>
+                            <a:srgbClr val="2B3340"/>
+                          </a:solidFill>
+                          <a:latin typeface="Georgia"/>
+                        </a:rPr>
+                        <a:t>Focus &amp; disposals, then sale; Intact/Tryg takeover at ~50% premium</a:t>
+                      </a:r>
+                    </a:p>
+                  </a:txBody>
+                  <a:tcPr>
+                    <a:solidFill>
+                      <a:srgbClr val="F2F4F8"/>
+                    </a:solidFill>
+                  </a:tcPr>
+                </a:tc>
+                <a:tc>
+                  <a:txBody>
+                    <a:bodyPr/>
+                    <a:lstStyle/>
+                    <a:p>
+                      <a:r>
+                        <a:rPr sz="900">
+                          <a:solidFill>
+                            <a:srgbClr val="2B3340"/>
+                          </a:solidFill>
+                          <a:latin typeface="Georgia"/>
+                        </a:rPr>
+                        <a:t>Win</a:t>
+                      </a:r>
+                    </a:p>
+                  </a:txBody>
+                  <a:tcPr>
+                    <a:solidFill>
+                      <a:srgbClr val="F2F4F8"/>
+                    </a:solidFill>
+                  </a:tcPr>
+                </a:tc>
+              </a:tr>
+              <a:tr h="384048">
+                <a:tc>
+                  <a:txBody>
+                    <a:bodyPr/>
+                    <a:lstStyle/>
+                    <a:p>
+                      <a:r>
+                        <a:rPr sz="900">
+                          <a:solidFill>
+                            <a:srgbClr val="2B3340"/>
+                          </a:solidFill>
+                          <a:latin typeface="Georgia"/>
+                        </a:rPr>
+                        <a:t>ABB</a:t>
+                      </a:r>
+                    </a:p>
+                  </a:txBody>
+                  <a:tcPr>
+                    <a:solidFill>
+                      <a:srgbClr val="FFFFFF"/>
+                    </a:solidFill>
+                  </a:tcPr>
+                </a:tc>
+                <a:tc>
+                  <a:txBody>
+                    <a:bodyPr/>
+                    <a:lstStyle/>
+                    <a:p>
+                      <a:r>
+                        <a:rPr sz="900">
+                          <a:solidFill>
+                            <a:srgbClr val="2B3340"/>
+                          </a:solidFill>
+                          <a:latin typeface="Georgia"/>
+                        </a:rPr>
+                        <a:t>2015–c.22</a:t>
+                      </a:r>
+                    </a:p>
+                  </a:txBody>
+                  <a:tcPr>
+                    <a:solidFill>
+                      <a:srgbClr val="FFFFFF"/>
+                    </a:solidFill>
+                  </a:tcPr>
+                </a:tc>
+                <a:tc>
+                  <a:txBody>
+                    <a:bodyPr/>
+                    <a:lstStyle/>
+                    <a:p>
+                      <a:r>
+                        <a:rPr sz="900">
+                          <a:solidFill>
+                            <a:srgbClr val="2B3340"/>
+                          </a:solidFill>
+                          <a:latin typeface="Georgia"/>
+                        </a:rPr>
+                        <a:t>Power Grids exit to Hitachi, decentralisation, buybacks; solid re-rating over a long hold</a:t>
+                      </a:r>
+                    </a:p>
+                  </a:txBody>
+                  <a:tcPr>
+                    <a:solidFill>
+                      <a:srgbClr val="FFFFFF"/>
+                    </a:solidFill>
+                  </a:tcPr>
+                </a:tc>
+                <a:tc>
+                  <a:txBody>
+                    <a:bodyPr/>
+                    <a:lstStyle/>
+                    <a:p>
+                      <a:r>
+                        <a:rPr sz="900">
+                          <a:solidFill>
+                            <a:srgbClr val="2B3340"/>
+                          </a:solidFill>
+                          <a:latin typeface="Georgia"/>
+                        </a:rPr>
+                        <a:t>Win</a:t>
+                      </a:r>
+                    </a:p>
+                  </a:txBody>
+                  <a:tcPr>
+                    <a:solidFill>
+                      <a:srgbClr val="FFFFFF"/>
+                    </a:solidFill>
+                  </a:tcPr>
+                </a:tc>
+              </a:tr>
+              <a:tr h="384048">
+                <a:tc>
+                  <a:txBody>
+                    <a:bodyPr/>
+                    <a:lstStyle/>
+                    <a:p>
+                      <a:r>
+                        <a:rPr sz="900">
+                          <a:solidFill>
+                            <a:srgbClr val="2B3340"/>
+                          </a:solidFill>
+                          <a:latin typeface="Georgia"/>
+                        </a:rPr>
+                        <a:t>Ericsson</a:t>
+                      </a:r>
+                    </a:p>
+                  </a:txBody>
+                  <a:tcPr>
+                    <a:solidFill>
+                      <a:srgbClr val="F2F4F8"/>
+                    </a:solidFill>
+                  </a:tcPr>
+                </a:tc>
+                <a:tc>
+                  <a:txBody>
+                    <a:bodyPr/>
+                    <a:lstStyle/>
+                    <a:p>
+                      <a:r>
+                        <a:rPr sz="900">
+                          <a:solidFill>
+                            <a:srgbClr val="2B3340"/>
+                          </a:solidFill>
+                          <a:latin typeface="Georgia"/>
+                        </a:rPr>
+                        <a:t>2017–c.23</a:t>
+                      </a:r>
+                    </a:p>
+                  </a:txBody>
+                  <a:tcPr>
+                    <a:solidFill>
+                      <a:srgbClr val="F2F4F8"/>
+                    </a:solidFill>
+                  </a:tcPr>
+                </a:tc>
+                <a:tc>
+                  <a:txBody>
+                    <a:bodyPr/>
+                    <a:lstStyle/>
+                    <a:p>
+                      <a:r>
+                        <a:rPr sz="900">
+                          <a:solidFill>
+                            <a:srgbClr val="2B3340"/>
+                          </a:solidFill>
+                          <a:latin typeface="Georgia"/>
+                        </a:rPr>
+                        <a:t>Chair change, cost focus; doubled into 2021, compliance issues gave much back</a:t>
+                      </a:r>
+                    </a:p>
+                  </a:txBody>
+                  <a:tcPr>
+                    <a:solidFill>
+                      <a:srgbClr val="F2F4F8"/>
+                    </a:solidFill>
+                  </a:tcPr>
+                </a:tc>
+                <a:tc>
+                  <a:txBody>
+                    <a:bodyPr/>
+                    <a:lstStyle/>
+                    <a:p>
+                      <a:r>
+                        <a:rPr sz="900">
+                          <a:solidFill>
+                            <a:srgbClr val="2B3340"/>
+                          </a:solidFill>
+                          <a:latin typeface="Georgia"/>
+                        </a:rPr>
+                        <a:t>Mixed+</a:t>
+                      </a:r>
+                    </a:p>
+                  </a:txBody>
+                  <a:tcPr>
+                    <a:solidFill>
+                      <a:srgbClr val="F2F4F8"/>
+                    </a:solidFill>
+                  </a:tcPr>
+                </a:tc>
+              </a:tr>
+              <a:tr h="384048">
+                <a:tc>
+                  <a:txBody>
+                    <a:bodyPr/>
+                    <a:lstStyle/>
+                    <a:p>
+                      <a:r>
+                        <a:rPr sz="900">
+                          <a:solidFill>
+                            <a:srgbClr val="2B3340"/>
+                          </a:solidFill>
+                          <a:latin typeface="Georgia"/>
+                        </a:rPr>
+                        <a:t>Panalpina</a:t>
+                      </a:r>
+                    </a:p>
+                  </a:txBody>
+                  <a:tcPr>
+                    <a:solidFill>
+                      <a:srgbClr val="FFFFFF"/>
+                    </a:solidFill>
+                  </a:tcPr>
+                </a:tc>
+                <a:tc>
+                  <a:txBody>
+                    <a:bodyPr/>
+                    <a:lstStyle/>
+                    <a:p>
+                      <a:r>
+                        <a:rPr sz="900">
+                          <a:solidFill>
+                            <a:srgbClr val="2B3340"/>
+                          </a:solidFill>
+                          <a:latin typeface="Georgia"/>
+                        </a:rPr>
+                        <a:t>2018–19</a:t>
+                      </a:r>
+                    </a:p>
+                  </a:txBody>
+                  <a:tcPr>
+                    <a:solidFill>
+                      <a:srgbClr val="FFFFFF"/>
+                    </a:solidFill>
+                  </a:tcPr>
+                </a:tc>
+                <a:tc>
+                  <a:txBody>
+                    <a:bodyPr/>
+                    <a:lstStyle/>
+                    <a:p>
+                      <a:r>
+                        <a:rPr sz="900">
+                          <a:solidFill>
+                            <a:srgbClr val="2B3340"/>
+                          </a:solidFill>
+                          <a:latin typeface="Georgia"/>
+                        </a:rPr>
+                        <a:t>Pushed sale; DSV takeover at a substantial premium within ~18 months</a:t>
+                      </a:r>
+                    </a:p>
+                  </a:txBody>
+                  <a:tcPr>
+                    <a:solidFill>
+                      <a:srgbClr val="FFFFFF"/>
+                    </a:solidFill>
+                  </a:tcPr>
+                </a:tc>
+                <a:tc>
+                  <a:txBody>
+                    <a:bodyPr/>
+                    <a:lstStyle/>
+                    <a:p>
+                      <a:r>
+                        <a:rPr sz="900">
+                          <a:solidFill>
+                            <a:srgbClr val="2B3340"/>
+                          </a:solidFill>
+                          <a:latin typeface="Georgia"/>
+                        </a:rPr>
+                        <a:t>Win</a:t>
+                      </a:r>
+                    </a:p>
+                  </a:txBody>
+                  <a:tcPr>
+                    <a:solidFill>
+                      <a:srgbClr val="FFFFFF"/>
+                    </a:solidFill>
+                  </a:tcPr>
+                </a:tc>
+              </a:tr>
+              <a:tr h="384048">
+                <a:tc>
+                  <a:txBody>
+                    <a:bodyPr/>
+                    <a:lstStyle/>
+                    <a:p>
+                      <a:r>
+                        <a:rPr sz="900">
+                          <a:solidFill>
+                            <a:srgbClr val="2B3340"/>
+                          </a:solidFill>
+                          <a:latin typeface="Georgia"/>
+                        </a:rPr>
+                        <a:t>Aviva</a:t>
+                      </a:r>
+                    </a:p>
+                  </a:txBody>
+                  <a:tcPr>
+                    <a:solidFill>
+                      <a:srgbClr val="F2F4F8"/>
+                    </a:solidFill>
+                  </a:tcPr>
+                </a:tc>
+                <a:tc>
+                  <a:txBody>
+                    <a:bodyPr/>
+                    <a:lstStyle/>
+                    <a:p>
+                      <a:r>
+                        <a:rPr sz="900">
+                          <a:solidFill>
+                            <a:srgbClr val="2B3340"/>
+                          </a:solidFill>
+                          <a:latin typeface="Georgia"/>
+                        </a:rPr>
+                        <a:t>2021–c.24</a:t>
+                      </a:r>
+                    </a:p>
+                  </a:txBody>
+                  <a:tcPr>
+                    <a:solidFill>
+                      <a:srgbClr val="F2F4F8"/>
+                    </a:solidFill>
+                  </a:tcPr>
+                </a:tc>
+                <a:tc>
+                  <a:txBody>
+                    <a:bodyPr/>
+                    <a:lstStyle/>
+                    <a:p>
+                      <a:r>
+                        <a:rPr sz="900">
+                          <a:solidFill>
+                            <a:srgbClr val="2B3340"/>
+                          </a:solidFill>
+                          <a:latin typeface="Georgia"/>
+                        </a:rPr>
+                        <a:t>Demanded ~GBP 5bn capital return; delivered, re-rated</a:t>
+                      </a:r>
+                    </a:p>
+                  </a:txBody>
+                  <a:tcPr>
+                    <a:solidFill>
+                      <a:srgbClr val="F2F4F8"/>
+                    </a:solidFill>
+                  </a:tcPr>
+                </a:tc>
+                <a:tc>
+                  <a:txBody>
+                    <a:bodyPr/>
+                    <a:lstStyle/>
+                    <a:p>
+                      <a:r>
+                        <a:rPr sz="900">
+                          <a:solidFill>
+                            <a:srgbClr val="2B3340"/>
+                          </a:solidFill>
+                          <a:latin typeface="Georgia"/>
+                        </a:rPr>
+                        <a:t>Win</a:t>
+                      </a:r>
+                    </a:p>
+                  </a:txBody>
+                  <a:tcPr>
+                    <a:solidFill>
+                      <a:srgbClr val="F2F4F8"/>
+                    </a:solidFill>
+                  </a:tcPr>
+                </a:tc>
+              </a:tr>
+              <a:tr h="384048">
+                <a:tc>
+                  <a:txBody>
+                    <a:bodyPr/>
+                    <a:lstStyle/>
+                    <a:p>
+                      <a:r>
+                        <a:rPr sz="900">
+                          <a:solidFill>
+                            <a:srgbClr val="2B3340"/>
+                          </a:solidFill>
+                          <a:latin typeface="Georgia"/>
+                        </a:rPr>
+                        <a:t>UBS</a:t>
+                      </a:r>
+                    </a:p>
+                  </a:txBody>
+                  <a:tcPr>
+                    <a:solidFill>
+                      <a:srgbClr val="FFFFFF"/>
+                    </a:solidFill>
+                  </a:tcPr>
+                </a:tc>
+                <a:tc>
+                  <a:txBody>
+                    <a:bodyPr/>
+                    <a:lstStyle/>
+                    <a:p>
+                      <a:r>
+                        <a:rPr sz="900">
+                          <a:solidFill>
+                            <a:srgbClr val="2B3340"/>
+                          </a:solidFill>
+                          <a:latin typeface="Georgia"/>
+                        </a:rPr>
+                        <a:t>2023–25</a:t>
+                      </a:r>
+                    </a:p>
+                  </a:txBody>
+                  <a:tcPr>
+                    <a:solidFill>
+                      <a:srgbClr val="FFFFFF"/>
+                    </a:solidFill>
+                  </a:tcPr>
+                </a:tc>
+                <a:tc>
+                  <a:txBody>
+                    <a:bodyPr/>
+                    <a:lstStyle/>
+                    <a:p>
+                      <a:r>
+                        <a:rPr sz="900">
+                          <a:solidFill>
+                            <a:srgbClr val="2B3340"/>
+                          </a:solidFill>
+                          <a:latin typeface="Georgia"/>
+                        </a:rPr>
+                        <a:t>Post-CS re-rating bet; reported ~2x on early tranches at 2025 sales</a:t>
+                      </a:r>
+                    </a:p>
+                  </a:txBody>
+                  <a:tcPr>
+                    <a:solidFill>
+                      <a:srgbClr val="FFFFFF"/>
+                    </a:solidFill>
+                  </a:tcPr>
+                </a:tc>
+                <a:tc>
+                  <a:txBody>
+                    <a:bodyPr/>
+                    <a:lstStyle/>
+                    <a:p>
+                      <a:r>
+                        <a:rPr sz="900">
+                          <a:solidFill>
+                            <a:srgbClr val="2B3340"/>
+                          </a:solidFill>
+                          <a:latin typeface="Georgia"/>
+                        </a:rPr>
+                        <a:t>Win</a:t>
+                      </a:r>
+                    </a:p>
+                  </a:txBody>
+                  <a:tcPr>
+                    <a:solidFill>
+                      <a:srgbClr val="FFFFFF"/>
+                    </a:solidFill>
+                  </a:tcPr>
+                </a:tc>
+              </a:tr>
+              <a:tr h="384048">
+                <a:tc>
+                  <a:txBody>
+                    <a:bodyPr/>
+                    <a:lstStyle/>
+                    <a:p>
+                      <a:r>
+                        <a:rPr sz="900">
+                          <a:solidFill>
+                            <a:srgbClr val="2B3340"/>
+                          </a:solidFill>
+                          <a:latin typeface="Georgia"/>
+                        </a:rPr>
+                        <a:t>Baloise</a:t>
+                      </a:r>
+                    </a:p>
+                  </a:txBody>
+                  <a:tcPr>
+                    <a:solidFill>
+                      <a:srgbClr val="F2F4F8"/>
+                    </a:solidFill>
+                  </a:tcPr>
+                </a:tc>
+                <a:tc>
+                  <a:txBody>
+                    <a:bodyPr/>
+                    <a:lstStyle/>
+                    <a:p>
+                      <a:r>
+                        <a:rPr sz="900">
+                          <a:solidFill>
+                            <a:srgbClr val="2B3340"/>
+                          </a:solidFill>
+                          <a:latin typeface="Georgia"/>
+                        </a:rPr>
+                        <a:t>2023–25</a:t>
+                      </a:r>
+                    </a:p>
+                  </a:txBody>
+                  <a:tcPr>
+                    <a:solidFill>
+                      <a:srgbClr val="F2F4F8"/>
+                    </a:solidFill>
+                  </a:tcPr>
+                </a:tc>
+                <a:tc>
+                  <a:txBody>
+                    <a:bodyPr/>
+                    <a:lstStyle/>
+                    <a:p>
+                      <a:r>
+                        <a:rPr sz="900">
+                          <a:solidFill>
+                            <a:srgbClr val="2B3340"/>
+                          </a:solidFill>
+                          <a:latin typeface="Georgia"/>
+                        </a:rPr>
+                        <a:t>Strategy reset, vote caps removed; Helvetia merger 2025; sold ~CHF 184 vs ~CHF 130 entry (~+40%)</a:t>
+                      </a:r>
+                    </a:p>
+                  </a:txBody>
+                  <a:tcPr>
+                    <a:solidFill>
+                      <a:srgbClr val="F2F4F8"/>
+                    </a:solidFill>
+                  </a:tcPr>
+                </a:tc>
+                <a:tc>
+                  <a:txBody>
+                    <a:bodyPr/>
+                    <a:lstStyle/>
+                    <a:p>
+                      <a:r>
+                        <a:rPr sz="900">
+                          <a:solidFill>
+                            <a:srgbClr val="2B3340"/>
+                          </a:solidFill>
+                          <a:latin typeface="Georgia"/>
+                        </a:rPr>
+                        <a:t>Win</a:t>
+                      </a:r>
+                    </a:p>
+                  </a:txBody>
+                  <a:tcPr>
+                    <a:solidFill>
+                      <a:srgbClr val="F2F4F8"/>
+                    </a:solidFill>
+                  </a:tcPr>
+                </a:tc>
+              </a:tr>
+            </a:tbl>
+          </a:graphicData>
+        </a:graphic>
+      </p:graphicFrame>
+      <p:sp>
+        <p:nvSpPr>
+          <p:cNvPr id="8" name="TextBox 7"/>
+          <p:cNvSpPr txBox="1"/>
+          <p:nvPr/>
+        </p:nvSpPr>
+        <p:spPr>
+          <a:xfrm>
+            <a:off x="502920" y="6126480"/>
+            <a:ext cx="11247120" cy="365760"/>
+          </a:xfrm>
+          <a:prstGeom prst="rect">
+            <a:avLst/>
+          </a:prstGeom>
+          <a:noFill/>
+        </p:spPr>
+        <p:txBody>
+          <a:bodyPr wrap="square" anchor="t">
+            <a:spAutoFit/>
+          </a:bodyPr>
+          <a:lstStyle/>
+          <a:p>
+            <a:pPr algn="l">
+              <a:lnSpc>
+                <a:spcPct val="105000"/>
+              </a:lnSpc>
+              <a:spcAft>
+                <a:spcPts val="400"/>
+              </a:spcAft>
+            </a:pPr>
+            <a:r>
+              <a:rPr sz="1000" b="0" i="1">
+                <a:solidFill>
+                  <a:srgbClr val="555F6E"/>
+                </a:solidFill>
+                <a:latin typeface="Georgia"/>
+              </a:rPr>
+              <a:t>Also: Tieto, Cookson/Vesuvius–Alent, Metso, Wolseley/Ferguson, Autoliv/Veoneer, Nordea, Pearson (wins/modest wins); Vodafone (failure); Smith+Nephew (ongoing). ~3 clear failures in ~20 campaigns; reported low-to-mid-teens net annualised since 2002. Wins cluster where a transaction crystallised value — our M&amp;A archetype.</a:t>
+            </a:r>
+          </a:p>
+        </p:txBody>
+      </p:sp>
+    </p:spTree>
+  </p:cSld>
+  <p:clrMapOvr>
+    <a:masterClrMapping/>
+  </p:clrMapOvr>
+</p:sld>
+</file>
+
+<file path=ppt/slides/slide17.xml><?xml version="1.0" encoding="utf-8"?>
+<p:sld xmlns:a="http://schemas.openxmlformats.org/drawingml/2006/main" xmlns:p="http://schemas.openxmlformats.org/presentationml/2006/main" xmlns:r="http://schemas.openxmlformats.org/officeDocument/2006/relationships">
+  <p:cSld>
+    <p:spTree>
+      <p:nvGrpSpPr>
+        <p:cNvPr id="1" name=""/>
+        <p:cNvGrpSpPr/>
+        <p:nvPr/>
+      </p:nvGrpSpPr>
+      <p:grpSpPr/>
+      <p:sp>
+        <p:nvSpPr>
+          <p:cNvPr id="2" name="Rectangle 1"/>
+          <p:cNvSpPr/>
+          <p:nvPr/>
+        </p:nvSpPr>
+        <p:spPr>
+          <a:xfrm>
+            <a:off x="0" y="0"/>
+            <a:ext cx="12191695" cy="868680"/>
+          </a:xfrm>
+          <a:prstGeom prst="rect">
+            <a:avLst/>
+          </a:prstGeom>
+          <a:solidFill>
+            <a:srgbClr val="0B2545"/>
+          </a:solidFill>
+          <a:ln>
+            <a:noFill/>
+          </a:ln>
+          <a:effectLst/>
+        </p:spPr>
+        <p:style>
+          <a:lnRef idx="1">
+            <a:schemeClr val="accent1"/>
+          </a:lnRef>
+          <a:fillRef idx="3">
+            <a:schemeClr val="accent1"/>
+          </a:fillRef>
+          <a:effectRef idx="2">
+            <a:schemeClr val="accent1"/>
+          </a:effectRef>
+          <a:fontRef idx="minor">
+            <a:schemeClr val="lt1"/>
+          </a:fontRef>
+        </p:style>
+        <p:txBody>
+          <a:bodyPr rtlCol="0" anchor="ctr"/>
+          <a:lstStyle/>
+          <a:p>
+            <a:pPr algn="ctr"/>
+          </a:p>
+        </p:txBody>
+      </p:sp>
+      <p:sp>
+        <p:nvSpPr>
+          <p:cNvPr id="3" name="Rectangle 2"/>
+          <p:cNvSpPr/>
+          <p:nvPr/>
+        </p:nvSpPr>
+        <p:spPr>
+          <a:xfrm>
+            <a:off x="0" y="868680"/>
+            <a:ext cx="12191695" cy="38100"/>
+          </a:xfrm>
+          <a:prstGeom prst="rect">
+            <a:avLst/>
+          </a:prstGeom>
+          <a:solidFill>
+            <a:srgbClr val="C49A3B"/>
+          </a:solidFill>
+          <a:ln>
+            <a:noFill/>
+          </a:ln>
+          <a:effectLst/>
+        </p:spPr>
+        <p:style>
+          <a:lnRef idx="1">
+            <a:schemeClr val="accent1"/>
+          </a:lnRef>
+          <a:fillRef idx="3">
+            <a:schemeClr val="accent1"/>
+          </a:fillRef>
+          <a:effectRef idx="2">
+            <a:schemeClr val="accent1"/>
+          </a:effectRef>
+          <a:fontRef idx="minor">
+            <a:schemeClr val="lt1"/>
+          </a:fontRef>
+        </p:style>
+        <p:txBody>
+          <a:bodyPr rtlCol="0" anchor="ctr"/>
+          <a:lstStyle/>
+          <a:p>
+            <a:pPr algn="ctr"/>
+          </a:p>
+        </p:txBody>
+      </p:sp>
+      <p:sp>
+        <p:nvSpPr>
+          <p:cNvPr id="4" name="TextBox 3"/>
+          <p:cNvSpPr txBox="1"/>
+          <p:nvPr/>
+        </p:nvSpPr>
+        <p:spPr>
+          <a:xfrm>
+            <a:off x="502920" y="73152"/>
+            <a:ext cx="10058400" cy="274320"/>
+          </a:xfrm>
+          <a:prstGeom prst="rect">
+            <a:avLst/>
+          </a:prstGeom>
+          <a:noFill/>
+        </p:spPr>
+        <p:txBody>
+          <a:bodyPr wrap="square" anchor="t">
+            <a:spAutoFit/>
+          </a:bodyPr>
+          <a:lstStyle/>
+          <a:p>
+            <a:pPr algn="l">
+              <a:lnSpc>
+                <a:spcPct val="100000"/>
+              </a:lnSpc>
+              <a:spcAft>
+                <a:spcPts val="400"/>
+              </a:spcAft>
+            </a:pPr>
+            <a:r>
+              <a:rPr sz="1000" b="1" i="0">
+                <a:solidFill>
+                  <a:srgbClr val="C49A3B"/>
+                </a:solidFill>
+                <a:latin typeface="Georgia"/>
+              </a:rPr>
+              <a:t>APPENDIX</a:t>
+            </a:r>
+          </a:p>
+        </p:txBody>
+      </p:sp>
+      <p:sp>
+        <p:nvSpPr>
+          <p:cNvPr id="5" name="TextBox 4"/>
+          <p:cNvSpPr txBox="1"/>
+          <p:nvPr/>
+        </p:nvSpPr>
+        <p:spPr>
+          <a:xfrm>
+            <a:off x="502920" y="310896"/>
+            <a:ext cx="11155680" cy="548640"/>
+          </a:xfrm>
+          <a:prstGeom prst="rect">
+            <a:avLst/>
+          </a:prstGeom>
+          <a:noFill/>
+        </p:spPr>
+        <p:txBody>
+          <a:bodyPr wrap="square" anchor="t">
+            <a:spAutoFit/>
+          </a:bodyPr>
+          <a:lstStyle/>
+          <a:p>
+            <a:pPr algn="l">
+              <a:lnSpc>
+                <a:spcPct val="100000"/>
+              </a:lnSpc>
+              <a:spcAft>
+                <a:spcPts val="400"/>
+              </a:spcAft>
+            </a:pPr>
+            <a:r>
+              <a:rPr sz="2400" b="1" i="0">
+                <a:solidFill>
+                  <a:srgbClr val="FFFFFF"/>
+                </a:solidFill>
+                <a:latin typeface="Georgia"/>
+              </a:rPr>
+              <a:t>Appendix — Precedents (2/2): sponsors in public markets</a:t>
+            </a:r>
+          </a:p>
+        </p:txBody>
+      </p:sp>
+      <p:sp>
+        <p:nvSpPr>
+          <p:cNvPr id="6" name="TextBox 5"/>
+          <p:cNvSpPr txBox="1"/>
+          <p:nvPr/>
+        </p:nvSpPr>
+        <p:spPr>
+          <a:xfrm>
+            <a:off x="502920" y="6510528"/>
+            <a:ext cx="11155680" cy="274320"/>
+          </a:xfrm>
+          <a:prstGeom prst="rect">
+            <a:avLst/>
+          </a:prstGeom>
+          <a:noFill/>
+        </p:spPr>
+        <p:txBody>
+          <a:bodyPr wrap="square" anchor="t">
+            <a:spAutoFit/>
+          </a:bodyPr>
+          <a:lstStyle/>
+          <a:p>
+            <a:pPr algn="l">
+              <a:lnSpc>
+                <a:spcPct val="100000"/>
+              </a:lnSpc>
+              <a:spcAft>
+                <a:spcPts val="400"/>
+              </a:spcAft>
+            </a:pPr>
+            <a:r>
+              <a:rPr sz="800" b="0" i="0">
+                <a:solidFill>
+                  <a:srgbClr val="9AA4B2"/>
+                </a:solidFill>
+                <a:latin typeface="Georgia"/>
+              </a:rPr>
+              <a:t>Strictly private &amp; confidential — illustrative discussion material</a:t>
+            </a:r>
+          </a:p>
+        </p:txBody>
+      </p:sp>
+      <p:sp>
+        <p:nvSpPr>
+          <p:cNvPr id="7" name="Rectangle 6"/>
+          <p:cNvSpPr/>
+          <p:nvPr/>
+        </p:nvSpPr>
+        <p:spPr>
+          <a:xfrm>
+            <a:off x="502920" y="1143000"/>
+            <a:ext cx="5577840" cy="2651760"/>
+          </a:xfrm>
+          <a:prstGeom prst="rect">
+            <a:avLst/>
+          </a:prstGeom>
+          <a:solidFill>
+            <a:srgbClr val="F2F4F8"/>
+          </a:solidFill>
+          <a:ln>
+            <a:noFill/>
+          </a:ln>
+          <a:effectLst/>
+        </p:spPr>
+        <p:style>
+          <a:lnRef idx="1">
+            <a:schemeClr val="accent1"/>
+          </a:lnRef>
+          <a:fillRef idx="3">
+            <a:schemeClr val="accent1"/>
+          </a:fillRef>
+          <a:effectRef idx="2">
+            <a:schemeClr val="accent1"/>
+          </a:effectRef>
+          <a:fontRef idx="minor">
+            <a:schemeClr val="lt1"/>
+          </a:fontRef>
+        </p:style>
+        <p:txBody>
+          <a:bodyPr rtlCol="0" anchor="ctr"/>
+          <a:lstStyle/>
+          <a:p>
+            <a:pPr algn="ctr"/>
+          </a:p>
+        </p:txBody>
+      </p:sp>
+      <p:sp>
+        <p:nvSpPr>
+          <p:cNvPr id="8" name="Rectangle 7"/>
+          <p:cNvSpPr/>
+          <p:nvPr/>
+        </p:nvSpPr>
+        <p:spPr>
+          <a:xfrm>
+            <a:off x="502920" y="1143000"/>
+            <a:ext cx="44450" cy="2651760"/>
+          </a:xfrm>
+          <a:prstGeom prst="rect">
+            <a:avLst/>
+          </a:prstGeom>
+          <a:solidFill>
+            <a:srgbClr val="C49A3B"/>
+          </a:solidFill>
+          <a:ln>
+            <a:noFill/>
+          </a:ln>
+          <a:effectLst/>
+        </p:spPr>
+        <p:style>
+          <a:lnRef idx="1">
+            <a:schemeClr val="accent1"/>
+          </a:lnRef>
+          <a:fillRef idx="3">
+            <a:schemeClr val="accent1"/>
+          </a:fillRef>
+          <a:effectRef idx="2">
+            <a:schemeClr val="accent1"/>
+          </a:effectRef>
+          <a:fontRef idx="minor">
+            <a:schemeClr val="lt1"/>
+          </a:fontRef>
+        </p:style>
+        <p:txBody>
+          <a:bodyPr rtlCol="0" anchor="ctr"/>
+          <a:lstStyle/>
+          <a:p>
+            <a:pPr algn="ctr"/>
+          </a:p>
+        </p:txBody>
+      </p:sp>
+      <p:sp>
+        <p:nvSpPr>
+          <p:cNvPr id="9" name="TextBox 8"/>
+          <p:cNvSpPr txBox="1"/>
+          <p:nvPr/>
+        </p:nvSpPr>
+        <p:spPr>
+          <a:xfrm>
+            <a:off x="667512" y="1234440"/>
+            <a:ext cx="5303520" cy="411480"/>
+          </a:xfrm>
+          <a:prstGeom prst="rect">
+            <a:avLst/>
+          </a:prstGeom>
+          <a:noFill/>
+        </p:spPr>
+        <p:txBody>
+          <a:bodyPr wrap="square" anchor="t">
+            <a:spAutoFit/>
+          </a:bodyPr>
+          <a:lstStyle/>
+          <a:p>
+            <a:pPr algn="l">
+              <a:lnSpc>
+                <a:spcPct val="100000"/>
+              </a:lnSpc>
+              <a:spcAft>
+                <a:spcPts val="400"/>
+              </a:spcAft>
+            </a:pPr>
+            <a:r>
+              <a:rPr sz="1300" b="1" i="0">
+                <a:solidFill>
+                  <a:srgbClr val="0B2545"/>
+                </a:solidFill>
+                <a:latin typeface="Georgia"/>
+              </a:rPr>
+              <a:t>EQT Public Value (2018–24) — the cautionary tale</a:t>
+            </a:r>
+          </a:p>
+        </p:txBody>
+      </p:sp>
+      <p:sp>
+        <p:nvSpPr>
+          <p:cNvPr id="10" name="TextBox 9"/>
+          <p:cNvSpPr txBox="1"/>
+          <p:nvPr/>
+        </p:nvSpPr>
+        <p:spPr>
+          <a:xfrm>
+            <a:off x="667512" y="1618488"/>
+            <a:ext cx="5303520" cy="2103120"/>
+          </a:xfrm>
+          <a:prstGeom prst="rect">
+            <a:avLst/>
+          </a:prstGeom>
+          <a:noFill/>
+        </p:spPr>
+        <p:txBody>
+          <a:bodyPr wrap="square" anchor="t">
+            <a:spAutoFit/>
+          </a:bodyPr>
+          <a:lstStyle/>
+          <a:p>
+            <a:pPr algn="l">
+              <a:lnSpc>
+                <a:spcPct val="105000"/>
+              </a:lnSpc>
+              <a:spcAft>
+                <a:spcPts val="400"/>
+              </a:spcAft>
+            </a:pPr>
+            <a:r>
+              <a:rPr sz="1100" b="0" i="0">
+                <a:solidFill>
+                  <a:srgbClr val="555F6E"/>
+                </a:solidFill>
+                <a:latin typeface="Georgia"/>
+              </a:rPr>
+              <a:t>Listed Nordic mid-cap strategy: Securitas, BHG, Storebrand, BioGaia, AFRY, and ~10% of Storytel (Sep 2021, became largest shareholder). Never reached scale, no board-seat engagement playbook, growth-momentum entries; the 2022 de-rating crushed the book and the fund was liquidated — the entire Storytel stake sold in Aug 2024.</a:t>
+            </a:r>
+          </a:p>
+        </p:txBody>
+      </p:sp>
+      <p:sp>
+        <p:nvSpPr>
+          <p:cNvPr id="11" name="Rectangle 10"/>
+          <p:cNvSpPr/>
+          <p:nvPr/>
+        </p:nvSpPr>
+        <p:spPr>
+          <a:xfrm>
+            <a:off x="6263640" y="1143000"/>
+            <a:ext cx="5486400" cy="2651760"/>
+          </a:xfrm>
+          <a:prstGeom prst="rect">
+            <a:avLst/>
+          </a:prstGeom>
+          <a:solidFill>
+            <a:srgbClr val="F2F4F8"/>
+          </a:solidFill>
+          <a:ln>
+            <a:noFill/>
+          </a:ln>
+          <a:effectLst/>
+        </p:spPr>
+        <p:style>
+          <a:lnRef idx="1">
+            <a:schemeClr val="accent1"/>
+          </a:lnRef>
+          <a:fillRef idx="3">
+            <a:schemeClr val="accent1"/>
+          </a:fillRef>
+          <a:effectRef idx="2">
+            <a:schemeClr val="accent1"/>
+          </a:effectRef>
+          <a:fontRef idx="minor">
+            <a:schemeClr val="lt1"/>
+          </a:fontRef>
+        </p:style>
+        <p:txBody>
+          <a:bodyPr rtlCol="0" anchor="ctr"/>
+          <a:lstStyle/>
+          <a:p>
+            <a:pPr algn="ctr"/>
+          </a:p>
+        </p:txBody>
+      </p:sp>
+      <p:sp>
+        <p:nvSpPr>
+          <p:cNvPr id="12" name="Rectangle 11"/>
+          <p:cNvSpPr/>
+          <p:nvPr/>
+        </p:nvSpPr>
+        <p:spPr>
+          <a:xfrm>
+            <a:off x="6263640" y="1143000"/>
+            <a:ext cx="44450" cy="2651760"/>
+          </a:xfrm>
+          <a:prstGeom prst="rect">
+            <a:avLst/>
+          </a:prstGeom>
+          <a:solidFill>
+            <a:srgbClr val="C49A3B"/>
+          </a:solidFill>
+          <a:ln>
+            <a:noFill/>
+          </a:ln>
+          <a:effectLst/>
+        </p:spPr>
+        <p:style>
+          <a:lnRef idx="1">
+            <a:schemeClr val="accent1"/>
+          </a:lnRef>
+          <a:fillRef idx="3">
+            <a:schemeClr val="accent1"/>
+          </a:fillRef>
+          <a:effectRef idx="2">
+            <a:schemeClr val="accent1"/>
+          </a:effectRef>
+          <a:fontRef idx="minor">
+            <a:schemeClr val="lt1"/>
+          </a:fontRef>
+        </p:style>
+        <p:txBody>
+          <a:bodyPr rtlCol="0" anchor="ctr"/>
+          <a:lstStyle/>
+          <a:p>
+            <a:pPr algn="ctr"/>
+          </a:p>
+        </p:txBody>
+      </p:sp>
+      <p:sp>
+        <p:nvSpPr>
+          <p:cNvPr id="13" name="TextBox 12"/>
+          <p:cNvSpPr txBox="1"/>
+          <p:nvPr/>
+        </p:nvSpPr>
+        <p:spPr>
+          <a:xfrm>
+            <a:off x="6428232" y="1234440"/>
+            <a:ext cx="5212080" cy="411480"/>
+          </a:xfrm>
+          <a:prstGeom prst="rect">
+            <a:avLst/>
+          </a:prstGeom>
+          <a:noFill/>
+        </p:spPr>
+        <p:txBody>
+          <a:bodyPr wrap="square" anchor="t">
+            <a:spAutoFit/>
+          </a:bodyPr>
+          <a:lstStyle/>
+          <a:p>
+            <a:pPr algn="l">
+              <a:lnSpc>
+                <a:spcPct val="100000"/>
+              </a:lnSpc>
+              <a:spcAft>
+                <a:spcPts val="400"/>
+              </a:spcAft>
+            </a:pPr>
+            <a:r>
+              <a:rPr sz="1300" b="1" i="0">
+                <a:solidFill>
+                  <a:srgbClr val="0B2545"/>
+                </a:solidFill>
+                <a:latin typeface="Georgia"/>
+              </a:rPr>
+              <a:t>KKR – Henry Schein (2025) — sponsor activism validated</a:t>
+            </a:r>
+          </a:p>
+        </p:txBody>
+      </p:sp>
+      <p:sp>
+        <p:nvSpPr>
+          <p:cNvPr id="14" name="TextBox 13"/>
+          <p:cNvSpPr txBox="1"/>
+          <p:nvPr/>
+        </p:nvSpPr>
+        <p:spPr>
+          <a:xfrm>
+            <a:off x="6428232" y="1618488"/>
+            <a:ext cx="5212080" cy="2103120"/>
+          </a:xfrm>
+          <a:prstGeom prst="rect">
+            <a:avLst/>
+          </a:prstGeom>
+          <a:noFill/>
+        </p:spPr>
+        <p:txBody>
+          <a:bodyPr wrap="square" anchor="t">
+            <a:spAutoFit/>
+          </a:bodyPr>
+          <a:lstStyle/>
+          <a:p>
+            <a:pPr algn="l">
+              <a:lnSpc>
+                <a:spcPct val="105000"/>
+              </a:lnSpc>
+              <a:spcAft>
+                <a:spcPts val="400"/>
+              </a:spcAft>
+            </a:pPr>
+            <a:r>
+              <a:rPr sz="1100" b="0" i="0">
+                <a:solidFill>
+                  <a:srgbClr val="555F6E"/>
+                </a:solidFill>
+                <a:latin typeface="Georgia"/>
+              </a:rPr>
+              <a:t>After Ananym Capital's late-2024 campaign, Henry Schein announced a USD 250m strategic investment from KKR (Jan 2025): two board seats (Dan Daniel ex-Danaher; Max Lin, KKR Healthcare), completed May 2025 with KKR at ~12% and clearance to build to 14.9%. A sponsor converted a modest stake into board influence within months — in our core sector.</a:t>
+            </a:r>
+          </a:p>
+        </p:txBody>
+      </p:sp>
+      <p:sp>
+        <p:nvSpPr>
+          <p:cNvPr id="15" name="Rectangle 14"/>
+          <p:cNvSpPr/>
+          <p:nvPr/>
+        </p:nvSpPr>
+        <p:spPr>
+          <a:xfrm>
+            <a:off x="502920" y="3977639"/>
+            <a:ext cx="11247120" cy="2103120"/>
+          </a:xfrm>
+          <a:prstGeom prst="rect">
+            <a:avLst/>
+          </a:prstGeom>
+          <a:solidFill>
+            <a:srgbClr val="0B2545"/>
+          </a:solidFill>
+          <a:ln>
+            <a:noFill/>
+          </a:ln>
+          <a:effectLst/>
+        </p:spPr>
+        <p:style>
+          <a:lnRef idx="1">
+            <a:schemeClr val="accent1"/>
+          </a:lnRef>
+          <a:fillRef idx="3">
+            <a:schemeClr val="accent1"/>
+          </a:fillRef>
+          <a:effectRef idx="2">
+            <a:schemeClr val="accent1"/>
+          </a:effectRef>
+          <a:fontRef idx="minor">
+            <a:schemeClr val="lt1"/>
+          </a:fontRef>
+        </p:style>
+        <p:txBody>
+          <a:bodyPr rtlCol="0" anchor="ctr"/>
+          <a:lstStyle/>
+          <a:p>
+            <a:pPr algn="ctr"/>
+          </a:p>
+        </p:txBody>
+      </p:sp>
+      <p:sp>
+        <p:nvSpPr>
+          <p:cNvPr id="16" name="TextBox 15"/>
+          <p:cNvSpPr txBox="1"/>
+          <p:nvPr/>
+        </p:nvSpPr>
+        <p:spPr>
+          <a:xfrm>
+            <a:off x="777240" y="4114800"/>
+            <a:ext cx="10789920" cy="320040"/>
+          </a:xfrm>
+          <a:prstGeom prst="rect">
+            <a:avLst/>
+          </a:prstGeom>
+          <a:noFill/>
+        </p:spPr>
+        <p:txBody>
+          <a:bodyPr wrap="square" anchor="t">
+            <a:spAutoFit/>
+          </a:bodyPr>
+          <a:lstStyle/>
+          <a:p>
+            <a:pPr algn="l">
+              <a:lnSpc>
+                <a:spcPct val="100000"/>
+              </a:lnSpc>
+              <a:spcAft>
+                <a:spcPts val="400"/>
+              </a:spcAft>
+            </a:pPr>
+            <a:r>
+              <a:rPr sz="1200" b="1" i="0">
+                <a:solidFill>
+                  <a:srgbClr val="C49A3B"/>
+                </a:solidFill>
+                <a:latin typeface="Georgia"/>
+              </a:rPr>
+              <a:t>What the precedents are designed into</a:t>
+            </a:r>
+          </a:p>
+        </p:txBody>
+      </p:sp>
+      <p:sp>
+        <p:nvSpPr>
+          <p:cNvPr id="17" name="TextBox 16"/>
+          <p:cNvSpPr txBox="1"/>
+          <p:nvPr/>
+        </p:nvSpPr>
+        <p:spPr>
+          <a:xfrm>
+            <a:off x="777240" y="4480560"/>
+            <a:ext cx="10789920" cy="1554480"/>
+          </a:xfrm>
+          <a:prstGeom prst="rect">
+            <a:avLst/>
+          </a:prstGeom>
+          <a:noFill/>
+        </p:spPr>
+        <p:txBody>
+          <a:bodyPr wrap="square" anchor="t">
+            <a:spAutoFit/>
+          </a:bodyPr>
+          <a:lstStyle/>
+          <a:p>
+            <a:pPr algn="l">
+              <a:lnSpc>
+                <a:spcPct val="120000"/>
+              </a:lnSpc>
+              <a:spcAft>
+                <a:spcPts val="400"/>
+              </a:spcAft>
+            </a:pPr>
+            <a:r>
+              <a:rPr sz="1200" b="0" i="0">
+                <a:solidFill>
+                  <a:srgbClr val="FFFFFF"/>
+                </a:solidFill>
+                <a:latin typeface="Georgia"/>
+              </a:rPr>
+              <a:t>Scale + seed from day one (EUR 150–200m GP commitment) — not EQT PV's subscale drift  ·  Partner-level activist leadership and a US campaign Principal — not PE generalists  ·  Stakes sized for influence (nomination committees / universal proxy) — not passive minorities  ·  ≥30% value-gap entries — not growth momentum  ·  Evergreen capital — never forced to liquidate at the bottom  ·  Screens exclude the Cevian failure fingerprint: fragile balance sheets, political stakeholders, catalysts outside shareholders' control. Triton–Caverion (2022–23) shows the take-private optionality; Active Value Partners (2026) shows the window is closing.</a:t>
+            </a:r>
+          </a:p>
+        </p:txBody>
+      </p:sp>
+    </p:spTree>
+  </p:cSld>
+  <p:clrMapOvr>
+    <a:masterClrMapping/>
+  </p:clrMapOvr>
+</p:sld>
+</file>
+
 <file path=ppt/slides/slide2.xml><?xml version="1.0" encoding="utf-8"?>
 <p:sld xmlns:a="http://schemas.openxmlformats.org/drawingml/2006/main" xmlns:p="http://schemas.openxmlformats.org/presentationml/2006/main" xmlns:r="http://schemas.openxmlformats.org/officeDocument/2006/relationships">
   <p:cSld>

</xml_diff>

<commit_message>
Deepen precedents appendix with campaign-level detail
Twelve in-depth Cevian campaign write-ups with lessons; full EQT Public
Value post-mortem incl. Storytel case study; KKR-Henry Schein step-by-
step through the 2026 chairmanship; Caverion bid sequence; deck synced.

https://claude.ai/code/session_014wJkiGJDWLqynffcMLAwBq
</commit_message>
<xml_diff>
--- a/nordic-capital-activism-pitch/Nordic_Capital_Engaged_Equities_Deck.pptx
+++ b/nordic-capital-activism-pitch/Nordic_Capital_Engaged_Equities_Deck.pptx
@@ -10738,7 +10738,7 @@
                           </a:solidFill>
                           <a:latin typeface="Georgia"/>
                         </a:rPr>
-                        <a:t>2018–19</a:t>
+                        <a:t>c.2013–19</a:t>
                       </a:r>
                     </a:p>
                   </a:txBody>
@@ -10760,7 +10760,7 @@
                           </a:solidFill>
                           <a:latin typeface="Georgia"/>
                         </a:rPr>
-                        <a:t>Pushed sale; DSV takeover at a substantial premium within ~18 months</a:t>
+                        <a:t>Long-held ~12%; pushed sale; DSV takeover 2019 at a substantial premium</a:t>
                       </a:r>
                     </a:p>
                   </a:txBody>
@@ -11278,7 +11278,7 @@
                           </a:solidFill>
                           <a:latin typeface="Georgia"/>
                         </a:rPr>
-                        <a:t>c.2024–</a:t>
+                        <a:t>2025–</a:t>
                       </a:r>
                     </a:p>
                   </a:txBody>
@@ -11300,7 +11300,7 @@
                           </a:solidFill>
                           <a:latin typeface="Georgia"/>
                         </a:rPr>
-                        <a:t>Coatings margin gap &amp; consolidation; doubled to ~10.2% late 2025, funded by the ABB exit</a:t>
+                        <a:t>Built ~5% pressing for reset; backed the USD 25bn Axalta merger (Nov 2025), doubled to ~10.2%</a:t>
                       </a:r>
                     </a:p>
                   </a:txBody>
@@ -11998,7 +11998,7 @@
                 </a:solidFill>
                 <a:latin typeface="Georgia"/>
               </a:rPr>
-              <a:t>KKR – Henry Schein (2025) — the template</a:t>
+              <a:t>KKR – Henry Schein (2024–26) — the template</a:t>
             </a:r>
           </a:p>
         </p:txBody>
@@ -12040,7 +12040,7 @@
                 </a:solidFill>
                 <a:latin typeface="Georgia"/>
               </a:rPr>
-              <a:t>After Ananym Capital's late-2024 campaign, Henry Schein announced a USD 250m strategic investment from KKR (Jan 2025): two board seats (Dan Daniel ex-Danaher; Max Lin, KKR Healthcare), completed May 2025 with KKR at ~12%, clearance to 14.9%. A modest stake became board influence within months — in our core sector.</a:t>
+              <a:t>Ananym campaigns (Nov 2024) → KKR USD 250m investment + 2 board seats (Jan 2025) → ~12% completed May 2025 → CEO succession: Lowery, ex-Thermo Fisher (Mar 2026) → KKR's Dan Daniel becomes Independent Chairman (May 2026), KKR at 16.4%. Zero to largest active holder + chairmanship in ~15 months, in our core sector.</a:t>
             </a:r>
           </a:p>
         </p:txBody>

</xml_diff>

<commit_message>
Add detailed case studies: EQT Public Value, Irenic, Ananym
Restructure EQT Public Value into a full case study with holdings table
and a four-flaw failure analysis mapped to design answers. Add A.5
covering new-generation strategic activists Irenic (Katz, ex-Elliott)
and Ananym (Penner, ex-Engine No. 1) with company-by-company thesis
tables. New deck appendix slide (3/3) summarizing all three.

https://claude.ai/code/session_014wJkiGJDWLqynffcMLAwBq
</commit_message>
<xml_diff>
--- a/nordic-capital-activism-pitch/Nordic_Capital_Engaged_Equities_Deck.pptx
+++ b/nordic-capital-activism-pitch/Nordic_Capital_Engaged_Equities_Deck.pptx
@@ -23,6 +23,7 @@
     <p:sldId id="271" r:id="rId22"/>
     <p:sldId id="272" r:id="rId23"/>
     <p:sldId id="273" r:id="rId24"/>
+    <p:sldId id="274" r:id="rId25"/>
   </p:sldIdLst>
   <p:sldSz cx="12191695" cy="6858000" type="screen4x3"/>
   <p:notesSz cx="6858000" cy="9144000"/>
@@ -10092,7 +10093,7 @@
                 </a:solidFill>
                 <a:latin typeface="Georgia"/>
               </a:rPr>
-              <a:t>Appendix — Precedents (1/2): Cevian, the constructive model at scale</a:t>
+              <a:t>Appendix — Precedents (1/3): Cevian, the constructive model at scale</a:t>
             </a:r>
           </a:p>
         </p:txBody>
@@ -11654,7 +11655,7 @@
                 </a:solidFill>
                 <a:latin typeface="Georgia"/>
               </a:rPr>
-              <a:t>Appendix — Precedents (2/2): sponsors entering public-market activism</a:t>
+              <a:t>Appendix — Precedents (2/3): sponsors entering public-market activism</a:t>
             </a:r>
           </a:p>
         </p:txBody>
@@ -12341,6 +12342,1750 @@
                 <a:latin typeface="Georgia"/>
               </a:rPr>
               <a:t>Scale + seed from day one — not EQT PV's subscale drift  ·  Partner-level activist leadership and a US campaign Principal — not PE generalists  ·  Stakes sized for influence — not passive minorities  ·  ≥30% value-gap entries — not growth momentum  ·  Evergreen capital — never forced to sell at the bottom  ·  Screens exclude the Cevian failure fingerprint: fragile balance sheets, political stakeholders, catalysts outside shareholders' control.</a:t>
+            </a:r>
+          </a:p>
+        </p:txBody>
+      </p:sp>
+    </p:spTree>
+  </p:cSld>
+  <p:clrMapOvr>
+    <a:masterClrMapping/>
+  </p:clrMapOvr>
+</p:sld>
+</file>
+
+<file path=ppt/slides/slide19.xml><?xml version="1.0" encoding="utf-8"?>
+<p:sld xmlns:a="http://schemas.openxmlformats.org/drawingml/2006/main" xmlns:p="http://schemas.openxmlformats.org/presentationml/2006/main" xmlns:r="http://schemas.openxmlformats.org/officeDocument/2006/relationships">
+  <p:cSld>
+    <p:spTree>
+      <p:nvGrpSpPr>
+        <p:cNvPr id="1" name=""/>
+        <p:cNvGrpSpPr/>
+        <p:nvPr/>
+      </p:nvGrpSpPr>
+      <p:grpSpPr/>
+      <p:sp>
+        <p:nvSpPr>
+          <p:cNvPr id="2" name="Rectangle 1"/>
+          <p:cNvSpPr/>
+          <p:nvPr/>
+        </p:nvSpPr>
+        <p:spPr>
+          <a:xfrm>
+            <a:off x="0" y="0"/>
+            <a:ext cx="12191695" cy="868680"/>
+          </a:xfrm>
+          <a:prstGeom prst="rect">
+            <a:avLst/>
+          </a:prstGeom>
+          <a:solidFill>
+            <a:srgbClr val="0B2545"/>
+          </a:solidFill>
+          <a:ln>
+            <a:noFill/>
+          </a:ln>
+          <a:effectLst/>
+        </p:spPr>
+        <p:style>
+          <a:lnRef idx="1">
+            <a:schemeClr val="accent1"/>
+          </a:lnRef>
+          <a:fillRef idx="3">
+            <a:schemeClr val="accent1"/>
+          </a:fillRef>
+          <a:effectRef idx="2">
+            <a:schemeClr val="accent1"/>
+          </a:effectRef>
+          <a:fontRef idx="minor">
+            <a:schemeClr val="lt1"/>
+          </a:fontRef>
+        </p:style>
+        <p:txBody>
+          <a:bodyPr rtlCol="0" anchor="ctr"/>
+          <a:lstStyle/>
+          <a:p>
+            <a:pPr algn="ctr"/>
+          </a:p>
+        </p:txBody>
+      </p:sp>
+      <p:sp>
+        <p:nvSpPr>
+          <p:cNvPr id="3" name="Rectangle 2"/>
+          <p:cNvSpPr/>
+          <p:nvPr/>
+        </p:nvSpPr>
+        <p:spPr>
+          <a:xfrm>
+            <a:off x="0" y="868680"/>
+            <a:ext cx="12191695" cy="38100"/>
+          </a:xfrm>
+          <a:prstGeom prst="rect">
+            <a:avLst/>
+          </a:prstGeom>
+          <a:solidFill>
+            <a:srgbClr val="C49A3B"/>
+          </a:solidFill>
+          <a:ln>
+            <a:noFill/>
+          </a:ln>
+          <a:effectLst/>
+        </p:spPr>
+        <p:style>
+          <a:lnRef idx="1">
+            <a:schemeClr val="accent1"/>
+          </a:lnRef>
+          <a:fillRef idx="3">
+            <a:schemeClr val="accent1"/>
+          </a:fillRef>
+          <a:effectRef idx="2">
+            <a:schemeClr val="accent1"/>
+          </a:effectRef>
+          <a:fontRef idx="minor">
+            <a:schemeClr val="lt1"/>
+          </a:fontRef>
+        </p:style>
+        <p:txBody>
+          <a:bodyPr rtlCol="0" anchor="ctr"/>
+          <a:lstStyle/>
+          <a:p>
+            <a:pPr algn="ctr"/>
+          </a:p>
+        </p:txBody>
+      </p:sp>
+      <p:sp>
+        <p:nvSpPr>
+          <p:cNvPr id="4" name="TextBox 3"/>
+          <p:cNvSpPr txBox="1"/>
+          <p:nvPr/>
+        </p:nvSpPr>
+        <p:spPr>
+          <a:xfrm>
+            <a:off x="502920" y="73152"/>
+            <a:ext cx="10058400" cy="274320"/>
+          </a:xfrm>
+          <a:prstGeom prst="rect">
+            <a:avLst/>
+          </a:prstGeom>
+          <a:noFill/>
+        </p:spPr>
+        <p:txBody>
+          <a:bodyPr wrap="square" anchor="t">
+            <a:spAutoFit/>
+          </a:bodyPr>
+          <a:lstStyle/>
+          <a:p>
+            <a:pPr algn="l">
+              <a:lnSpc>
+                <a:spcPct val="100000"/>
+              </a:lnSpc>
+              <a:spcAft>
+                <a:spcPts val="400"/>
+              </a:spcAft>
+            </a:pPr>
+            <a:r>
+              <a:rPr sz="1000" b="1" i="0">
+                <a:solidFill>
+                  <a:srgbClr val="C49A3B"/>
+                </a:solidFill>
+                <a:latin typeface="Georgia"/>
+              </a:rPr>
+              <a:t>APPENDIX</a:t>
+            </a:r>
+          </a:p>
+        </p:txBody>
+      </p:sp>
+      <p:sp>
+        <p:nvSpPr>
+          <p:cNvPr id="5" name="TextBox 4"/>
+          <p:cNvSpPr txBox="1"/>
+          <p:nvPr/>
+        </p:nvSpPr>
+        <p:spPr>
+          <a:xfrm>
+            <a:off x="502920" y="310896"/>
+            <a:ext cx="11155680" cy="548640"/>
+          </a:xfrm>
+          <a:prstGeom prst="rect">
+            <a:avLst/>
+          </a:prstGeom>
+          <a:noFill/>
+        </p:spPr>
+        <p:txBody>
+          <a:bodyPr wrap="square" anchor="t">
+            <a:spAutoFit/>
+          </a:bodyPr>
+          <a:lstStyle/>
+          <a:p>
+            <a:pPr algn="l">
+              <a:lnSpc>
+                <a:spcPct val="100000"/>
+              </a:lnSpc>
+              <a:spcAft>
+                <a:spcPts val="400"/>
+              </a:spcAft>
+            </a:pPr>
+            <a:r>
+              <a:rPr sz="2400" b="1" i="0">
+                <a:solidFill>
+                  <a:srgbClr val="FFFFFF"/>
+                </a:solidFill>
+                <a:latin typeface="Georgia"/>
+              </a:rPr>
+              <a:t>Appendix — Precedents (3/3): the model that fails vs the models that work</a:t>
+            </a:r>
+          </a:p>
+        </p:txBody>
+      </p:sp>
+      <p:sp>
+        <p:nvSpPr>
+          <p:cNvPr id="6" name="TextBox 5"/>
+          <p:cNvSpPr txBox="1"/>
+          <p:nvPr/>
+        </p:nvSpPr>
+        <p:spPr>
+          <a:xfrm>
+            <a:off x="502920" y="6510528"/>
+            <a:ext cx="11155680" cy="274320"/>
+          </a:xfrm>
+          <a:prstGeom prst="rect">
+            <a:avLst/>
+          </a:prstGeom>
+          <a:noFill/>
+        </p:spPr>
+        <p:txBody>
+          <a:bodyPr wrap="square" anchor="t">
+            <a:spAutoFit/>
+          </a:bodyPr>
+          <a:lstStyle/>
+          <a:p>
+            <a:pPr algn="l">
+              <a:lnSpc>
+                <a:spcPct val="100000"/>
+              </a:lnSpc>
+              <a:spcAft>
+                <a:spcPts val="400"/>
+              </a:spcAft>
+            </a:pPr>
+            <a:r>
+              <a:rPr sz="800" b="0" i="0">
+                <a:solidFill>
+                  <a:srgbClr val="9AA4B2"/>
+                </a:solidFill>
+                <a:latin typeface="Georgia"/>
+              </a:rPr>
+              <a:t>Strictly private &amp; confidential — illustrative discussion material</a:t>
+            </a:r>
+          </a:p>
+        </p:txBody>
+      </p:sp>
+      <p:sp>
+        <p:nvSpPr>
+          <p:cNvPr id="7" name="Rectangle 6"/>
+          <p:cNvSpPr/>
+          <p:nvPr/>
+        </p:nvSpPr>
+        <p:spPr>
+          <a:xfrm>
+            <a:off x="502920" y="1097280"/>
+            <a:ext cx="5532120" cy="5029200"/>
+          </a:xfrm>
+          <a:prstGeom prst="rect">
+            <a:avLst/>
+          </a:prstGeom>
+          <a:solidFill>
+            <a:srgbClr val="F2F4F8"/>
+          </a:solidFill>
+          <a:ln>
+            <a:noFill/>
+          </a:ln>
+          <a:effectLst/>
+        </p:spPr>
+        <p:style>
+          <a:lnRef idx="1">
+            <a:schemeClr val="accent1"/>
+          </a:lnRef>
+          <a:fillRef idx="3">
+            <a:schemeClr val="accent1"/>
+          </a:fillRef>
+          <a:effectRef idx="2">
+            <a:schemeClr val="accent1"/>
+          </a:effectRef>
+          <a:fontRef idx="minor">
+            <a:schemeClr val="lt1"/>
+          </a:fontRef>
+        </p:style>
+        <p:txBody>
+          <a:bodyPr rtlCol="0" anchor="ctr"/>
+          <a:lstStyle/>
+          <a:p>
+            <a:pPr algn="ctr"/>
+          </a:p>
+        </p:txBody>
+      </p:sp>
+      <p:sp>
+        <p:nvSpPr>
+          <p:cNvPr id="8" name="Rectangle 7"/>
+          <p:cNvSpPr/>
+          <p:nvPr/>
+        </p:nvSpPr>
+        <p:spPr>
+          <a:xfrm>
+            <a:off x="502920" y="1097280"/>
+            <a:ext cx="50800" cy="5029200"/>
+          </a:xfrm>
+          <a:prstGeom prst="rect">
+            <a:avLst/>
+          </a:prstGeom>
+          <a:solidFill>
+            <a:srgbClr val="B03A2E"/>
+          </a:solidFill>
+          <a:ln>
+            <a:noFill/>
+          </a:ln>
+          <a:effectLst/>
+        </p:spPr>
+        <p:style>
+          <a:lnRef idx="1">
+            <a:schemeClr val="accent1"/>
+          </a:lnRef>
+          <a:fillRef idx="3">
+            <a:schemeClr val="accent1"/>
+          </a:fillRef>
+          <a:effectRef idx="2">
+            <a:schemeClr val="accent1"/>
+          </a:effectRef>
+          <a:fontRef idx="minor">
+            <a:schemeClr val="lt1"/>
+          </a:fontRef>
+        </p:style>
+        <p:txBody>
+          <a:bodyPr rtlCol="0" anchor="ctr"/>
+          <a:lstStyle/>
+          <a:p>
+            <a:pPr algn="ctr"/>
+          </a:p>
+        </p:txBody>
+      </p:sp>
+      <p:sp>
+        <p:nvSpPr>
+          <p:cNvPr id="9" name="TextBox 8"/>
+          <p:cNvSpPr txBox="1"/>
+          <p:nvPr/>
+        </p:nvSpPr>
+        <p:spPr>
+          <a:xfrm>
+            <a:off x="685800" y="1207008"/>
+            <a:ext cx="5212080" cy="365760"/>
+          </a:xfrm>
+          <a:prstGeom prst="rect">
+            <a:avLst/>
+          </a:prstGeom>
+          <a:noFill/>
+        </p:spPr>
+        <p:txBody>
+          <a:bodyPr wrap="square" anchor="t">
+            <a:spAutoFit/>
+          </a:bodyPr>
+          <a:lstStyle/>
+          <a:p>
+            <a:pPr algn="l">
+              <a:lnSpc>
+                <a:spcPct val="100000"/>
+              </a:lnSpc>
+              <a:spcAft>
+                <a:spcPts val="400"/>
+              </a:spcAft>
+            </a:pPr>
+            <a:r>
+              <a:rPr sz="1400" b="1" i="0">
+                <a:solidFill>
+                  <a:srgbClr val="0B2545"/>
+                </a:solidFill>
+                <a:latin typeface="Georgia"/>
+              </a:rPr>
+              <a:t>EQT Public Value (2018–24) — what NOT to do</a:t>
+            </a:r>
+          </a:p>
+        </p:txBody>
+      </p:sp>
+      <p:sp>
+        <p:nvSpPr>
+          <p:cNvPr id="10" name="TextBox 9"/>
+          <p:cNvSpPr txBox="1"/>
+          <p:nvPr/>
+        </p:nvSpPr>
+        <p:spPr>
+          <a:xfrm>
+            <a:off x="685800" y="1627632"/>
+            <a:ext cx="5212080" cy="868680"/>
+          </a:xfrm>
+          <a:prstGeom prst="rect">
+            <a:avLst/>
+          </a:prstGeom>
+          <a:noFill/>
+        </p:spPr>
+        <p:txBody>
+          <a:bodyPr wrap="square" anchor="t">
+            <a:spAutoFit/>
+          </a:bodyPr>
+          <a:lstStyle/>
+          <a:p>
+            <a:pPr algn="l">
+              <a:lnSpc>
+                <a:spcPct val="108000"/>
+              </a:lnSpc>
+              <a:spcAft>
+                <a:spcPts val="400"/>
+              </a:spcAft>
+            </a:pPr>
+            <a:r>
+              <a:rPr sz="1050" b="0" i="0">
+                <a:solidFill>
+                  <a:srgbClr val="555F6E"/>
+                </a:solidFill>
+                <a:latin typeface="Georgia"/>
+              </a:rPr>
+              <a:t>The closest analogue to this proposal — a top-tier Nordic PE sponsor in listed mid-caps — and it failed on design, not concept. Book drifted from value (Securitas, Storebrand) to momentum (BHG, Storytel: ~10% bought Sep 2021, ~80% de-rating, force-sold Aug 2024 on the fund clock).</a:t>
+            </a:r>
+          </a:p>
+        </p:txBody>
+      </p:sp>
+      <p:sp>
+        <p:nvSpPr>
+          <p:cNvPr id="11" name="TextBox 10"/>
+          <p:cNvSpPr txBox="1"/>
+          <p:nvPr/>
+        </p:nvSpPr>
+        <p:spPr>
+          <a:xfrm>
+            <a:off x="685800" y="2"/>
+            <a:ext cx="5212080" cy="228600"/>
+          </a:xfrm>
+          <a:prstGeom prst="rect">
+            <a:avLst/>
+          </a:prstGeom>
+          <a:noFill/>
+        </p:spPr>
+        <p:txBody>
+          <a:bodyPr wrap="square" anchor="t">
+            <a:spAutoFit/>
+          </a:bodyPr>
+          <a:lstStyle/>
+          <a:p>
+            <a:pPr algn="l">
+              <a:lnSpc>
+                <a:spcPct val="100000"/>
+              </a:lnSpc>
+              <a:spcAft>
+                <a:spcPts val="400"/>
+              </a:spcAft>
+            </a:pPr>
+            <a:r>
+              <a:rPr sz="1050" b="1" i="0">
+                <a:solidFill>
+                  <a:srgbClr val="0B2545"/>
+                </a:solidFill>
+                <a:latin typeface="Georgia"/>
+              </a:rPr>
+              <a:t>Four flaws → this proposal's answers</a:t>
+            </a:r>
+          </a:p>
+        </p:txBody>
+      </p:sp>
+      <p:sp>
+        <p:nvSpPr>
+          <p:cNvPr id="12" name="TextBox 11"/>
+          <p:cNvSpPr txBox="1"/>
+          <p:nvPr/>
+        </p:nvSpPr>
+        <p:spPr>
+          <a:xfrm>
+            <a:off x="685800" y="2651760"/>
+            <a:ext cx="5212080" cy="640080"/>
+          </a:xfrm>
+          <a:prstGeom prst="rect">
+            <a:avLst/>
+          </a:prstGeom>
+          <a:noFill/>
+        </p:spPr>
+        <p:txBody>
+          <a:bodyPr wrap="square" anchor="t">
+            <a:spAutoFit/>
+          </a:bodyPr>
+          <a:lstStyle/>
+          <a:p>
+            <a:pPr algn="l">
+              <a:lnSpc>
+                <a:spcPct val="100000"/>
+              </a:lnSpc>
+              <a:spcAft>
+                <a:spcPts val="100"/>
+              </a:spcAft>
+            </a:pPr>
+            <a:r>
+              <a:rPr sz="1000" b="1" i="0">
+                <a:solidFill>
+                  <a:srgbClr val="B03A2E"/>
+                </a:solidFill>
+                <a:latin typeface="Georgia"/>
+              </a:rPr>
+              <a:t>✗ Sub-scale capital</a:t>
+            </a:r>
+          </a:p>
+          <a:p>
+            <a:pPr algn="l">
+              <a:lnSpc>
+                <a:spcPct val="100000"/>
+              </a:lnSpc>
+              <a:spcAft>
+                <a:spcPts val="400"/>
+              </a:spcAft>
+            </a:pPr>
+            <a:r>
+              <a:rPr sz="1000" b="0" i="0">
+                <a:solidFill>
+                  <a:srgbClr val="1E6B3A"/>
+                </a:solidFill>
+                <a:latin typeface="Georgia"/>
+              </a:rPr>
+              <a:t>→ Influence-sized stakes (2–10%) + EUR 150–200m seed</a:t>
+            </a:r>
+          </a:p>
+        </p:txBody>
+      </p:sp>
+      <p:sp>
+        <p:nvSpPr>
+          <p:cNvPr id="13" name="TextBox 12"/>
+          <p:cNvSpPr txBox="1"/>
+          <p:nvPr/>
+        </p:nvSpPr>
+        <p:spPr>
+          <a:xfrm>
+            <a:off x="685800" y="3328415"/>
+            <a:ext cx="5212080" cy="640080"/>
+          </a:xfrm>
+          <a:prstGeom prst="rect">
+            <a:avLst/>
+          </a:prstGeom>
+          <a:noFill/>
+        </p:spPr>
+        <p:txBody>
+          <a:bodyPr wrap="square" anchor="t">
+            <a:spAutoFit/>
+          </a:bodyPr>
+          <a:lstStyle/>
+          <a:p>
+            <a:pPr algn="l">
+              <a:lnSpc>
+                <a:spcPct val="100000"/>
+              </a:lnSpc>
+              <a:spcAft>
+                <a:spcPts val="100"/>
+              </a:spcAft>
+            </a:pPr>
+            <a:r>
+              <a:rPr sz="1000" b="1" i="0">
+                <a:solidFill>
+                  <a:srgbClr val="B03A2E"/>
+                </a:solidFill>
+                <a:latin typeface="Georgia"/>
+              </a:rPr>
+              <a:t>✗ No activist leadership</a:t>
+            </a:r>
+          </a:p>
+          <a:p>
+            <a:pPr algn="l">
+              <a:lnSpc>
+                <a:spcPct val="100000"/>
+              </a:lnSpc>
+              <a:spcAft>
+                <a:spcPts val="400"/>
+              </a:spcAft>
+            </a:pPr>
+            <a:r>
+              <a:rPr sz="1000" b="0" i="0">
+                <a:solidFill>
+                  <a:srgbClr val="1E6B3A"/>
+                </a:solidFill>
+                <a:latin typeface="Georgia"/>
+              </a:rPr>
+              <a:t>→ Partner Head + US Campaign Principal (Knut Nyman)</a:t>
+            </a:r>
+          </a:p>
+        </p:txBody>
+      </p:sp>
+      <p:sp>
+        <p:nvSpPr>
+          <p:cNvPr id="14" name="TextBox 13"/>
+          <p:cNvSpPr txBox="1"/>
+          <p:nvPr/>
+        </p:nvSpPr>
+        <p:spPr>
+          <a:xfrm>
+            <a:off x="685800" y="4005072"/>
+            <a:ext cx="5212080" cy="640080"/>
+          </a:xfrm>
+          <a:prstGeom prst="rect">
+            <a:avLst/>
+          </a:prstGeom>
+          <a:noFill/>
+        </p:spPr>
+        <p:txBody>
+          <a:bodyPr wrap="square" anchor="t">
+            <a:spAutoFit/>
+          </a:bodyPr>
+          <a:lstStyle/>
+          <a:p>
+            <a:pPr algn="l">
+              <a:lnSpc>
+                <a:spcPct val="100000"/>
+              </a:lnSpc>
+              <a:spcAft>
+                <a:spcPts val="100"/>
+              </a:spcAft>
+            </a:pPr>
+            <a:r>
+              <a:rPr sz="1000" b="1" i="0">
+                <a:solidFill>
+                  <a:srgbClr val="B03A2E"/>
+                </a:solidFill>
+                <a:latin typeface="Georgia"/>
+              </a:rPr>
+              <a:t>✗ Quality/momentum entries</a:t>
+            </a:r>
+          </a:p>
+          <a:p>
+            <a:pPr algn="l">
+              <a:lnSpc>
+                <a:spcPct val="100000"/>
+              </a:lnSpc>
+              <a:spcAft>
+                <a:spcPts val="400"/>
+              </a:spcAft>
+            </a:pPr>
+            <a:r>
+              <a:rPr sz="1000" b="0" i="0">
+                <a:solidFill>
+                  <a:srgbClr val="1E6B3A"/>
+                </a:solidFill>
+                <a:latin typeface="Georgia"/>
+              </a:rPr>
+              <a:t>→ ≥30% value-gap with a named catalyst; no momentum</a:t>
+            </a:r>
+          </a:p>
+        </p:txBody>
+      </p:sp>
+      <p:sp>
+        <p:nvSpPr>
+          <p:cNvPr id="15" name="TextBox 14"/>
+          <p:cNvSpPr txBox="1"/>
+          <p:nvPr/>
+        </p:nvSpPr>
+        <p:spPr>
+          <a:xfrm>
+            <a:off x="685800" y="4681728"/>
+            <a:ext cx="5212080" cy="640080"/>
+          </a:xfrm>
+          <a:prstGeom prst="rect">
+            <a:avLst/>
+          </a:prstGeom>
+          <a:noFill/>
+        </p:spPr>
+        <p:txBody>
+          <a:bodyPr wrap="square" anchor="t">
+            <a:spAutoFit/>
+          </a:bodyPr>
+          <a:lstStyle/>
+          <a:p>
+            <a:pPr algn="l">
+              <a:lnSpc>
+                <a:spcPct val="100000"/>
+              </a:lnSpc>
+              <a:spcAft>
+                <a:spcPts val="100"/>
+              </a:spcAft>
+            </a:pPr>
+            <a:r>
+              <a:rPr sz="1000" b="1" i="0">
+                <a:solidFill>
+                  <a:srgbClr val="B03A2E"/>
+                </a:solidFill>
+                <a:latin typeface="Georgia"/>
+              </a:rPr>
+              <a:t>✗ Finite fund clock</a:t>
+            </a:r>
+          </a:p>
+          <a:p>
+            <a:pPr algn="l">
+              <a:lnSpc>
+                <a:spcPct val="100000"/>
+              </a:lnSpc>
+              <a:spcAft>
+                <a:spcPts val="400"/>
+              </a:spcAft>
+            </a:pPr>
+            <a:r>
+              <a:rPr sz="1000" b="0" i="0">
+                <a:solidFill>
+                  <a:srgbClr val="1E6B3A"/>
+                </a:solidFill>
+                <a:latin typeface="Georgia"/>
+              </a:rPr>
+              <a:t>→ Evergreen + 3-yr lock — never a forced seller</a:t>
+            </a:r>
+          </a:p>
+        </p:txBody>
+      </p:sp>
+      <p:sp>
+        <p:nvSpPr>
+          <p:cNvPr id="16" name="TextBox 15"/>
+          <p:cNvSpPr txBox="1"/>
+          <p:nvPr/>
+        </p:nvSpPr>
+        <p:spPr>
+          <a:xfrm>
+            <a:off x="685800" y="5312664"/>
+            <a:ext cx="5212080" cy="502920"/>
+          </a:xfrm>
+          <a:prstGeom prst="rect">
+            <a:avLst/>
+          </a:prstGeom>
+          <a:noFill/>
+        </p:spPr>
+        <p:txBody>
+          <a:bodyPr wrap="square" anchor="t">
+            <a:spAutoFit/>
+          </a:bodyPr>
+          <a:lstStyle/>
+          <a:p>
+            <a:pPr algn="l">
+              <a:lnSpc>
+                <a:spcPct val="105000"/>
+              </a:lnSpc>
+              <a:spcAft>
+                <a:spcPts val="400"/>
+              </a:spcAft>
+            </a:pPr>
+            <a:r>
+              <a:rPr sz="1000" b="0" i="1">
+                <a:solidFill>
+                  <a:srgbClr val="0B2545"/>
+                </a:solidFill>
+                <a:latin typeface="Georgia"/>
+              </a:rPr>
+              <a:t>Lesson: a sponsor's public vehicle only works if built as an engagement platform from day one — not a long-only fund with a famous logo.</a:t>
+            </a:r>
+          </a:p>
+        </p:txBody>
+      </p:sp>
+      <p:sp>
+        <p:nvSpPr>
+          <p:cNvPr id="17" name="TextBox 16"/>
+          <p:cNvSpPr txBox="1"/>
+          <p:nvPr/>
+        </p:nvSpPr>
+        <p:spPr>
+          <a:xfrm>
+            <a:off x="6263640" y="1097280"/>
+            <a:ext cx="5486400" cy="320040"/>
+          </a:xfrm>
+          <a:prstGeom prst="rect">
+            <a:avLst/>
+          </a:prstGeom>
+          <a:noFill/>
+        </p:spPr>
+        <p:txBody>
+          <a:bodyPr wrap="square" anchor="t">
+            <a:spAutoFit/>
+          </a:bodyPr>
+          <a:lstStyle/>
+          <a:p>
+            <a:pPr algn="l">
+              <a:lnSpc>
+                <a:spcPct val="100000"/>
+              </a:lnSpc>
+              <a:spcAft>
+                <a:spcPts val="400"/>
+              </a:spcAft>
+            </a:pPr>
+            <a:r>
+              <a:rPr sz="1400" b="1" i="0">
+                <a:solidFill>
+                  <a:srgbClr val="0B2545"/>
+                </a:solidFill>
+                <a:latin typeface="Georgia"/>
+              </a:rPr>
+              <a:t>New-generation strategic activists — the model that WORKS</a:t>
+            </a:r>
+          </a:p>
+        </p:txBody>
+      </p:sp>
+      <p:sp>
+        <p:nvSpPr>
+          <p:cNvPr id="18" name="TextBox 17"/>
+          <p:cNvSpPr txBox="1"/>
+          <p:nvPr/>
+        </p:nvSpPr>
+        <p:spPr>
+          <a:xfrm>
+            <a:off x="6263640" y="1444752"/>
+            <a:ext cx="5486400" cy="457200"/>
+          </a:xfrm>
+          <a:prstGeom prst="rect">
+            <a:avLst/>
+          </a:prstGeom>
+          <a:noFill/>
+        </p:spPr>
+        <p:txBody>
+          <a:bodyPr wrap="square" anchor="t">
+            <a:spAutoFit/>
+          </a:bodyPr>
+          <a:lstStyle/>
+          <a:p>
+            <a:pPr algn="l">
+              <a:lnSpc>
+                <a:spcPct val="105000"/>
+              </a:lnSpc>
+              <a:spcAft>
+                <a:spcPts val="400"/>
+              </a:spcAft>
+            </a:pPr>
+            <a:r>
+              <a:rPr sz="1000" b="0" i="0">
+                <a:solidFill>
+                  <a:srgbClr val="555F6E"/>
+                </a:solidFill>
+                <a:latin typeface="Georgia"/>
+              </a:rPr>
+              <a:t>Concentrated separation/sale theses (our SOTP archetype), constructive-first, run by Elliott / JANA / Engine No. 1 alumni — the talent pool this team draws on.</a:t>
+            </a:r>
+          </a:p>
+        </p:txBody>
+      </p:sp>
+      <p:sp>
+        <p:nvSpPr>
+          <p:cNvPr id="19" name="TextBox 18"/>
+          <p:cNvSpPr txBox="1"/>
+          <p:nvPr/>
+        </p:nvSpPr>
+        <p:spPr>
+          <a:xfrm>
+            <a:off x="6263640" y="1965960"/>
+            <a:ext cx="5486400" cy="274320"/>
+          </a:xfrm>
+          <a:prstGeom prst="rect">
+            <a:avLst/>
+          </a:prstGeom>
+          <a:noFill/>
+        </p:spPr>
+        <p:txBody>
+          <a:bodyPr wrap="square" anchor="t">
+            <a:spAutoFit/>
+          </a:bodyPr>
+          <a:lstStyle/>
+          <a:p>
+            <a:pPr algn="l">
+              <a:lnSpc>
+                <a:spcPct val="100000"/>
+              </a:lnSpc>
+              <a:spcAft>
+                <a:spcPts val="400"/>
+              </a:spcAft>
+            </a:pPr>
+            <a:r>
+              <a:rPr sz="1050" b="1" i="0">
+                <a:solidFill>
+                  <a:srgbClr val="C49A3B"/>
+                </a:solidFill>
+                <a:latin typeface="Georgia"/>
+              </a:rPr>
+              <a:t>Irenic Capital (est. 2021, Adam Katz ex-Elliott) — ~$335m → ~$2.5bn AUM; +14/19/17% '23–'25</a:t>
+            </a:r>
+          </a:p>
+        </p:txBody>
+      </p:sp>
+      <p:graphicFrame>
+        <p:nvGraphicFramePr>
+          <p:cNvPr id="20" name="Table 19"/>
+          <p:cNvGraphicFramePr>
+            <a:graphicFrameLocks noGrp="1"/>
+          </p:cNvGraphicFramePr>
+          <p:nvPr/>
+        </p:nvGraphicFramePr>
+        <p:xfrm>
+          <a:off x="6263640" y="2286000"/>
+          <a:ext cx="5486400" cy="1975104"/>
+        </p:xfrm>
+        <a:graphic>
+          <a:graphicData uri="http://schemas.openxmlformats.org/drawingml/2006/table">
+            <a:tbl>
+              <a:tblPr firstRow="1" bandRow="1">
+                <a:tableStyleId>{5C22544A-7EE6-4342-B048-85BDC9FD1C3A}</a:tableStyleId>
+              </a:tblPr>
+              <a:tblGrid>
+                <a:gridCol w="1463040"/>
+                <a:gridCol w="2286000"/>
+                <a:gridCol w="1737360"/>
+              </a:tblGrid>
+              <a:tr h="329184">
+                <a:tc>
+                  <a:txBody>
+                    <a:bodyPr/>
+                    <a:lstStyle/>
+                    <a:p>
+                      <a:r>
+                        <a:rPr sz="850" b="1">
+                          <a:solidFill>
+                            <a:srgbClr val="FFFFFF"/>
+                          </a:solidFill>
+                          <a:latin typeface="Georgia"/>
+                        </a:rPr>
+                        <a:t>Target</a:t>
+                      </a:r>
+                    </a:p>
+                  </a:txBody>
+                  <a:tcPr>
+                    <a:solidFill>
+                      <a:srgbClr val="0B2545"/>
+                    </a:solidFill>
+                  </a:tcPr>
+                </a:tc>
+                <a:tc>
+                  <a:txBody>
+                    <a:bodyPr/>
+                    <a:lstStyle/>
+                    <a:p>
+                      <a:r>
+                        <a:rPr sz="850" b="1">
+                          <a:solidFill>
+                            <a:srgbClr val="FFFFFF"/>
+                          </a:solidFill>
+                          <a:latin typeface="Georgia"/>
+                        </a:rPr>
+                        <a:t>Thesis</a:t>
+                      </a:r>
+                    </a:p>
+                  </a:txBody>
+                  <a:tcPr>
+                    <a:solidFill>
+                      <a:srgbClr val="0B2545"/>
+                    </a:solidFill>
+                  </a:tcPr>
+                </a:tc>
+                <a:tc>
+                  <a:txBody>
+                    <a:bodyPr/>
+                    <a:lstStyle/>
+                    <a:p>
+                      <a:r>
+                        <a:rPr sz="850" b="1">
+                          <a:solidFill>
+                            <a:srgbClr val="FFFFFF"/>
+                          </a:solidFill>
+                          <a:latin typeface="Georgia"/>
+                        </a:rPr>
+                        <a:t>Outcome</a:t>
+                      </a:r>
+                    </a:p>
+                  </a:txBody>
+                  <a:tcPr>
+                    <a:solidFill>
+                      <a:srgbClr val="0B2545"/>
+                    </a:solidFill>
+                  </a:tcPr>
+                </a:tc>
+              </a:tr>
+              <a:tr h="329184">
+                <a:tc>
+                  <a:txBody>
+                    <a:bodyPr/>
+                    <a:lstStyle/>
+                    <a:p>
+                      <a:r>
+                        <a:rPr sz="800">
+                          <a:solidFill>
+                            <a:srgbClr val="2B3340"/>
+                          </a:solidFill>
+                          <a:latin typeface="Georgia"/>
+                        </a:rPr>
+                        <a:t>Barnes Group</a:t>
+                      </a:r>
+                    </a:p>
+                  </a:txBody>
+                  <a:tcPr>
+                    <a:solidFill>
+                      <a:srgbClr val="FFFFFF"/>
+                    </a:solidFill>
+                  </a:tcPr>
+                </a:tc>
+                <a:tc>
+                  <a:txBody>
+                    <a:bodyPr/>
+                    <a:lstStyle/>
+                    <a:p>
+                      <a:r>
+                        <a:rPr sz="800">
+                          <a:solidFill>
+                            <a:srgbClr val="2B3340"/>
+                          </a:solidFill>
+                          <a:latin typeface="Georgia"/>
+                        </a:rPr>
+                        <a:t>Aerospace SOTP → sale</a:t>
+                      </a:r>
+                    </a:p>
+                  </a:txBody>
+                  <a:tcPr>
+                    <a:solidFill>
+                      <a:srgbClr val="FFFFFF"/>
+                    </a:solidFill>
+                  </a:tcPr>
+                </a:tc>
+                <a:tc>
+                  <a:txBody>
+                    <a:bodyPr/>
+                    <a:lstStyle/>
+                    <a:p>
+                      <a:r>
+                        <a:rPr sz="800">
+                          <a:solidFill>
+                            <a:srgbClr val="2B3340"/>
+                          </a:solidFill>
+                          <a:latin typeface="Georgia"/>
+                        </a:rPr>
+                        <a:t>Board seats; sold to Apollo</a:t>
+                      </a:r>
+                    </a:p>
+                  </a:txBody>
+                  <a:tcPr>
+                    <a:solidFill>
+                      <a:srgbClr val="FFFFFF"/>
+                    </a:solidFill>
+                  </a:tcPr>
+                </a:tc>
+              </a:tr>
+              <a:tr h="329184">
+                <a:tc>
+                  <a:txBody>
+                    <a:bodyPr/>
+                    <a:lstStyle/>
+                    <a:p>
+                      <a:r>
+                        <a:rPr sz="800">
+                          <a:solidFill>
+                            <a:srgbClr val="2B3340"/>
+                          </a:solidFill>
+                          <a:latin typeface="Georgia"/>
+                        </a:rPr>
+                        <a:t>News Corp</a:t>
+                      </a:r>
+                    </a:p>
+                  </a:txBody>
+                  <a:tcPr>
+                    <a:solidFill>
+                      <a:srgbClr val="F2F4F8"/>
+                    </a:solidFill>
+                  </a:tcPr>
+                </a:tc>
+                <a:tc>
+                  <a:txBody>
+                    <a:bodyPr/>
+                    <a:lstStyle/>
+                    <a:p>
+                      <a:r>
+                        <a:rPr sz="800">
+                          <a:solidFill>
+                            <a:srgbClr val="2B3340"/>
+                          </a:solidFill>
+                          <a:latin typeface="Georgia"/>
+                        </a:rPr>
+                        <a:t>Split real estate from media</a:t>
+                      </a:r>
+                    </a:p>
+                  </a:txBody>
+                  <a:tcPr>
+                    <a:solidFill>
+                      <a:srgbClr val="F2F4F8"/>
+                    </a:solidFill>
+                  </a:tcPr>
+                </a:tc>
+                <a:tc>
+                  <a:txBody>
+                    <a:bodyPr/>
+                    <a:lstStyle/>
+                    <a:p>
+                      <a:r>
+                        <a:rPr sz="800">
+                          <a:solidFill>
+                            <a:srgbClr val="2B3340"/>
+                          </a:solidFill>
+                          <a:latin typeface="Georgia"/>
+                        </a:rPr>
+                        <a:t>Special-committee review</a:t>
+                      </a:r>
+                    </a:p>
+                  </a:txBody>
+                  <a:tcPr>
+                    <a:solidFill>
+                      <a:srgbClr val="F2F4F8"/>
+                    </a:solidFill>
+                  </a:tcPr>
+                </a:tc>
+              </a:tr>
+              <a:tr h="329184">
+                <a:tc>
+                  <a:txBody>
+                    <a:bodyPr/>
+                    <a:lstStyle/>
+                    <a:p>
+                      <a:r>
+                        <a:rPr sz="800">
+                          <a:solidFill>
+                            <a:srgbClr val="2B3340"/>
+                          </a:solidFill>
+                          <a:latin typeface="Georgia"/>
+                        </a:rPr>
+                        <a:t>Integer Holdings</a:t>
+                      </a:r>
+                    </a:p>
+                  </a:txBody>
+                  <a:tcPr>
+                    <a:solidFill>
+                      <a:srgbClr val="FFFFFF"/>
+                    </a:solidFill>
+                  </a:tcPr>
+                </a:tc>
+                <a:tc>
+                  <a:txBody>
+                    <a:bodyPr/>
+                    <a:lstStyle/>
+                    <a:p>
+                      <a:r>
+                        <a:rPr sz="800">
+                          <a:solidFill>
+                            <a:srgbClr val="2B3340"/>
+                          </a:solidFill>
+                          <a:latin typeface="Georgia"/>
+                        </a:rPr>
+                        <a:t>Board refresh + sale</a:t>
+                      </a:r>
+                    </a:p>
+                  </a:txBody>
+                  <a:tcPr>
+                    <a:solidFill>
+                      <a:srgbClr val="FFFFFF"/>
+                    </a:solidFill>
+                  </a:tcPr>
+                </a:tc>
+                <a:tc>
+                  <a:txBody>
+                    <a:bodyPr/>
+                    <a:lstStyle/>
+                    <a:p>
+                      <a:r>
+                        <a:rPr sz="800">
+                          <a:solidFill>
+                            <a:srgbClr val="2B3340"/>
+                          </a:solidFill>
+                          <a:latin typeface="Georgia"/>
+                        </a:rPr>
+                        <a:t>2 seats; strategic review '26</a:t>
+                      </a:r>
+                    </a:p>
+                  </a:txBody>
+                  <a:tcPr>
+                    <a:solidFill>
+                      <a:srgbClr val="FFFFFF"/>
+                    </a:solidFill>
+                  </a:tcPr>
+                </a:tc>
+              </a:tr>
+              <a:tr h="329184">
+                <a:tc>
+                  <a:txBody>
+                    <a:bodyPr/>
+                    <a:lstStyle/>
+                    <a:p>
+                      <a:r>
+                        <a:rPr sz="800">
+                          <a:solidFill>
+                            <a:srgbClr val="2B3340"/>
+                          </a:solidFill>
+                          <a:latin typeface="Georgia"/>
+                        </a:rPr>
+                        <a:t>Atkore / Workiva</a:t>
+                      </a:r>
+                    </a:p>
+                  </a:txBody>
+                  <a:tcPr>
+                    <a:solidFill>
+                      <a:srgbClr val="F2F4F8"/>
+                    </a:solidFill>
+                  </a:tcPr>
+                </a:tc>
+                <a:tc>
+                  <a:txBody>
+                    <a:bodyPr/>
+                    <a:lstStyle/>
+                    <a:p>
+                      <a:r>
+                        <a:rPr sz="800">
+                          <a:solidFill>
+                            <a:srgbClr val="2B3340"/>
+                          </a:solidFill>
+                          <a:latin typeface="Georgia"/>
+                        </a:rPr>
+                        <a:t>Sale / ops + 2 seats</a:t>
+                      </a:r>
+                    </a:p>
+                  </a:txBody>
+                  <a:tcPr>
+                    <a:solidFill>
+                      <a:srgbClr val="F2F4F8"/>
+                    </a:solidFill>
+                  </a:tcPr>
+                </a:tc>
+                <a:tc>
+                  <a:txBody>
+                    <a:bodyPr/>
+                    <a:lstStyle/>
+                    <a:p>
+                      <a:r>
+                        <a:rPr sz="800">
+                          <a:solidFill>
+                            <a:srgbClr val="2B3340"/>
+                          </a:solidFill>
+                          <a:latin typeface="Georgia"/>
+                        </a:rPr>
+                        <a:t>Ongoing</a:t>
+                      </a:r>
+                    </a:p>
+                  </a:txBody>
+                  <a:tcPr>
+                    <a:solidFill>
+                      <a:srgbClr val="F2F4F8"/>
+                    </a:solidFill>
+                  </a:tcPr>
+                </a:tc>
+              </a:tr>
+              <a:tr h="329184">
+                <a:tc>
+                  <a:txBody>
+                    <a:bodyPr/>
+                    <a:lstStyle/>
+                    <a:p>
+                      <a:r>
+                        <a:rPr sz="800">
+                          <a:solidFill>
+                            <a:srgbClr val="2B3340"/>
+                          </a:solidFill>
+                          <a:latin typeface="Georgia"/>
+                        </a:rPr>
+                        <a:t>Reservoir, Snap, HPE</a:t>
+                      </a:r>
+                    </a:p>
+                  </a:txBody>
+                  <a:tcPr>
+                    <a:solidFill>
+                      <a:srgbClr val="FFFFFF"/>
+                    </a:solidFill>
+                  </a:tcPr>
+                </a:tc>
+                <a:tc>
+                  <a:txBody>
+                    <a:bodyPr/>
+                    <a:lstStyle/>
+                    <a:p>
+                      <a:r>
+                        <a:rPr sz="800">
+                          <a:solidFill>
+                            <a:srgbClr val="2B3340"/>
+                          </a:solidFill>
+                          <a:latin typeface="Georgia"/>
+                        </a:rPr>
+                        <a:t>Strategic review / costs</a:t>
+                      </a:r>
+                    </a:p>
+                  </a:txBody>
+                  <a:tcPr>
+                    <a:solidFill>
+                      <a:srgbClr val="FFFFFF"/>
+                    </a:solidFill>
+                  </a:tcPr>
+                </a:tc>
+                <a:tc>
+                  <a:txBody>
+                    <a:bodyPr/>
+                    <a:lstStyle/>
+                    <a:p>
+                      <a:r>
+                        <a:rPr sz="800">
+                          <a:solidFill>
+                            <a:srgbClr val="2B3340"/>
+                          </a:solidFill>
+                          <a:latin typeface="Georgia"/>
+                        </a:rPr>
+                        <a:t>Ongoing</a:t>
+                      </a:r>
+                    </a:p>
+                  </a:txBody>
+                  <a:tcPr>
+                    <a:solidFill>
+                      <a:srgbClr val="FFFFFF"/>
+                    </a:solidFill>
+                  </a:tcPr>
+                </a:tc>
+              </a:tr>
+            </a:tbl>
+          </a:graphicData>
+        </a:graphic>
+      </p:graphicFrame>
+      <p:sp>
+        <p:nvSpPr>
+          <p:cNvPr id="21" name="TextBox 20"/>
+          <p:cNvSpPr txBox="1"/>
+          <p:nvPr/>
+        </p:nvSpPr>
+        <p:spPr>
+          <a:xfrm>
+            <a:off x="6263640" y="4343400"/>
+            <a:ext cx="5486400" cy="274320"/>
+          </a:xfrm>
+          <a:prstGeom prst="rect">
+            <a:avLst/>
+          </a:prstGeom>
+          <a:noFill/>
+        </p:spPr>
+        <p:txBody>
+          <a:bodyPr wrap="square" anchor="t">
+            <a:spAutoFit/>
+          </a:bodyPr>
+          <a:lstStyle/>
+          <a:p>
+            <a:pPr algn="l">
+              <a:lnSpc>
+                <a:spcPct val="100000"/>
+              </a:lnSpc>
+              <a:spcAft>
+                <a:spcPts val="400"/>
+              </a:spcAft>
+            </a:pPr>
+            <a:r>
+              <a:rPr sz="1050" b="1" i="0">
+                <a:solidFill>
+                  <a:srgbClr val="C49A3B"/>
+                </a:solidFill>
+                <a:latin typeface="Georgia"/>
+              </a:rPr>
+              <a:t>Ananym Capital (est. 2024, Penner ex-Engine No. 1/Exxon + Silver) — ~$260m, ~10 names</a:t>
+            </a:r>
+          </a:p>
+        </p:txBody>
+      </p:sp>
+      <p:graphicFrame>
+        <p:nvGraphicFramePr>
+          <p:cNvPr id="22" name="Table 21"/>
+          <p:cNvGraphicFramePr>
+            <a:graphicFrameLocks noGrp="1"/>
+          </p:cNvGraphicFramePr>
+          <p:nvPr/>
+        </p:nvGraphicFramePr>
+        <p:xfrm>
+          <a:off x="6263640" y="4663440"/>
+          <a:ext cx="5486400" cy="1645919"/>
+        </p:xfrm>
+        <a:graphic>
+          <a:graphicData uri="http://schemas.openxmlformats.org/drawingml/2006/table">
+            <a:tbl>
+              <a:tblPr firstRow="1" bandRow="1">
+                <a:tableStyleId>{5C22544A-7EE6-4342-B048-85BDC9FD1C3A}</a:tableStyleId>
+              </a:tblPr>
+              <a:tblGrid>
+                <a:gridCol w="1463040"/>
+                <a:gridCol w="2286000"/>
+                <a:gridCol w="1737360"/>
+              </a:tblGrid>
+              <a:tr h="329183">
+                <a:tc>
+                  <a:txBody>
+                    <a:bodyPr/>
+                    <a:lstStyle/>
+                    <a:p>
+                      <a:r>
+                        <a:rPr sz="850" b="1">
+                          <a:solidFill>
+                            <a:srgbClr val="FFFFFF"/>
+                          </a:solidFill>
+                          <a:latin typeface="Georgia"/>
+                        </a:rPr>
+                        <a:t>Target</a:t>
+                      </a:r>
+                    </a:p>
+                  </a:txBody>
+                  <a:tcPr>
+                    <a:solidFill>
+                      <a:srgbClr val="0B2545"/>
+                    </a:solidFill>
+                  </a:tcPr>
+                </a:tc>
+                <a:tc>
+                  <a:txBody>
+                    <a:bodyPr/>
+                    <a:lstStyle/>
+                    <a:p>
+                      <a:r>
+                        <a:rPr sz="850" b="1">
+                          <a:solidFill>
+                            <a:srgbClr val="FFFFFF"/>
+                          </a:solidFill>
+                          <a:latin typeface="Georgia"/>
+                        </a:rPr>
+                        <a:t>Thesis</a:t>
+                      </a:r>
+                    </a:p>
+                  </a:txBody>
+                  <a:tcPr>
+                    <a:solidFill>
+                      <a:srgbClr val="0B2545"/>
+                    </a:solidFill>
+                  </a:tcPr>
+                </a:tc>
+                <a:tc>
+                  <a:txBody>
+                    <a:bodyPr/>
+                    <a:lstStyle/>
+                    <a:p>
+                      <a:r>
+                        <a:rPr sz="850" b="1">
+                          <a:solidFill>
+                            <a:srgbClr val="FFFFFF"/>
+                          </a:solidFill>
+                          <a:latin typeface="Georgia"/>
+                        </a:rPr>
+                        <a:t>Outcome</a:t>
+                      </a:r>
+                    </a:p>
+                  </a:txBody>
+                  <a:tcPr>
+                    <a:solidFill>
+                      <a:srgbClr val="0B2545"/>
+                    </a:solidFill>
+                  </a:tcPr>
+                </a:tc>
+              </a:tr>
+              <a:tr h="329183">
+                <a:tc>
+                  <a:txBody>
+                    <a:bodyPr/>
+                    <a:lstStyle/>
+                    <a:p>
+                      <a:r>
+                        <a:rPr sz="800">
+                          <a:solidFill>
+                            <a:srgbClr val="2B3340"/>
+                          </a:solidFill>
+                          <a:latin typeface="Georgia"/>
+                        </a:rPr>
+                        <a:t>Henry Schein</a:t>
+                      </a:r>
+                    </a:p>
+                  </a:txBody>
+                  <a:tcPr>
+                    <a:solidFill>
+                      <a:srgbClr val="FFFFFF"/>
+                    </a:solidFill>
+                  </a:tcPr>
+                </a:tc>
+                <a:tc>
+                  <a:txBody>
+                    <a:bodyPr/>
+                    <a:lstStyle/>
+                    <a:p>
+                      <a:r>
+                        <a:rPr sz="800">
+                          <a:solidFill>
+                            <a:srgbClr val="2B3340"/>
+                          </a:solidFill>
+                          <a:latin typeface="Georgia"/>
+                        </a:rPr>
+                        <a:t>Costs, CEO, board (≤6 seats)</a:t>
+                      </a:r>
+                    </a:p>
+                  </a:txBody>
+                  <a:tcPr>
+                    <a:solidFill>
+                      <a:srgbClr val="FFFFFF"/>
+                    </a:solidFill>
+                  </a:tcPr>
+                </a:tc>
+                <a:tc>
+                  <a:txBody>
+                    <a:bodyPr/>
+                    <a:lstStyle/>
+                    <a:p>
+                      <a:r>
+                        <a:rPr sz="800">
+                          <a:solidFill>
+                            <a:srgbClr val="2B3340"/>
+                          </a:solidFill>
+                          <a:latin typeface="Georgia"/>
+                        </a:rPr>
+                        <a:t>Catalysed KKR deal</a:t>
+                      </a:r>
+                    </a:p>
+                  </a:txBody>
+                  <a:tcPr>
+                    <a:solidFill>
+                      <a:srgbClr val="FFFFFF"/>
+                    </a:solidFill>
+                  </a:tcPr>
+                </a:tc>
+              </a:tr>
+              <a:tr h="329183">
+                <a:tc>
+                  <a:txBody>
+                    <a:bodyPr/>
+                    <a:lstStyle/>
+                    <a:p>
+                      <a:r>
+                        <a:rPr sz="800">
+                          <a:solidFill>
+                            <a:srgbClr val="2B3340"/>
+                          </a:solidFill>
+                          <a:latin typeface="Georgia"/>
+                        </a:rPr>
+                        <a:t>Baker Hughes</a:t>
+                      </a:r>
+                    </a:p>
+                  </a:txBody>
+                  <a:tcPr>
+                    <a:solidFill>
+                      <a:srgbClr val="F2F4F8"/>
+                    </a:solidFill>
+                  </a:tcPr>
+                </a:tc>
+                <a:tc>
+                  <a:txBody>
+                    <a:bodyPr/>
+                    <a:lstStyle/>
+                    <a:p>
+                      <a:r>
+                        <a:rPr sz="800">
+                          <a:solidFill>
+                            <a:srgbClr val="2B3340"/>
+                          </a:solidFill>
+                          <a:latin typeface="Georgia"/>
+                        </a:rPr>
+                        <a:t>Spin off oilfield services</a:t>
+                      </a:r>
+                    </a:p>
+                  </a:txBody>
+                  <a:tcPr>
+                    <a:solidFill>
+                      <a:srgbClr val="F2F4F8"/>
+                    </a:solidFill>
+                  </a:tcPr>
+                </a:tc>
+                <a:tc>
+                  <a:txBody>
+                    <a:bodyPr/>
+                    <a:lstStyle/>
+                    <a:p>
+                      <a:r>
+                        <a:rPr sz="800">
+                          <a:solidFill>
+                            <a:srgbClr val="2B3340"/>
+                          </a:solidFill>
+                          <a:latin typeface="Georgia"/>
+                        </a:rPr>
+                        <a:t>Ongoing (≥60% upside)</a:t>
+                      </a:r>
+                    </a:p>
+                  </a:txBody>
+                  <a:tcPr>
+                    <a:solidFill>
+                      <a:srgbClr val="F2F4F8"/>
+                    </a:solidFill>
+                  </a:tcPr>
+                </a:tc>
+              </a:tr>
+              <a:tr h="329183">
+                <a:tc>
+                  <a:txBody>
+                    <a:bodyPr/>
+                    <a:lstStyle/>
+                    <a:p>
+                      <a:r>
+                        <a:rPr sz="800">
+                          <a:solidFill>
+                            <a:srgbClr val="2B3340"/>
+                          </a:solidFill>
+                          <a:latin typeface="Georgia"/>
+                        </a:rPr>
+                        <a:t>Siemens Energy</a:t>
+                      </a:r>
+                    </a:p>
+                  </a:txBody>
+                  <a:tcPr>
+                    <a:solidFill>
+                      <a:srgbClr val="FFFFFF"/>
+                    </a:solidFill>
+                  </a:tcPr>
+                </a:tc>
+                <a:tc>
+                  <a:txBody>
+                    <a:bodyPr/>
+                    <a:lstStyle/>
+                    <a:p>
+                      <a:r>
+                        <a:rPr sz="800">
+                          <a:solidFill>
+                            <a:srgbClr val="2B3340"/>
+                          </a:solidFill>
+                          <a:latin typeface="Georgia"/>
+                        </a:rPr>
+                        <a:t>Separate wind (Gamesa)</a:t>
+                      </a:r>
+                    </a:p>
+                  </a:txBody>
+                  <a:tcPr>
+                    <a:solidFill>
+                      <a:srgbClr val="FFFFFF"/>
+                    </a:solidFill>
+                  </a:tcPr>
+                </a:tc>
+                <a:tc>
+                  <a:txBody>
+                    <a:bodyPr/>
+                    <a:lstStyle/>
+                    <a:p>
+                      <a:r>
+                        <a:rPr sz="800">
+                          <a:solidFill>
+                            <a:srgbClr val="2B3340"/>
+                          </a:solidFill>
+                          <a:latin typeface="Georgia"/>
+                        </a:rPr>
+                        <a:t>Ongoing</a:t>
+                      </a:r>
+                    </a:p>
+                  </a:txBody>
+                  <a:tcPr>
+                    <a:solidFill>
+                      <a:srgbClr val="FFFFFF"/>
+                    </a:solidFill>
+                  </a:tcPr>
+                </a:tc>
+              </a:tr>
+              <a:tr h="329187">
+                <a:tc>
+                  <a:txBody>
+                    <a:bodyPr/>
+                    <a:lstStyle/>
+                    <a:p>
+                      <a:r>
+                        <a:rPr sz="800">
+                          <a:solidFill>
+                            <a:srgbClr val="2B3340"/>
+                          </a:solidFill>
+                          <a:latin typeface="Georgia"/>
+                        </a:rPr>
+                        <a:t>LKQ</a:t>
+                      </a:r>
+                    </a:p>
+                  </a:txBody>
+                  <a:tcPr>
+                    <a:solidFill>
+                      <a:srgbClr val="F2F4F8"/>
+                    </a:solidFill>
+                  </a:tcPr>
+                </a:tc>
+                <a:tc>
+                  <a:txBody>
+                    <a:bodyPr/>
+                    <a:lstStyle/>
+                    <a:p>
+                      <a:r>
+                        <a:rPr sz="800">
+                          <a:solidFill>
+                            <a:srgbClr val="2B3340"/>
+                          </a:solidFill>
+                          <a:latin typeface="Georgia"/>
+                        </a:rPr>
+                        <a:t>Divest Europe</a:t>
+                      </a:r>
+                    </a:p>
+                  </a:txBody>
+                  <a:tcPr>
+                    <a:solidFill>
+                      <a:srgbClr val="F2F4F8"/>
+                    </a:solidFill>
+                  </a:tcPr>
+                </a:tc>
+                <a:tc>
+                  <a:txBody>
+                    <a:bodyPr/>
+                    <a:lstStyle/>
+                    <a:p>
+                      <a:r>
+                        <a:rPr sz="800">
+                          <a:solidFill>
+                            <a:srgbClr val="2B3340"/>
+                          </a:solidFill>
+                          <a:latin typeface="Georgia"/>
+                        </a:rPr>
+                        <a:t>Ongoing</a:t>
+                      </a:r>
+                    </a:p>
+                  </a:txBody>
+                  <a:tcPr>
+                    <a:solidFill>
+                      <a:srgbClr val="F2F4F8"/>
+                    </a:solidFill>
+                  </a:tcPr>
+                </a:tc>
+              </a:tr>
+            </a:tbl>
+          </a:graphicData>
+        </a:graphic>
+      </p:graphicFrame>
+      <p:sp>
+        <p:nvSpPr>
+          <p:cNvPr id="23" name="TextBox 22"/>
+          <p:cNvSpPr txBox="1"/>
+          <p:nvPr/>
+        </p:nvSpPr>
+        <p:spPr>
+          <a:xfrm>
+            <a:off x="6263640" y="6355080"/>
+            <a:ext cx="5486400" cy="274320"/>
+          </a:xfrm>
+          <a:prstGeom prst="rect">
+            <a:avLst/>
+          </a:prstGeom>
+          <a:noFill/>
+        </p:spPr>
+        <p:txBody>
+          <a:bodyPr wrap="square" anchor="t">
+            <a:spAutoFit/>
+          </a:bodyPr>
+          <a:lstStyle/>
+          <a:p>
+            <a:pPr algn="l">
+              <a:lnSpc>
+                <a:spcPct val="100000"/>
+              </a:lnSpc>
+              <a:spcAft>
+                <a:spcPts val="400"/>
+              </a:spcAft>
+            </a:pPr>
+            <a:r>
+              <a:rPr sz="900" b="0" i="1">
+                <a:solidFill>
+                  <a:srgbClr val="0B2545"/>
+                </a:solidFill>
+                <a:latin typeface="Georgia"/>
+              </a:rPr>
+              <a:t>Edge vs them: they have the craft but no operating platform, no EU nomination-committee home field, no buyout balance sheet for take-privates.</a:t>
             </a:r>
           </a:p>
         </p:txBody>

</xml_diff>